<commit_message>
Correct revised deadline and team-confirmed delivery status
</commit_message>
<xml_diff>
--- a/submission/Project1_Presentation.pptx
+++ b/submission/Project1_Presentation.pptx
@@ -2,40 +2,40 @@
 <file path=ppt/presentation.xml><?xml version="1.0" encoding="utf-8"?>
 <p:presentation xmlns:p="http://schemas.openxmlformats.org/presentationml/2006/main">
   <p:sldMasterIdLst>
-    <p:sldMasterId xmlns:r="http://schemas.openxmlformats.org/officeDocument/2006/relationships" id="2147483648" r:id="Rf75756551dd6454c"/>
+    <p:sldMasterId xmlns:r="http://schemas.openxmlformats.org/officeDocument/2006/relationships" id="2147483648" r:id="R27b1f9f77d3640a8"/>
   </p:sldMasterIdLst>
   <p:notesMasterIdLst>
-    <p:notesMasterId xmlns:r="http://schemas.openxmlformats.org/officeDocument/2006/relationships" r:id="R2fc585b03dc7420f"/>
+    <p:notesMasterId xmlns:r="http://schemas.openxmlformats.org/officeDocument/2006/relationships" r:id="Re970bcdf63ed4927"/>
   </p:notesMasterIdLst>
   <p:sldIdLst>
-    <p:sldId xmlns:r="http://schemas.openxmlformats.org/officeDocument/2006/relationships" id="256" r:id="R189f9040a6814d73"/>
-    <p:sldId xmlns:r="http://schemas.openxmlformats.org/officeDocument/2006/relationships" id="257" r:id="R0bb3f5dd15264e35"/>
-    <p:sldId xmlns:r="http://schemas.openxmlformats.org/officeDocument/2006/relationships" id="258" r:id="R6bba49bfc98f442e"/>
-    <p:sldId xmlns:r="http://schemas.openxmlformats.org/officeDocument/2006/relationships" id="259" r:id="Rfdab70f226da4623"/>
-    <p:sldId xmlns:r="http://schemas.openxmlformats.org/officeDocument/2006/relationships" id="260" r:id="R3f8a2df196bf4e3b"/>
-    <p:sldId xmlns:r="http://schemas.openxmlformats.org/officeDocument/2006/relationships" id="261" r:id="Rf72df13ed5f94059"/>
-    <p:sldId xmlns:r="http://schemas.openxmlformats.org/officeDocument/2006/relationships" id="262" r:id="Rf0aa565752b94d51"/>
-    <p:sldId xmlns:r="http://schemas.openxmlformats.org/officeDocument/2006/relationships" id="263" r:id="R65bbeb14e52f4f59"/>
-    <p:sldId xmlns:r="http://schemas.openxmlformats.org/officeDocument/2006/relationships" id="264" r:id="R14a809bc6c8643b3"/>
-    <p:sldId xmlns:r="http://schemas.openxmlformats.org/officeDocument/2006/relationships" id="265" r:id="Re270ae051b574e4a"/>
-    <p:sldId xmlns:r="http://schemas.openxmlformats.org/officeDocument/2006/relationships" id="266" r:id="Rf16a6f79ec9f4729"/>
-    <p:sldId xmlns:r="http://schemas.openxmlformats.org/officeDocument/2006/relationships" id="267" r:id="R8d73df96a57c401b"/>
-    <p:sldId xmlns:r="http://schemas.openxmlformats.org/officeDocument/2006/relationships" id="268" r:id="R412b9339e452470e"/>
-    <p:sldId xmlns:r="http://schemas.openxmlformats.org/officeDocument/2006/relationships" id="269" r:id="R0d09abc8eb5940c5"/>
-    <p:sldId xmlns:r="http://schemas.openxmlformats.org/officeDocument/2006/relationships" id="270" r:id="R989396bca2ff4e85"/>
-    <p:sldId xmlns:r="http://schemas.openxmlformats.org/officeDocument/2006/relationships" id="271" r:id="Re1fd1aec461c425d"/>
-    <p:sldId xmlns:r="http://schemas.openxmlformats.org/officeDocument/2006/relationships" id="272" r:id="Re978df4ba2964744"/>
-    <p:sldId xmlns:r="http://schemas.openxmlformats.org/officeDocument/2006/relationships" id="273" r:id="R9fcdc683fbcb43a3"/>
-    <p:sldId xmlns:r="http://schemas.openxmlformats.org/officeDocument/2006/relationships" id="274" r:id="R1769d340c7ff4a2a"/>
-    <p:sldId xmlns:r="http://schemas.openxmlformats.org/officeDocument/2006/relationships" id="275" r:id="R1a568d1c504c423e"/>
-    <p:sldId xmlns:r="http://schemas.openxmlformats.org/officeDocument/2006/relationships" id="276" r:id="R0d49221fe5124d78"/>
-    <p:sldId xmlns:r="http://schemas.openxmlformats.org/officeDocument/2006/relationships" id="277" r:id="Radd049d944ed4ac0"/>
-    <p:sldId xmlns:r="http://schemas.openxmlformats.org/officeDocument/2006/relationships" id="278" r:id="R2a183b09ede14328"/>
-    <p:sldId xmlns:r="http://schemas.openxmlformats.org/officeDocument/2006/relationships" id="279" r:id="Re2d1370a151c4f36"/>
-    <p:sldId xmlns:r="http://schemas.openxmlformats.org/officeDocument/2006/relationships" id="280" r:id="R0d1e0747a6ba4a19"/>
-    <p:sldId xmlns:r="http://schemas.openxmlformats.org/officeDocument/2006/relationships" id="281" r:id="Rb4387421a58443b9"/>
-    <p:sldId xmlns:r="http://schemas.openxmlformats.org/officeDocument/2006/relationships" id="282" r:id="Rf8bdafbe9c0145f4"/>
-    <p:sldId xmlns:r="http://schemas.openxmlformats.org/officeDocument/2006/relationships" id="283" r:id="R2a48abc84d3148ea"/>
+    <p:sldId xmlns:r="http://schemas.openxmlformats.org/officeDocument/2006/relationships" id="256" r:id="Reaf884436a00433e"/>
+    <p:sldId xmlns:r="http://schemas.openxmlformats.org/officeDocument/2006/relationships" id="257" r:id="Rbd1c03e1b3b942cc"/>
+    <p:sldId xmlns:r="http://schemas.openxmlformats.org/officeDocument/2006/relationships" id="258" r:id="R828f8209a82b4ede"/>
+    <p:sldId xmlns:r="http://schemas.openxmlformats.org/officeDocument/2006/relationships" id="259" r:id="Rf0c1a4c2539a4eed"/>
+    <p:sldId xmlns:r="http://schemas.openxmlformats.org/officeDocument/2006/relationships" id="260" r:id="Rf37cd7a1840d4453"/>
+    <p:sldId xmlns:r="http://schemas.openxmlformats.org/officeDocument/2006/relationships" id="261" r:id="R15d08fe5ab4b460c"/>
+    <p:sldId xmlns:r="http://schemas.openxmlformats.org/officeDocument/2006/relationships" id="262" r:id="R7e7f068e7ef54312"/>
+    <p:sldId xmlns:r="http://schemas.openxmlformats.org/officeDocument/2006/relationships" id="263" r:id="Rb95276fe7b7643d5"/>
+    <p:sldId xmlns:r="http://schemas.openxmlformats.org/officeDocument/2006/relationships" id="264" r:id="R0607750556694d1a"/>
+    <p:sldId xmlns:r="http://schemas.openxmlformats.org/officeDocument/2006/relationships" id="265" r:id="R8a34929163264985"/>
+    <p:sldId xmlns:r="http://schemas.openxmlformats.org/officeDocument/2006/relationships" id="266" r:id="R65a8052f569142b4"/>
+    <p:sldId xmlns:r="http://schemas.openxmlformats.org/officeDocument/2006/relationships" id="267" r:id="Rdac1ed9dc0484f30"/>
+    <p:sldId xmlns:r="http://schemas.openxmlformats.org/officeDocument/2006/relationships" id="268" r:id="R55b741328a334375"/>
+    <p:sldId xmlns:r="http://schemas.openxmlformats.org/officeDocument/2006/relationships" id="269" r:id="R0f70f4407506419b"/>
+    <p:sldId xmlns:r="http://schemas.openxmlformats.org/officeDocument/2006/relationships" id="270" r:id="R8b11e2c68e7d4129"/>
+    <p:sldId xmlns:r="http://schemas.openxmlformats.org/officeDocument/2006/relationships" id="271" r:id="R9ae2171adcf0459b"/>
+    <p:sldId xmlns:r="http://schemas.openxmlformats.org/officeDocument/2006/relationships" id="272" r:id="R11e38fb337f7443c"/>
+    <p:sldId xmlns:r="http://schemas.openxmlformats.org/officeDocument/2006/relationships" id="273" r:id="R28b60dd93ec44e5b"/>
+    <p:sldId xmlns:r="http://schemas.openxmlformats.org/officeDocument/2006/relationships" id="274" r:id="R03faaf529d48459d"/>
+    <p:sldId xmlns:r="http://schemas.openxmlformats.org/officeDocument/2006/relationships" id="275" r:id="R30577046b3bc4943"/>
+    <p:sldId xmlns:r="http://schemas.openxmlformats.org/officeDocument/2006/relationships" id="276" r:id="Rb913421084bf483d"/>
+    <p:sldId xmlns:r="http://schemas.openxmlformats.org/officeDocument/2006/relationships" id="277" r:id="R827655237f0b496e"/>
+    <p:sldId xmlns:r="http://schemas.openxmlformats.org/officeDocument/2006/relationships" id="278" r:id="R742d2be834fd4e16"/>
+    <p:sldId xmlns:r="http://schemas.openxmlformats.org/officeDocument/2006/relationships" id="279" r:id="R89920b5c30474951"/>
+    <p:sldId xmlns:r="http://schemas.openxmlformats.org/officeDocument/2006/relationships" id="280" r:id="R9276ee5eb0a84667"/>
+    <p:sldId xmlns:r="http://schemas.openxmlformats.org/officeDocument/2006/relationships" id="281" r:id="R98bb503bfbe442a3"/>
+    <p:sldId xmlns:r="http://schemas.openxmlformats.org/officeDocument/2006/relationships" id="282" r:id="Re2891fb0363b4442"/>
+    <p:sldId xmlns:r="http://schemas.openxmlformats.org/officeDocument/2006/relationships" id="283" r:id="R35afab8f5a1e4b03"/>
   </p:sldIdLst>
   <p:sldSz cx="12192000" cy="6858000"/>
   <p:notesSz cx="6858000" cy="9144000"/>
@@ -2899,7 +2899,7 @@
           </a:p>
           <a:p xmlns:a="http://schemas.openxmlformats.org/drawingml/2006/main">
             <a:r>
-              <a:t>The dated ClickUp snapshots and steady target of twenty meaningful commits per person remain gaps in our evidence. The preserved branch history, integration and actual test logs are available for review. In a future project, we would collect board evidence throughout development.</a:t>
+              <a:t>I hold our ClickUp evidence, and the instructor’s revised final deadline is October 31. Our team recording is complete. The preserved branch history, integration and actual test logs are available for review. In a future project, we would collect board evidence throughout development.</a:t>
             </a:r>
           </a:p>
           <a:p xmlns:a="http://schemas.openxmlformats.org/drawingml/2006/main">
@@ -7142,12 +7142,12 @@
   </p:cSld>
   <p:clrMap bg1="lt1" tx1="dk1" bg2="lt2" tx2="dk2" accent1="accent1" accent2="accent2" accent3="accent3" accent4="accent4" accent5="accent5" accent6="accent6" hlink="hlink" folHlink="folHlink"/>
   <p:sldLayoutIdLst>
-    <p:sldLayoutId xmlns:r="http://schemas.openxmlformats.org/officeDocument/2006/relationships" id="2147483649" r:id="R1ece97640304470a"/>
-    <p:sldLayoutId xmlns:r="http://schemas.openxmlformats.org/officeDocument/2006/relationships" id="2147483650" r:id="Rf51997b52dcd4680"/>
-    <p:sldLayoutId xmlns:r="http://schemas.openxmlformats.org/officeDocument/2006/relationships" id="2147483651" r:id="Reb80313eaec1440f"/>
-    <p:sldLayoutId xmlns:r="http://schemas.openxmlformats.org/officeDocument/2006/relationships" id="2147483652" r:id="R1de1182481e5445b"/>
-    <p:sldLayoutId xmlns:r="http://schemas.openxmlformats.org/officeDocument/2006/relationships" id="2147483653" r:id="R48f44055308341a7"/>
-    <p:sldLayoutId xmlns:r="http://schemas.openxmlformats.org/officeDocument/2006/relationships" id="2147483654" r:id="R7d0c3f09b4274736"/>
+    <p:sldLayoutId xmlns:r="http://schemas.openxmlformats.org/officeDocument/2006/relationships" id="2147483649" r:id="R5be862c5885c4b85"/>
+    <p:sldLayoutId xmlns:r="http://schemas.openxmlformats.org/officeDocument/2006/relationships" id="2147483650" r:id="R2386279bae074e4a"/>
+    <p:sldLayoutId xmlns:r="http://schemas.openxmlformats.org/officeDocument/2006/relationships" id="2147483651" r:id="R84853fd1534848f4"/>
+    <p:sldLayoutId xmlns:r="http://schemas.openxmlformats.org/officeDocument/2006/relationships" id="2147483652" r:id="R426f19b080cc44a8"/>
+    <p:sldLayoutId xmlns:r="http://schemas.openxmlformats.org/officeDocument/2006/relationships" id="2147483653" r:id="R0cf20d769f994d08"/>
+    <p:sldLayoutId xmlns:r="http://schemas.openxmlformats.org/officeDocument/2006/relationships" id="2147483654" r:id="Rbd4bb7881919483f"/>
   </p:sldLayoutIdLst>
   <p:txStyles>
     <p:titleStyle>
@@ -8827,7 +8827,7 @@
           <p:cNvPr id="6" name="">
             <a:extLst xmlns:a="http://schemas.openxmlformats.org/drawingml/2006/main">
               <a:ext uri="{FF2B5EF4-FFF2-40B4-BE49-F238E27FC236}">
-                <a16:creationId xmlns:a16="http://schemas.microsoft.com/office/drawing/2014/main" id="{6CB0D06F-739A-460E-BF09-FCBB38E9199E}"/>
+                <a16:creationId xmlns:a16="http://schemas.microsoft.com/office/drawing/2014/main" id="{1D5AE7B8-C70D-4B47-ADAA-2DA938B4F28F}"/>
               </a:ext>
             </a:extLst>
           </p:cNvPr>
@@ -8837,7 +8837,7 @@
           <p:nvPr/>
         </p:nvPicPr>
         <p:blipFill>
-          <a:blip xmlns:r="http://schemas.openxmlformats.org/officeDocument/2006/relationships" xmlns:a="http://schemas.openxmlformats.org/drawingml/2006/main" r:embed="R95227b87eb474894"/>
+          <a:blip xmlns:r="http://schemas.openxmlformats.org/officeDocument/2006/relationships" xmlns:a="http://schemas.openxmlformats.org/drawingml/2006/main" r:embed="R2d0dc4cb723e4f11"/>
           <a:stretch xmlns:a="http://schemas.openxmlformats.org/drawingml/2006/main"/>
         </p:blipFill>
         <p:spPr>
@@ -8855,7 +8855,7 @@
           <p:cNvPr id="7" name="">
             <a:extLst xmlns:a="http://schemas.openxmlformats.org/drawingml/2006/main">
               <a:ext uri="{FF2B5EF4-FFF2-40B4-BE49-F238E27FC236}">
-                <a16:creationId xmlns:a16="http://schemas.microsoft.com/office/drawing/2014/main" id="{350D971D-692A-4746-A2EA-15F2BCEE8641}"/>
+                <a16:creationId xmlns:a16="http://schemas.microsoft.com/office/drawing/2014/main" id="{B8FD0BF7-E571-418E-AABC-9ABD50F6F176}"/>
               </a:ext>
             </a:extLst>
           </p:cNvPr>
@@ -8865,7 +8865,7 @@
           <p:nvPr/>
         </p:nvPicPr>
         <p:blipFill>
-          <a:blip xmlns:r="http://schemas.openxmlformats.org/officeDocument/2006/relationships" xmlns:a="http://schemas.openxmlformats.org/drawingml/2006/main" r:embed="R63ff22ecc9f84d4e"/>
+          <a:blip xmlns:r="http://schemas.openxmlformats.org/officeDocument/2006/relationships" xmlns:a="http://schemas.openxmlformats.org/drawingml/2006/main" r:embed="Ra60d1400efdd463a"/>
           <a:stretch xmlns:a="http://schemas.openxmlformats.org/drawingml/2006/main"/>
         </p:blipFill>
         <p:spPr>
@@ -8885,9 +8885,6 @@
       </p:ext>
     </p:extLst>
   </p:cSld>
-  <p:transition spd="med">
-    <p:fade/>
-  </p:transition>
 </p:sld>
 </file>
 
@@ -10460,9 +10457,6 @@
       </p:ext>
     </p:extLst>
   </p:cSld>
-  <p:transition spd="med">
-    <p:fade/>
-  </p:transition>
 </p:sld>
 </file>
 
@@ -12129,9 +12123,6 @@
       </p:ext>
     </p:extLst>
   </p:cSld>
-  <p:transition spd="med">
-    <p:fade/>
-  </p:transition>
 </p:sld>
 </file>
 
@@ -13776,9 +13767,6 @@
       </p:ext>
     </p:extLst>
   </p:cSld>
-  <p:transition spd="med">
-    <p:fade/>
-  </p:transition>
 </p:sld>
 </file>
 
@@ -15265,9 +15253,6 @@
       </p:ext>
     </p:extLst>
   </p:cSld>
-  <p:transition spd="med">
-    <p:fade/>
-  </p:transition>
 </p:sld>
 </file>
 
@@ -16349,7 +16334,7 @@
           <p:cNvPr id="7" name="">
             <a:extLst xmlns:a="http://schemas.openxmlformats.org/drawingml/2006/main">
               <a:ext uri="{FF2B5EF4-FFF2-40B4-BE49-F238E27FC236}">
-                <a16:creationId xmlns:a16="http://schemas.microsoft.com/office/drawing/2014/main" id="{CCDB4A75-D326-456D-AFD8-A281CB1942AC}"/>
+                <a16:creationId xmlns:a16="http://schemas.microsoft.com/office/drawing/2014/main" id="{AC893EFE-8A70-42F5-BEDF-03E95772F6DB}"/>
               </a:ext>
             </a:extLst>
           </p:cNvPr>
@@ -16359,7 +16344,7 @@
           <p:nvPr/>
         </p:nvPicPr>
         <p:blipFill>
-          <a:blip xmlns:r="http://schemas.openxmlformats.org/officeDocument/2006/relationships" xmlns:a="http://schemas.openxmlformats.org/drawingml/2006/main" r:embed="Re86834ac2d7f4868"/>
+          <a:blip xmlns:r="http://schemas.openxmlformats.org/officeDocument/2006/relationships" xmlns:a="http://schemas.openxmlformats.org/drawingml/2006/main" r:embed="R9efefb12df8b4c09"/>
           <a:stretch xmlns:a="http://schemas.openxmlformats.org/drawingml/2006/main"/>
         </p:blipFill>
         <p:spPr>
@@ -16379,9 +16364,6 @@
       </p:ext>
     </p:extLst>
   </p:cSld>
-  <p:transition spd="med">
-    <p:fade/>
-  </p:transition>
 </p:sld>
 </file>
 
@@ -17904,9 +17886,6 @@
       </p:ext>
     </p:extLst>
   </p:cSld>
-  <p:transition spd="med">
-    <p:fade/>
-  </p:transition>
 </p:sld>
 </file>
 
@@ -18988,7 +18967,7 @@
           <p:cNvPr id="7" name="">
             <a:extLst xmlns:a="http://schemas.openxmlformats.org/drawingml/2006/main">
               <a:ext uri="{FF2B5EF4-FFF2-40B4-BE49-F238E27FC236}">
-                <a16:creationId xmlns:a16="http://schemas.microsoft.com/office/drawing/2014/main" id="{C9382141-287D-4EC6-BE01-5A33E4E1942B}"/>
+                <a16:creationId xmlns:a16="http://schemas.microsoft.com/office/drawing/2014/main" id="{749B947B-EEDE-4F8C-AB82-0835F08B6B78}"/>
               </a:ext>
             </a:extLst>
           </p:cNvPr>
@@ -18998,7 +18977,7 @@
           <p:nvPr/>
         </p:nvPicPr>
         <p:blipFill>
-          <a:blip xmlns:r="http://schemas.openxmlformats.org/officeDocument/2006/relationships" xmlns:a="http://schemas.openxmlformats.org/drawingml/2006/main" r:embed="R043649746fff440c"/>
+          <a:blip xmlns:r="http://schemas.openxmlformats.org/officeDocument/2006/relationships" xmlns:a="http://schemas.openxmlformats.org/drawingml/2006/main" r:embed="R175001f6bd384063"/>
           <a:srcRect xmlns:a="http://schemas.openxmlformats.org/drawingml/2006/main" l="4000" t="32500" r="4000" b="50000"/>
           <a:stretch xmlns:a="http://schemas.openxmlformats.org/drawingml/2006/main"/>
         </p:blipFill>
@@ -19183,7 +19162,7 @@
           <p:cNvPr id="9" name="">
             <a:extLst xmlns:a="http://schemas.openxmlformats.org/drawingml/2006/main">
               <a:ext uri="{FF2B5EF4-FFF2-40B4-BE49-F238E27FC236}">
-                <a16:creationId xmlns:a16="http://schemas.microsoft.com/office/drawing/2014/main" id="{2F650D6F-A6D2-4AE1-8C1A-B41FDDEF8FDB}"/>
+                <a16:creationId xmlns:a16="http://schemas.microsoft.com/office/drawing/2014/main" id="{ED5F21E0-4FD9-4962-80FA-01252B1ABC89}"/>
               </a:ext>
             </a:extLst>
           </p:cNvPr>
@@ -19193,7 +19172,7 @@
           <p:nvPr/>
         </p:nvPicPr>
         <p:blipFill>
-          <a:blip xmlns:r="http://schemas.openxmlformats.org/officeDocument/2006/relationships" xmlns:a="http://schemas.openxmlformats.org/drawingml/2006/main" r:embed="R8799587ddf7c49c8"/>
+          <a:blip xmlns:r="http://schemas.openxmlformats.org/officeDocument/2006/relationships" xmlns:a="http://schemas.openxmlformats.org/drawingml/2006/main" r:embed="R1301c351d6f241e1"/>
           <a:srcRect xmlns:a="http://schemas.openxmlformats.org/drawingml/2006/main" l="4000" t="86500" r="4000" b="6500"/>
           <a:stretch xmlns:a="http://schemas.openxmlformats.org/drawingml/2006/main"/>
         </p:blipFill>
@@ -19248,6 +19227,7 @@
               </a:defRPr>
             </a:defPPr>
             <a:lvl1pPr>
+              <a:buNone/>
               <a:defRPr sz="1500" b="1">
                 <a:solidFill>
                   <a:srgbClr val="176452"/>
@@ -19258,6 +19238,7 @@
               </a:defRPr>
             </a:lvl1pPr>
             <a:lvl2pPr>
+              <a:buNone/>
               <a:defRPr sz="1500" b="1">
                 <a:solidFill>
                   <a:srgbClr val="176452"/>
@@ -19268,6 +19249,7 @@
               </a:defRPr>
             </a:lvl2pPr>
             <a:lvl3pPr>
+              <a:buNone/>
               <a:defRPr sz="1500" b="1">
                 <a:solidFill>
                   <a:srgbClr val="176452"/>
@@ -19278,6 +19260,7 @@
               </a:defRPr>
             </a:lvl3pPr>
             <a:lvl4pPr>
+              <a:buNone/>
               <a:defRPr sz="1500" b="1">
                 <a:solidFill>
                   <a:srgbClr val="176452"/>
@@ -19288,6 +19271,7 @@
               </a:defRPr>
             </a:lvl4pPr>
             <a:lvl5pPr>
+              <a:buNone/>
               <a:defRPr sz="1500" b="1">
                 <a:solidFill>
                   <a:srgbClr val="176452"/>
@@ -19298,6 +19282,7 @@
               </a:defRPr>
             </a:lvl5pPr>
             <a:lvl6pPr>
+              <a:buNone/>
               <a:defRPr sz="1500" b="1">
                 <a:solidFill>
                   <a:srgbClr val="176452"/>
@@ -19308,6 +19293,7 @@
               </a:defRPr>
             </a:lvl6pPr>
             <a:lvl7pPr>
+              <a:buNone/>
               <a:defRPr sz="1500" b="1">
                 <a:solidFill>
                   <a:srgbClr val="176452"/>
@@ -19318,6 +19304,7 @@
               </a:defRPr>
             </a:lvl7pPr>
             <a:lvl8pPr>
+              <a:buNone/>
               <a:defRPr sz="1500" b="1">
                 <a:solidFill>
                   <a:srgbClr val="176452"/>
@@ -19328,6 +19315,7 @@
               </a:defRPr>
             </a:lvl8pPr>
             <a:lvl9pPr>
+              <a:buNone/>
               <a:defRPr sz="1500" b="1">
                 <a:solidFill>
                   <a:srgbClr val="176452"/>
@@ -19340,6 +19328,7 @@
           </a:lstStyle>
           <a:p xmlns:a="http://schemas.openxmlformats.org/drawingml/2006/main">
             <a:pPr>
+              <a:buNone/>
               <a:defRPr sz="1500" b="1">
                 <a:solidFill>
                   <a:srgbClr val="176452"/>
@@ -19370,9 +19359,6 @@
       </p:ext>
     </p:extLst>
   </p:cSld>
-  <p:transition spd="med">
-    <p:fade/>
-  </p:transition>
 </p:sld>
 </file>
 
@@ -20454,7 +20440,7 @@
           <p:cNvPr id="7" name="">
             <a:extLst xmlns:a="http://schemas.openxmlformats.org/drawingml/2006/main">
               <a:ext uri="{FF2B5EF4-FFF2-40B4-BE49-F238E27FC236}">
-                <a16:creationId xmlns:a16="http://schemas.microsoft.com/office/drawing/2014/main" id="{12E445A0-ABFD-47B1-9721-26468888BB3B}"/>
+                <a16:creationId xmlns:a16="http://schemas.microsoft.com/office/drawing/2014/main" id="{5CC727A0-0CD7-4E3E-99E7-D33A40CA5835}"/>
               </a:ext>
             </a:extLst>
           </p:cNvPr>
@@ -20464,7 +20450,7 @@
           <p:nvPr/>
         </p:nvPicPr>
         <p:blipFill>
-          <a:blip xmlns:r="http://schemas.openxmlformats.org/officeDocument/2006/relationships" xmlns:a="http://schemas.openxmlformats.org/drawingml/2006/main" r:embed="R0eabc1120a2942d1"/>
+          <a:blip xmlns:r="http://schemas.openxmlformats.org/officeDocument/2006/relationships" xmlns:a="http://schemas.openxmlformats.org/drawingml/2006/main" r:embed="R63e5dd5e9a9749be"/>
           <a:srcRect xmlns:a="http://schemas.openxmlformats.org/drawingml/2006/main" l="8000" t="40000" r="8000" b="37000"/>
           <a:stretch xmlns:a="http://schemas.openxmlformats.org/drawingml/2006/main"/>
         </p:blipFill>
@@ -20651,9 +20637,6 @@
       </p:ext>
     </p:extLst>
   </p:cSld>
-  <p:transition spd="med">
-    <p:fade/>
-  </p:transition>
 </p:sld>
 </file>
 
@@ -21677,7 +21660,7 @@
           <p:cNvPr id="7" name="">
             <a:extLst xmlns:a="http://schemas.openxmlformats.org/drawingml/2006/main">
               <a:ext uri="{FF2B5EF4-FFF2-40B4-BE49-F238E27FC236}">
-                <a16:creationId xmlns:a16="http://schemas.microsoft.com/office/drawing/2014/main" id="{5C6D9C07-DC9E-4AB9-BEF5-F493A53C53B9}"/>
+                <a16:creationId xmlns:a16="http://schemas.microsoft.com/office/drawing/2014/main" id="{F89E876A-30C5-4789-812D-9AD343715ED0}"/>
               </a:ext>
             </a:extLst>
           </p:cNvPr>
@@ -21687,7 +21670,7 @@
           <p:nvPr/>
         </p:nvPicPr>
         <p:blipFill>
-          <a:blip xmlns:r="http://schemas.openxmlformats.org/officeDocument/2006/relationships" xmlns:a="http://schemas.openxmlformats.org/drawingml/2006/main" r:embed="R3877e4ddce424b57"/>
+          <a:blip xmlns:r="http://schemas.openxmlformats.org/officeDocument/2006/relationships" xmlns:a="http://schemas.openxmlformats.org/drawingml/2006/main" r:embed="Re037737aa2cd4907"/>
           <a:srcRect xmlns:a="http://schemas.openxmlformats.org/drawingml/2006/main" l="2000" t="37000" r="2000" b="19000"/>
           <a:stretch xmlns:a="http://schemas.openxmlformats.org/drawingml/2006/main"/>
         </p:blipFill>
@@ -21706,7 +21689,7 @@
           <p:cNvPr id="8" name="">
             <a:extLst xmlns:a="http://schemas.openxmlformats.org/drawingml/2006/main">
               <a:ext uri="{FF2B5EF4-FFF2-40B4-BE49-F238E27FC236}">
-                <a16:creationId xmlns:a16="http://schemas.microsoft.com/office/drawing/2014/main" id="{CD94A56F-F5B3-49BE-8E90-C67F46C8E277}"/>
+                <a16:creationId xmlns:a16="http://schemas.microsoft.com/office/drawing/2014/main" id="{E8FB0FC4-7268-4249-93DE-71124B65EB85}"/>
               </a:ext>
             </a:extLst>
           </p:cNvPr>
@@ -21716,7 +21699,7 @@
           <p:nvPr/>
         </p:nvPicPr>
         <p:blipFill>
-          <a:blip xmlns:r="http://schemas.openxmlformats.org/officeDocument/2006/relationships" xmlns:a="http://schemas.openxmlformats.org/drawingml/2006/main" r:embed="R61269b8eb2db46fc"/>
+          <a:blip xmlns:r="http://schemas.openxmlformats.org/officeDocument/2006/relationships" xmlns:a="http://schemas.openxmlformats.org/drawingml/2006/main" r:embed="Rf77e5282818f4f7e"/>
           <a:srcRect xmlns:a="http://schemas.openxmlformats.org/drawingml/2006/main" l="2000" t="37000" r="2000" b="19000"/>
           <a:stretch xmlns:a="http://schemas.openxmlformats.org/drawingml/2006/main"/>
         </p:blipFill>
@@ -22293,9 +22276,6 @@
       </p:ext>
     </p:extLst>
   </p:cSld>
-  <p:transition spd="med">
-    <p:fade/>
-  </p:transition>
 </p:sld>
 </file>
 
@@ -23377,7 +23357,7 @@
           <p:cNvPr id="7" name="">
             <a:extLst xmlns:a="http://schemas.openxmlformats.org/drawingml/2006/main">
               <a:ext uri="{FF2B5EF4-FFF2-40B4-BE49-F238E27FC236}">
-                <a16:creationId xmlns:a16="http://schemas.microsoft.com/office/drawing/2014/main" id="{8D66D49D-6A09-41D1-B1EB-5CEFFF95ACFF}"/>
+                <a16:creationId xmlns:a16="http://schemas.microsoft.com/office/drawing/2014/main" id="{30911474-3EC3-420B-B2CC-AF35237D1116}"/>
               </a:ext>
             </a:extLst>
           </p:cNvPr>
@@ -23387,7 +23367,7 @@
           <p:nvPr/>
         </p:nvPicPr>
         <p:blipFill>
-          <a:blip xmlns:r="http://schemas.openxmlformats.org/officeDocument/2006/relationships" xmlns:a="http://schemas.openxmlformats.org/drawingml/2006/main" r:embed="R55f307e24d72495e"/>
+          <a:blip xmlns:r="http://schemas.openxmlformats.org/officeDocument/2006/relationships" xmlns:a="http://schemas.openxmlformats.org/drawingml/2006/main" r:embed="R50a1dddac0144e60"/>
           <a:srcRect xmlns:a="http://schemas.openxmlformats.org/drawingml/2006/main" l="4500" t="25500" r="4500" b="41500"/>
           <a:stretch xmlns:a="http://schemas.openxmlformats.org/drawingml/2006/main"/>
         </p:blipFill>
@@ -23408,9 +23388,6 @@
       </p:ext>
     </p:extLst>
   </p:cSld>
-  <p:transition spd="med">
-    <p:fade/>
-  </p:transition>
 </p:sld>
 </file>
 
@@ -24492,7 +24469,7 @@
           <p:cNvPr id="7" name="">
             <a:extLst xmlns:a="http://schemas.openxmlformats.org/drawingml/2006/main">
               <a:ext uri="{FF2B5EF4-FFF2-40B4-BE49-F238E27FC236}">
-                <a16:creationId xmlns:a16="http://schemas.microsoft.com/office/drawing/2014/main" id="{72B8CA41-5612-40FE-B27A-8DF23355D850}"/>
+                <a16:creationId xmlns:a16="http://schemas.microsoft.com/office/drawing/2014/main" id="{CFAA675D-67C3-4257-9961-8371648C3803}"/>
               </a:ext>
             </a:extLst>
           </p:cNvPr>
@@ -24502,7 +24479,7 @@
           <p:nvPr/>
         </p:nvPicPr>
         <p:blipFill>
-          <a:blip xmlns:r="http://schemas.openxmlformats.org/officeDocument/2006/relationships" xmlns:a="http://schemas.openxmlformats.org/drawingml/2006/main" r:embed="Rd4de6939d5ad4fd0"/>
+          <a:blip xmlns:r="http://schemas.openxmlformats.org/officeDocument/2006/relationships" xmlns:a="http://schemas.openxmlformats.org/drawingml/2006/main" r:embed="R95e1563983004836"/>
           <a:srcRect xmlns:a="http://schemas.openxmlformats.org/drawingml/2006/main" l="4000" t="58000" r="4000" b="17000"/>
           <a:stretch xmlns:a="http://schemas.openxmlformats.org/drawingml/2006/main"/>
         </p:blipFill>
@@ -24689,9 +24666,6 @@
       </p:ext>
     </p:extLst>
   </p:cSld>
-  <p:transition spd="med">
-    <p:fade/>
-  </p:transition>
 </p:sld>
 </file>
 
@@ -26737,9 +26711,6 @@
       </p:ext>
     </p:extLst>
   </p:cSld>
-  <p:transition spd="med">
-    <p:fade/>
-  </p:transition>
 </p:sld>
 </file>
 
@@ -27597,7 +27568,7 @@
           <p:cNvPr id="6" name="">
             <a:extLst xmlns:a="http://schemas.openxmlformats.org/drawingml/2006/main">
               <a:ext uri="{FF2B5EF4-FFF2-40B4-BE49-F238E27FC236}">
-                <a16:creationId xmlns:a16="http://schemas.microsoft.com/office/drawing/2014/main" id="{B37E5790-9934-4F5C-AB5F-23E6FD01680C}"/>
+                <a16:creationId xmlns:a16="http://schemas.microsoft.com/office/drawing/2014/main" id="{FE27C0A0-4FC3-4FD7-8FE3-E4A0467C6237}"/>
               </a:ext>
             </a:extLst>
           </p:cNvPr>
@@ -28731,9 +28702,6 @@
       </p:ext>
     </p:extLst>
   </p:cSld>
-  <p:transition spd="med">
-    <p:fade/>
-  </p:transition>
 </p:sld>
 </file>
 
@@ -29649,7 +29617,7 @@
           <p:cNvPr id="6" name="Chart">
             <a:extLst xmlns:a="http://schemas.openxmlformats.org/drawingml/2006/main">
               <a:ext uri="{FF2B5EF4-FFF2-40B4-BE49-F238E27FC236}">
-                <a16:creationId xmlns:a16="http://schemas.microsoft.com/office/drawing/2014/main" id="{87BD6ABC-60ED-4650-A9E6-E7ABC2093A5D}"/>
+                <a16:creationId xmlns:a16="http://schemas.microsoft.com/office/drawing/2014/main" id="{42D3DB0E-1DDD-4AD0-8CDD-2B8A0C1B0202}"/>
               </a:ext>
             </a:extLst>
           </p:cNvPr>
@@ -29662,7 +29630,7 @@
         </p:xfrm>
         <a:graphic xmlns:a="http://schemas.openxmlformats.org/drawingml/2006/main">
           <a:graphicData uri="http://schemas.openxmlformats.org/drawingml/2006/chart">
-            <c:chart xmlns:r="http://schemas.openxmlformats.org/officeDocument/2006/relationships" xmlns:c="http://schemas.openxmlformats.org/drawingml/2006/chart" r:id="R1ef0c7cd015c4c89"/>
+            <c:chart xmlns:r="http://schemas.openxmlformats.org/officeDocument/2006/relationships" xmlns:c="http://schemas.openxmlformats.org/drawingml/2006/chart" r:id="R1c8a1cf7f4454d06"/>
           </a:graphicData>
         </a:graphic>
       </p:graphicFrame>
@@ -29863,9 +29831,6 @@
       </p:ext>
     </p:extLst>
   </p:cSld>
-  <p:transition spd="med">
-    <p:fade/>
-  </p:transition>
 </p:sld>
 </file>
 
@@ -31641,9 +31606,6 @@
       </p:ext>
     </p:extLst>
   </p:cSld>
-  <p:transition spd="med">
-    <p:fade/>
-  </p:transition>
 </p:sld>
 </file>
 
@@ -32335,7 +32297,7 @@
           <p:cNvPr id="5" name="">
             <a:extLst xmlns:a="http://schemas.openxmlformats.org/drawingml/2006/main">
               <a:ext uri="{FF2B5EF4-FFF2-40B4-BE49-F238E27FC236}">
-                <a16:creationId xmlns:a16="http://schemas.microsoft.com/office/drawing/2014/main" id="{BFDC1A62-FC95-4C11-89BD-ACF862955BFD}"/>
+                <a16:creationId xmlns:a16="http://schemas.microsoft.com/office/drawing/2014/main" id="{C24FF05A-4E15-41D6-A03C-DB8428ABCB1F}"/>
               </a:ext>
             </a:extLst>
           </p:cNvPr>
@@ -32345,7 +32307,7 @@
           <p:nvPr/>
         </p:nvPicPr>
         <p:blipFill>
-          <a:blip xmlns:r="http://schemas.openxmlformats.org/officeDocument/2006/relationships" xmlns:a="http://schemas.openxmlformats.org/drawingml/2006/main" r:embed="Rdd5a6b9282c94d01"/>
+          <a:blip xmlns:r="http://schemas.openxmlformats.org/officeDocument/2006/relationships" xmlns:a="http://schemas.openxmlformats.org/drawingml/2006/main" r:embed="R145d925432ef4dfc"/>
           <a:stretch xmlns:a="http://schemas.openxmlformats.org/drawingml/2006/main"/>
         </p:blipFill>
         <p:spPr>
@@ -32363,7 +32325,7 @@
           <p:cNvPr id="6" name="">
             <a:extLst xmlns:a="http://schemas.openxmlformats.org/drawingml/2006/main">
               <a:ext uri="{FF2B5EF4-FFF2-40B4-BE49-F238E27FC236}">
-                <a16:creationId xmlns:a16="http://schemas.microsoft.com/office/drawing/2014/main" id="{B246989F-CF8A-4056-B963-23AEA6FC4909}"/>
+                <a16:creationId xmlns:a16="http://schemas.microsoft.com/office/drawing/2014/main" id="{3A1DE2C6-4142-4AB6-ABCE-22E02A0312B8}"/>
               </a:ext>
             </a:extLst>
           </p:cNvPr>
@@ -32373,7 +32335,7 @@
           <p:nvPr/>
         </p:nvPicPr>
         <p:blipFill>
-          <a:blip xmlns:r="http://schemas.openxmlformats.org/officeDocument/2006/relationships" xmlns:a="http://schemas.openxmlformats.org/drawingml/2006/main" r:embed="R5f0473d77c11466d"/>
+          <a:blip xmlns:r="http://schemas.openxmlformats.org/officeDocument/2006/relationships" xmlns:a="http://schemas.openxmlformats.org/drawingml/2006/main" r:embed="R05df3c945c654d9b"/>
           <a:stretch xmlns:a="http://schemas.openxmlformats.org/drawingml/2006/main"/>
         </p:blipFill>
         <p:spPr>
@@ -33271,9 +33233,6 @@
       </p:ext>
     </p:extLst>
   </p:cSld>
-  <p:transition spd="med">
-    <p:fade/>
-  </p:transition>
 </p:sld>
 </file>
 
@@ -34179,7 +34138,7 @@
                 <a:ea typeface="Arial"/>
                 <a:cs typeface="Arial"/>
               </a:rPr>
-              <a:t>The dated ClickUp snapshots and steady target of twenty meaningful commits per person remain gaps in our evidence. The preserved branch history, integration and actual test logs are available for review. In a future project, we would collect board evidence throughout development.</a:t>
+              <a:t>I hold our ClickUp evidence, and the instructor’s revised final deadline is October 31. Our team recording is complete. The preserved branch history, integration and actual test logs are available for review. The repository links connect our implementation to the recorded tests.</a:t>
             </a:r>
           </a:p>
         </p:txBody>
@@ -34892,9 +34851,6 @@
       </p:ext>
     </p:extLst>
   </p:cSld>
-  <p:transition spd="med">
-    <p:fade/>
-  </p:transition>
 </p:sld>
 </file>
 
@@ -36086,9 +36042,6 @@
       </p:ext>
     </p:extLst>
   </p:cSld>
-  <p:transition spd="med">
-    <p:fade/>
-  </p:transition>
 </p:sld>
 </file>
 
@@ -37159,7 +37112,7 @@
                 <a:latin typeface="Arial"/>
                 <a:ea typeface="Arial"/>
                 <a:cs typeface="Arial"/>
-                <a:hlinkClick xmlns:r="http://schemas.openxmlformats.org/officeDocument/2006/relationships" r:id="Ra06066dd93ec4f6f"/>
+                <a:hlinkClick xmlns:r="http://schemas.openxmlformats.org/officeDocument/2006/relationships" r:id="R0cbf5c73a925481b"/>
               </a:rPr>
               <a:t>https://github.com/Omswaroopreddyudumula/ajxom-budget-bites</a:t>
             </a:r>
@@ -37710,9 +37663,6 @@
       </p:ext>
     </p:extLst>
   </p:cSld>
-  <p:transition spd="med">
-    <p:fade/>
-  </p:transition>
 </p:sld>
 </file>
 
@@ -38628,7 +38578,7 @@
           <p:cNvPr id="6" name="">
             <a:extLst xmlns:a="http://schemas.openxmlformats.org/drawingml/2006/main">
               <a:ext uri="{FF2B5EF4-FFF2-40B4-BE49-F238E27FC236}">
-                <a16:creationId xmlns:a16="http://schemas.microsoft.com/office/drawing/2014/main" id="{DA755F4A-C86E-409F-884C-F0609772537B}"/>
+                <a16:creationId xmlns:a16="http://schemas.microsoft.com/office/drawing/2014/main" id="{80D2D186-7E10-4C3D-920E-B35C15B78277}"/>
               </a:ext>
             </a:extLst>
           </p:cNvPr>
@@ -38638,7 +38588,7 @@
           <p:nvPr/>
         </p:nvPicPr>
         <p:blipFill>
-          <a:blip xmlns:r="http://schemas.openxmlformats.org/officeDocument/2006/relationships" xmlns:a="http://schemas.openxmlformats.org/drawingml/2006/main" r:embed="R308c4ef8027b4680"/>
+          <a:blip xmlns:r="http://schemas.openxmlformats.org/officeDocument/2006/relationships" xmlns:a="http://schemas.openxmlformats.org/drawingml/2006/main" r:embed="R92a8b56c04514485"/>
           <a:stretch xmlns:a="http://schemas.openxmlformats.org/drawingml/2006/main"/>
         </p:blipFill>
         <p:spPr>
@@ -38658,9 +38608,6 @@
       </p:ext>
     </p:extLst>
   </p:cSld>
-  <p:transition spd="med">
-    <p:fade/>
-  </p:transition>
 </p:sld>
 </file>
 
@@ -39852,9 +39799,6 @@
       </p:ext>
     </p:extLst>
   </p:cSld>
-  <p:transition spd="med">
-    <p:fade/>
-  </p:transition>
 </p:sld>
 </file>
 
@@ -40712,7 +40656,7 @@
           <p:cNvPr id="6" name="">
             <a:extLst xmlns:a="http://schemas.openxmlformats.org/drawingml/2006/main">
               <a:ext uri="{FF2B5EF4-FFF2-40B4-BE49-F238E27FC236}">
-                <a16:creationId xmlns:a16="http://schemas.microsoft.com/office/drawing/2014/main" id="{AA02E2A7-8C49-4CC1-BF42-CBDBF6B04AB5}"/>
+                <a16:creationId xmlns:a16="http://schemas.microsoft.com/office/drawing/2014/main" id="{29DB429B-4A59-4773-97A2-B1CACFE64490}"/>
               </a:ext>
             </a:extLst>
           </p:cNvPr>
@@ -40722,7 +40666,7 @@
           <p:nvPr/>
         </p:nvPicPr>
         <p:blipFill>
-          <a:blip xmlns:r="http://schemas.openxmlformats.org/officeDocument/2006/relationships" xmlns:a="http://schemas.openxmlformats.org/drawingml/2006/main" r:embed="R0ecd54cc05864550"/>
+          <a:blip xmlns:r="http://schemas.openxmlformats.org/officeDocument/2006/relationships" xmlns:a="http://schemas.openxmlformats.org/drawingml/2006/main" r:embed="R20f54b06f3594ade"/>
           <a:stretch xmlns:a="http://schemas.openxmlformats.org/drawingml/2006/main"/>
         </p:blipFill>
         <p:spPr>
@@ -40906,7 +40850,7 @@
           <p:cNvPr id="8" name="">
             <a:extLst xmlns:a="http://schemas.openxmlformats.org/drawingml/2006/main">
               <a:ext uri="{FF2B5EF4-FFF2-40B4-BE49-F238E27FC236}">
-                <a16:creationId xmlns:a16="http://schemas.microsoft.com/office/drawing/2014/main" id="{F6AC8AFE-16DA-4650-ABB4-D2E9B42748FF}"/>
+                <a16:creationId xmlns:a16="http://schemas.microsoft.com/office/drawing/2014/main" id="{A536199A-D513-4388-867A-8A1C777FA757}"/>
               </a:ext>
             </a:extLst>
           </p:cNvPr>
@@ -40916,7 +40860,7 @@
           <p:nvPr/>
         </p:nvPicPr>
         <p:blipFill>
-          <a:blip xmlns:r="http://schemas.openxmlformats.org/officeDocument/2006/relationships" xmlns:a="http://schemas.openxmlformats.org/drawingml/2006/main" r:embed="Rc3501f87789548e4"/>
+          <a:blip xmlns:r="http://schemas.openxmlformats.org/officeDocument/2006/relationships" xmlns:a="http://schemas.openxmlformats.org/drawingml/2006/main" r:embed="R511f047e1874418e"/>
           <a:stretch xmlns:a="http://schemas.openxmlformats.org/drawingml/2006/main"/>
         </p:blipFill>
         <p:spPr>
@@ -41100,7 +41044,7 @@
           <p:cNvPr id="10" name="">
             <a:extLst xmlns:a="http://schemas.openxmlformats.org/drawingml/2006/main">
               <a:ext uri="{FF2B5EF4-FFF2-40B4-BE49-F238E27FC236}">
-                <a16:creationId xmlns:a16="http://schemas.microsoft.com/office/drawing/2014/main" id="{A063E6DD-EF5F-4709-BDB8-6DA9114337FA}"/>
+                <a16:creationId xmlns:a16="http://schemas.microsoft.com/office/drawing/2014/main" id="{13126ED0-8C47-4C22-B9AB-7AFC7D93E906}"/>
               </a:ext>
             </a:extLst>
           </p:cNvPr>
@@ -41110,7 +41054,7 @@
           <p:nvPr/>
         </p:nvPicPr>
         <p:blipFill>
-          <a:blip xmlns:r="http://schemas.openxmlformats.org/officeDocument/2006/relationships" xmlns:a="http://schemas.openxmlformats.org/drawingml/2006/main" r:embed="R8dfc668c2c14403c"/>
+          <a:blip xmlns:r="http://schemas.openxmlformats.org/officeDocument/2006/relationships" xmlns:a="http://schemas.openxmlformats.org/drawingml/2006/main" r:embed="R8fdfaed146c74edb"/>
           <a:stretch xmlns:a="http://schemas.openxmlformats.org/drawingml/2006/main"/>
         </p:blipFill>
         <p:spPr>
@@ -41294,7 +41238,7 @@
           <p:cNvPr id="12" name="">
             <a:extLst xmlns:a="http://schemas.openxmlformats.org/drawingml/2006/main">
               <a:ext uri="{FF2B5EF4-FFF2-40B4-BE49-F238E27FC236}">
-                <a16:creationId xmlns:a16="http://schemas.microsoft.com/office/drawing/2014/main" id="{2B7A52A4-5AED-4586-B0C9-1759EECE493F}"/>
+                <a16:creationId xmlns:a16="http://schemas.microsoft.com/office/drawing/2014/main" id="{335141B5-461F-4500-9D0D-51BF1566312D}"/>
               </a:ext>
             </a:extLst>
           </p:cNvPr>
@@ -41304,7 +41248,7 @@
           <p:nvPr/>
         </p:nvPicPr>
         <p:blipFill>
-          <a:blip xmlns:r="http://schemas.openxmlformats.org/officeDocument/2006/relationships" xmlns:a="http://schemas.openxmlformats.org/drawingml/2006/main" r:embed="R054955bd8db741e8"/>
+          <a:blip xmlns:r="http://schemas.openxmlformats.org/officeDocument/2006/relationships" xmlns:a="http://schemas.openxmlformats.org/drawingml/2006/main" r:embed="R6afbce61c86d4b9f"/>
           <a:stretch xmlns:a="http://schemas.openxmlformats.org/drawingml/2006/main"/>
         </p:blipFill>
         <p:spPr>
@@ -41488,7 +41432,7 @@
           <p:cNvPr id="14" name="">
             <a:extLst xmlns:a="http://schemas.openxmlformats.org/drawingml/2006/main">
               <a:ext uri="{FF2B5EF4-FFF2-40B4-BE49-F238E27FC236}">
-                <a16:creationId xmlns:a16="http://schemas.microsoft.com/office/drawing/2014/main" id="{832FB5B3-4B0B-4A02-A71C-486A80E46196}"/>
+                <a16:creationId xmlns:a16="http://schemas.microsoft.com/office/drawing/2014/main" id="{25D7885C-4A4C-4510-BD18-E57602F3E931}"/>
               </a:ext>
             </a:extLst>
           </p:cNvPr>
@@ -41498,7 +41442,7 @@
           <p:nvPr/>
         </p:nvPicPr>
         <p:blipFill>
-          <a:blip xmlns:r="http://schemas.openxmlformats.org/officeDocument/2006/relationships" xmlns:a="http://schemas.openxmlformats.org/drawingml/2006/main" r:embed="Rbad71ad9a0244049"/>
+          <a:blip xmlns:r="http://schemas.openxmlformats.org/officeDocument/2006/relationships" xmlns:a="http://schemas.openxmlformats.org/drawingml/2006/main" r:embed="R9ffd963a9a944a22"/>
           <a:stretch xmlns:a="http://schemas.openxmlformats.org/drawingml/2006/main"/>
         </p:blipFill>
         <p:spPr>
@@ -41684,9 +41628,6 @@
       </p:ext>
     </p:extLst>
   </p:cSld>
-  <p:transition spd="med">
-    <p:fade/>
-  </p:transition>
 </p:sld>
 </file>
 
@@ -41714,7 +41655,7 @@
           <p:cNvPr id="11" name="">
             <a:extLst xmlns:a="http://schemas.openxmlformats.org/drawingml/2006/main">
               <a:ext uri="{FF2B5EF4-FFF2-40B4-BE49-F238E27FC236}">
-                <a16:creationId xmlns:a16="http://schemas.microsoft.com/office/drawing/2014/main" id="{BF50F018-B5C7-4F16-88E8-33C7707CE71F}"/>
+                <a16:creationId xmlns:a16="http://schemas.microsoft.com/office/drawing/2014/main" id="{E3F2BF44-1131-40BF-9902-F20B1DCAD645}"/>
               </a:ext>
             </a:extLst>
           </p:cNvPr>
@@ -41745,7 +41686,7 @@
           <p:cNvPr id="10" name="">
             <a:extLst xmlns:a="http://schemas.openxmlformats.org/drawingml/2006/main">
               <a:ext uri="{FF2B5EF4-FFF2-40B4-BE49-F238E27FC236}">
-                <a16:creationId xmlns:a16="http://schemas.microsoft.com/office/drawing/2014/main" id="{A5FA750C-D8E8-4128-972A-5764B437D4AC}"/>
+                <a16:creationId xmlns:a16="http://schemas.microsoft.com/office/drawing/2014/main" id="{0D2BB147-3AC8-4B1B-84B8-6E99130D9D07}"/>
               </a:ext>
             </a:extLst>
           </p:cNvPr>
@@ -43408,9 +43349,6 @@
       </p:ext>
     </p:extLst>
   </p:cSld>
-  <p:transition spd="med">
-    <p:fade/>
-  </p:transition>
 </p:sld>
 </file>
 
@@ -44996,9 +44934,6 @@
       </p:ext>
     </p:extLst>
   </p:cSld>
-  <p:transition spd="med">
-    <p:fade/>
-  </p:transition>
 </p:sld>
 </file>
 
@@ -46499,9 +46434,6 @@
       </p:ext>
     </p:extLst>
   </p:cSld>
-  <p:transition spd="med">
-    <p:fade/>
-  </p:transition>
 </p:sld>
 </file>
 
@@ -47583,7 +47515,7 @@
           <p:cNvPr id="7" name="">
             <a:extLst xmlns:a="http://schemas.openxmlformats.org/drawingml/2006/main">
               <a:ext uri="{FF2B5EF4-FFF2-40B4-BE49-F238E27FC236}">
-                <a16:creationId xmlns:a16="http://schemas.microsoft.com/office/drawing/2014/main" id="{1318BE27-AF40-47AB-A7B1-CB5E4710C395}"/>
+                <a16:creationId xmlns:a16="http://schemas.microsoft.com/office/drawing/2014/main" id="{592868B8-18A0-47C1-A2B2-FA2C4EC86847}"/>
               </a:ext>
             </a:extLst>
           </p:cNvPr>
@@ -47593,7 +47525,7 @@
           <p:nvPr/>
         </p:nvPicPr>
         <p:blipFill>
-          <a:blip xmlns:r="http://schemas.openxmlformats.org/officeDocument/2006/relationships" xmlns:a="http://schemas.openxmlformats.org/drawingml/2006/main" r:embed="R55503b1ff6284133"/>
+          <a:blip xmlns:r="http://schemas.openxmlformats.org/officeDocument/2006/relationships" xmlns:a="http://schemas.openxmlformats.org/drawingml/2006/main" r:embed="R7769198ae4f94d88"/>
           <a:srcRect xmlns:a="http://schemas.openxmlformats.org/drawingml/2006/main" l="13000" t="37500" r="13000" b="33500"/>
           <a:stretch xmlns:a="http://schemas.openxmlformats.org/drawingml/2006/main"/>
         </p:blipFill>
@@ -47780,9 +47712,6 @@
       </p:ext>
     </p:extLst>
   </p:cSld>
-  <p:transition spd="med">
-    <p:fade/>
-  </p:transition>
 </p:sld>
 </file>
 
@@ -47810,7 +47739,7 @@
           <p:cNvPr id="7" name="">
             <a:extLst xmlns:a="http://schemas.openxmlformats.org/drawingml/2006/main">
               <a:ext uri="{FF2B5EF4-FFF2-40B4-BE49-F238E27FC236}">
-                <a16:creationId xmlns:a16="http://schemas.microsoft.com/office/drawing/2014/main" id="{1CA5DBE2-3751-4CB5-942A-CFACF60A31F7}"/>
+                <a16:creationId xmlns:a16="http://schemas.microsoft.com/office/drawing/2014/main" id="{B6F2FA01-6D0E-432D-812C-78BF759EFDCB}"/>
               </a:ext>
             </a:extLst>
           </p:cNvPr>
@@ -49425,9 +49354,6 @@
       </p:ext>
     </p:extLst>
   </p:cSld>
-  <p:transition spd="med">
-    <p:fade/>
-  </p:transition>
 </p:sld>
 </file>
 

</xml_diff>

<commit_message>
Keep report and presentation focused on delivered project
</commit_message>
<xml_diff>
--- a/submission/Project1_Presentation.pptx
+++ b/submission/Project1_Presentation.pptx
@@ -2,40 +2,40 @@
 <file path=ppt/presentation.xml><?xml version="1.0" encoding="utf-8"?>
 <p:presentation xmlns:p="http://schemas.openxmlformats.org/presentationml/2006/main">
   <p:sldMasterIdLst>
-    <p:sldMasterId xmlns:r="http://schemas.openxmlformats.org/officeDocument/2006/relationships" id="2147483648" r:id="R27b1f9f77d3640a8"/>
+    <p:sldMasterId xmlns:r="http://schemas.openxmlformats.org/officeDocument/2006/relationships" id="2147483648" r:id="R2f6c0666d9774630"/>
   </p:sldMasterIdLst>
   <p:notesMasterIdLst>
-    <p:notesMasterId xmlns:r="http://schemas.openxmlformats.org/officeDocument/2006/relationships" r:id="Re970bcdf63ed4927"/>
+    <p:notesMasterId xmlns:r="http://schemas.openxmlformats.org/officeDocument/2006/relationships" r:id="R76c1ccfbee2240b1"/>
   </p:notesMasterIdLst>
   <p:sldIdLst>
-    <p:sldId xmlns:r="http://schemas.openxmlformats.org/officeDocument/2006/relationships" id="256" r:id="Reaf884436a00433e"/>
-    <p:sldId xmlns:r="http://schemas.openxmlformats.org/officeDocument/2006/relationships" id="257" r:id="Rbd1c03e1b3b942cc"/>
-    <p:sldId xmlns:r="http://schemas.openxmlformats.org/officeDocument/2006/relationships" id="258" r:id="R828f8209a82b4ede"/>
-    <p:sldId xmlns:r="http://schemas.openxmlformats.org/officeDocument/2006/relationships" id="259" r:id="Rf0c1a4c2539a4eed"/>
-    <p:sldId xmlns:r="http://schemas.openxmlformats.org/officeDocument/2006/relationships" id="260" r:id="Rf37cd7a1840d4453"/>
-    <p:sldId xmlns:r="http://schemas.openxmlformats.org/officeDocument/2006/relationships" id="261" r:id="R15d08fe5ab4b460c"/>
-    <p:sldId xmlns:r="http://schemas.openxmlformats.org/officeDocument/2006/relationships" id="262" r:id="R7e7f068e7ef54312"/>
-    <p:sldId xmlns:r="http://schemas.openxmlformats.org/officeDocument/2006/relationships" id="263" r:id="Rb95276fe7b7643d5"/>
-    <p:sldId xmlns:r="http://schemas.openxmlformats.org/officeDocument/2006/relationships" id="264" r:id="R0607750556694d1a"/>
-    <p:sldId xmlns:r="http://schemas.openxmlformats.org/officeDocument/2006/relationships" id="265" r:id="R8a34929163264985"/>
-    <p:sldId xmlns:r="http://schemas.openxmlformats.org/officeDocument/2006/relationships" id="266" r:id="R65a8052f569142b4"/>
-    <p:sldId xmlns:r="http://schemas.openxmlformats.org/officeDocument/2006/relationships" id="267" r:id="Rdac1ed9dc0484f30"/>
-    <p:sldId xmlns:r="http://schemas.openxmlformats.org/officeDocument/2006/relationships" id="268" r:id="R55b741328a334375"/>
-    <p:sldId xmlns:r="http://schemas.openxmlformats.org/officeDocument/2006/relationships" id="269" r:id="R0f70f4407506419b"/>
-    <p:sldId xmlns:r="http://schemas.openxmlformats.org/officeDocument/2006/relationships" id="270" r:id="R8b11e2c68e7d4129"/>
-    <p:sldId xmlns:r="http://schemas.openxmlformats.org/officeDocument/2006/relationships" id="271" r:id="R9ae2171adcf0459b"/>
-    <p:sldId xmlns:r="http://schemas.openxmlformats.org/officeDocument/2006/relationships" id="272" r:id="R11e38fb337f7443c"/>
-    <p:sldId xmlns:r="http://schemas.openxmlformats.org/officeDocument/2006/relationships" id="273" r:id="R28b60dd93ec44e5b"/>
-    <p:sldId xmlns:r="http://schemas.openxmlformats.org/officeDocument/2006/relationships" id="274" r:id="R03faaf529d48459d"/>
-    <p:sldId xmlns:r="http://schemas.openxmlformats.org/officeDocument/2006/relationships" id="275" r:id="R30577046b3bc4943"/>
-    <p:sldId xmlns:r="http://schemas.openxmlformats.org/officeDocument/2006/relationships" id="276" r:id="Rb913421084bf483d"/>
-    <p:sldId xmlns:r="http://schemas.openxmlformats.org/officeDocument/2006/relationships" id="277" r:id="R827655237f0b496e"/>
-    <p:sldId xmlns:r="http://schemas.openxmlformats.org/officeDocument/2006/relationships" id="278" r:id="R742d2be834fd4e16"/>
-    <p:sldId xmlns:r="http://schemas.openxmlformats.org/officeDocument/2006/relationships" id="279" r:id="R89920b5c30474951"/>
-    <p:sldId xmlns:r="http://schemas.openxmlformats.org/officeDocument/2006/relationships" id="280" r:id="R9276ee5eb0a84667"/>
-    <p:sldId xmlns:r="http://schemas.openxmlformats.org/officeDocument/2006/relationships" id="281" r:id="R98bb503bfbe442a3"/>
-    <p:sldId xmlns:r="http://schemas.openxmlformats.org/officeDocument/2006/relationships" id="282" r:id="Re2891fb0363b4442"/>
-    <p:sldId xmlns:r="http://schemas.openxmlformats.org/officeDocument/2006/relationships" id="283" r:id="R35afab8f5a1e4b03"/>
+    <p:sldId xmlns:r="http://schemas.openxmlformats.org/officeDocument/2006/relationships" id="256" r:id="Rc262af832e584845"/>
+    <p:sldId xmlns:r="http://schemas.openxmlformats.org/officeDocument/2006/relationships" id="257" r:id="R67861ceee6274b7a"/>
+    <p:sldId xmlns:r="http://schemas.openxmlformats.org/officeDocument/2006/relationships" id="258" r:id="Ra1d497e917f14f50"/>
+    <p:sldId xmlns:r="http://schemas.openxmlformats.org/officeDocument/2006/relationships" id="259" r:id="R8106b5e208284730"/>
+    <p:sldId xmlns:r="http://schemas.openxmlformats.org/officeDocument/2006/relationships" id="260" r:id="R49e4d12a89a44d9e"/>
+    <p:sldId xmlns:r="http://schemas.openxmlformats.org/officeDocument/2006/relationships" id="261" r:id="R79ea75d7f20c4397"/>
+    <p:sldId xmlns:r="http://schemas.openxmlformats.org/officeDocument/2006/relationships" id="262" r:id="Rde0153c993d04c61"/>
+    <p:sldId xmlns:r="http://schemas.openxmlformats.org/officeDocument/2006/relationships" id="263" r:id="Rbdf55c726bf44a2e"/>
+    <p:sldId xmlns:r="http://schemas.openxmlformats.org/officeDocument/2006/relationships" id="264" r:id="R6f6cdcb2c19941ab"/>
+    <p:sldId xmlns:r="http://schemas.openxmlformats.org/officeDocument/2006/relationships" id="265" r:id="Refebaea549eb4473"/>
+    <p:sldId xmlns:r="http://schemas.openxmlformats.org/officeDocument/2006/relationships" id="266" r:id="R495b125ad07041d3"/>
+    <p:sldId xmlns:r="http://schemas.openxmlformats.org/officeDocument/2006/relationships" id="267" r:id="R632e0aed7b004077"/>
+    <p:sldId xmlns:r="http://schemas.openxmlformats.org/officeDocument/2006/relationships" id="268" r:id="Rb19b5e44a97c409d"/>
+    <p:sldId xmlns:r="http://schemas.openxmlformats.org/officeDocument/2006/relationships" id="269" r:id="R605ff5c97d4b4b7b"/>
+    <p:sldId xmlns:r="http://schemas.openxmlformats.org/officeDocument/2006/relationships" id="270" r:id="R2c4260df3e4c4a75"/>
+    <p:sldId xmlns:r="http://schemas.openxmlformats.org/officeDocument/2006/relationships" id="271" r:id="Rddc7ab21a1034163"/>
+    <p:sldId xmlns:r="http://schemas.openxmlformats.org/officeDocument/2006/relationships" id="272" r:id="R1e2b3acdf4ae4494"/>
+    <p:sldId xmlns:r="http://schemas.openxmlformats.org/officeDocument/2006/relationships" id="273" r:id="R7acda321335143e2"/>
+    <p:sldId xmlns:r="http://schemas.openxmlformats.org/officeDocument/2006/relationships" id="274" r:id="Rd6186a0afd9847ce"/>
+    <p:sldId xmlns:r="http://schemas.openxmlformats.org/officeDocument/2006/relationships" id="275" r:id="R93bc79826cb04124"/>
+    <p:sldId xmlns:r="http://schemas.openxmlformats.org/officeDocument/2006/relationships" id="276" r:id="R38c0b5f053b541c9"/>
+    <p:sldId xmlns:r="http://schemas.openxmlformats.org/officeDocument/2006/relationships" id="277" r:id="R931d052cf3d94c12"/>
+    <p:sldId xmlns:r="http://schemas.openxmlformats.org/officeDocument/2006/relationships" id="278" r:id="Rd5846a9e7e0c4d05"/>
+    <p:sldId xmlns:r="http://schemas.openxmlformats.org/officeDocument/2006/relationships" id="279" r:id="Rc5f977b28927443b"/>
+    <p:sldId xmlns:r="http://schemas.openxmlformats.org/officeDocument/2006/relationships" id="280" r:id="Rc4b78e7c13784546"/>
+    <p:sldId xmlns:r="http://schemas.openxmlformats.org/officeDocument/2006/relationships" id="281" r:id="Rbe2d993f964548a3"/>
+    <p:sldId xmlns:r="http://schemas.openxmlformats.org/officeDocument/2006/relationships" id="282" r:id="R9df815d6892e4550"/>
+    <p:sldId xmlns:r="http://schemas.openxmlformats.org/officeDocument/2006/relationships" id="283" r:id="Ra044dc48d5d44db4"/>
   </p:sldIdLst>
   <p:sldSz cx="12192000" cy="6858000"/>
   <p:notesSz cx="6858000" cy="9144000"/>
@@ -2899,7 +2899,7 @@
           </a:p>
           <a:p xmlns:a="http://schemas.openxmlformats.org/drawingml/2006/main">
             <a:r>
-              <a:t>I hold our ClickUp evidence, and the instructor’s revised final deadline is October 31. Our team recording is complete. The preserved branch history, integration and actual test logs are available for review. In a future project, we would collect board evidence throughout development.</a:t>
+              <a:t>The preserved branch history, shared data ownership and focused regression tests connect both contributions into one working application. The preserved branch history, integration and actual test logs are available for review. In a future project, we would collect board evidence throughout development.</a:t>
             </a:r>
           </a:p>
           <a:p xmlns:a="http://schemas.openxmlformats.org/drawingml/2006/main">
@@ -7142,12 +7142,12 @@
   </p:cSld>
   <p:clrMap bg1="lt1" tx1="dk1" bg2="lt2" tx2="dk2" accent1="accent1" accent2="accent2" accent3="accent3" accent4="accent4" accent5="accent5" accent6="accent6" hlink="hlink" folHlink="folHlink"/>
   <p:sldLayoutIdLst>
-    <p:sldLayoutId xmlns:r="http://schemas.openxmlformats.org/officeDocument/2006/relationships" id="2147483649" r:id="R5be862c5885c4b85"/>
-    <p:sldLayoutId xmlns:r="http://schemas.openxmlformats.org/officeDocument/2006/relationships" id="2147483650" r:id="R2386279bae074e4a"/>
-    <p:sldLayoutId xmlns:r="http://schemas.openxmlformats.org/officeDocument/2006/relationships" id="2147483651" r:id="R84853fd1534848f4"/>
-    <p:sldLayoutId xmlns:r="http://schemas.openxmlformats.org/officeDocument/2006/relationships" id="2147483652" r:id="R426f19b080cc44a8"/>
-    <p:sldLayoutId xmlns:r="http://schemas.openxmlformats.org/officeDocument/2006/relationships" id="2147483653" r:id="R0cf20d769f994d08"/>
-    <p:sldLayoutId xmlns:r="http://schemas.openxmlformats.org/officeDocument/2006/relationships" id="2147483654" r:id="Rbd4bb7881919483f"/>
+    <p:sldLayoutId xmlns:r="http://schemas.openxmlformats.org/officeDocument/2006/relationships" id="2147483649" r:id="Rc5e3ee7467124200"/>
+    <p:sldLayoutId xmlns:r="http://schemas.openxmlformats.org/officeDocument/2006/relationships" id="2147483650" r:id="R54bd08de30384167"/>
+    <p:sldLayoutId xmlns:r="http://schemas.openxmlformats.org/officeDocument/2006/relationships" id="2147483651" r:id="R526b91d6b65440ab"/>
+    <p:sldLayoutId xmlns:r="http://schemas.openxmlformats.org/officeDocument/2006/relationships" id="2147483652" r:id="R95986136d75a4f15"/>
+    <p:sldLayoutId xmlns:r="http://schemas.openxmlformats.org/officeDocument/2006/relationships" id="2147483653" r:id="R0a46196606a24675"/>
+    <p:sldLayoutId xmlns:r="http://schemas.openxmlformats.org/officeDocument/2006/relationships" id="2147483654" r:id="Rf5cc2477e4a14231"/>
   </p:sldLayoutIdLst>
   <p:txStyles>
     <p:titleStyle>
@@ -8827,7 +8827,7 @@
           <p:cNvPr id="6" name="">
             <a:extLst xmlns:a="http://schemas.openxmlformats.org/drawingml/2006/main">
               <a:ext uri="{FF2B5EF4-FFF2-40B4-BE49-F238E27FC236}">
-                <a16:creationId xmlns:a16="http://schemas.microsoft.com/office/drawing/2014/main" id="{1D5AE7B8-C70D-4B47-ADAA-2DA938B4F28F}"/>
+                <a16:creationId xmlns:a16="http://schemas.microsoft.com/office/drawing/2014/main" id="{C3CE75D1-1D84-48DD-8025-E5C65F4CD00A}"/>
               </a:ext>
             </a:extLst>
           </p:cNvPr>
@@ -8837,7 +8837,7 @@
           <p:nvPr/>
         </p:nvPicPr>
         <p:blipFill>
-          <a:blip xmlns:r="http://schemas.openxmlformats.org/officeDocument/2006/relationships" xmlns:a="http://schemas.openxmlformats.org/drawingml/2006/main" r:embed="R2d0dc4cb723e4f11"/>
+          <a:blip xmlns:r="http://schemas.openxmlformats.org/officeDocument/2006/relationships" xmlns:a="http://schemas.openxmlformats.org/drawingml/2006/main" r:embed="R584b0e0af8af430f"/>
           <a:stretch xmlns:a="http://schemas.openxmlformats.org/drawingml/2006/main"/>
         </p:blipFill>
         <p:spPr>
@@ -8855,7 +8855,7 @@
           <p:cNvPr id="7" name="">
             <a:extLst xmlns:a="http://schemas.openxmlformats.org/drawingml/2006/main">
               <a:ext uri="{FF2B5EF4-FFF2-40B4-BE49-F238E27FC236}">
-                <a16:creationId xmlns:a16="http://schemas.microsoft.com/office/drawing/2014/main" id="{B8FD0BF7-E571-418E-AABC-9ABD50F6F176}"/>
+                <a16:creationId xmlns:a16="http://schemas.microsoft.com/office/drawing/2014/main" id="{AEE0C344-DE49-452A-A5E8-CBCF72AD0F6C}"/>
               </a:ext>
             </a:extLst>
           </p:cNvPr>
@@ -8865,7 +8865,7 @@
           <p:nvPr/>
         </p:nvPicPr>
         <p:blipFill>
-          <a:blip xmlns:r="http://schemas.openxmlformats.org/officeDocument/2006/relationships" xmlns:a="http://schemas.openxmlformats.org/drawingml/2006/main" r:embed="Ra60d1400efdd463a"/>
+          <a:blip xmlns:r="http://schemas.openxmlformats.org/officeDocument/2006/relationships" xmlns:a="http://schemas.openxmlformats.org/drawingml/2006/main" r:embed="R287b9904d4134c00"/>
           <a:stretch xmlns:a="http://schemas.openxmlformats.org/drawingml/2006/main"/>
         </p:blipFill>
         <p:spPr>
@@ -16334,7 +16334,7 @@
           <p:cNvPr id="7" name="">
             <a:extLst xmlns:a="http://schemas.openxmlformats.org/drawingml/2006/main">
               <a:ext uri="{FF2B5EF4-FFF2-40B4-BE49-F238E27FC236}">
-                <a16:creationId xmlns:a16="http://schemas.microsoft.com/office/drawing/2014/main" id="{AC893EFE-8A70-42F5-BEDF-03E95772F6DB}"/>
+                <a16:creationId xmlns:a16="http://schemas.microsoft.com/office/drawing/2014/main" id="{62E3CA1A-74E7-4FAA-8056-A9303CF8BB73}"/>
               </a:ext>
             </a:extLst>
           </p:cNvPr>
@@ -16344,7 +16344,7 @@
           <p:nvPr/>
         </p:nvPicPr>
         <p:blipFill>
-          <a:blip xmlns:r="http://schemas.openxmlformats.org/officeDocument/2006/relationships" xmlns:a="http://schemas.openxmlformats.org/drawingml/2006/main" r:embed="R9efefb12df8b4c09"/>
+          <a:blip xmlns:r="http://schemas.openxmlformats.org/officeDocument/2006/relationships" xmlns:a="http://schemas.openxmlformats.org/drawingml/2006/main" r:embed="R66ea30d4df6c4388"/>
           <a:stretch xmlns:a="http://schemas.openxmlformats.org/drawingml/2006/main"/>
         </p:blipFill>
         <p:spPr>
@@ -18967,7 +18967,7 @@
           <p:cNvPr id="7" name="">
             <a:extLst xmlns:a="http://schemas.openxmlformats.org/drawingml/2006/main">
               <a:ext uri="{FF2B5EF4-FFF2-40B4-BE49-F238E27FC236}">
-                <a16:creationId xmlns:a16="http://schemas.microsoft.com/office/drawing/2014/main" id="{749B947B-EEDE-4F8C-AB82-0835F08B6B78}"/>
+                <a16:creationId xmlns:a16="http://schemas.microsoft.com/office/drawing/2014/main" id="{3A4D4157-D518-4D02-95B5-E463091C2163}"/>
               </a:ext>
             </a:extLst>
           </p:cNvPr>
@@ -18977,7 +18977,7 @@
           <p:nvPr/>
         </p:nvPicPr>
         <p:blipFill>
-          <a:blip xmlns:r="http://schemas.openxmlformats.org/officeDocument/2006/relationships" xmlns:a="http://schemas.openxmlformats.org/drawingml/2006/main" r:embed="R175001f6bd384063"/>
+          <a:blip xmlns:r="http://schemas.openxmlformats.org/officeDocument/2006/relationships" xmlns:a="http://schemas.openxmlformats.org/drawingml/2006/main" r:embed="Rc505e338ed8f4765"/>
           <a:srcRect xmlns:a="http://schemas.openxmlformats.org/drawingml/2006/main" l="4000" t="32500" r="4000" b="50000"/>
           <a:stretch xmlns:a="http://schemas.openxmlformats.org/drawingml/2006/main"/>
         </p:blipFill>
@@ -19162,7 +19162,7 @@
           <p:cNvPr id="9" name="">
             <a:extLst xmlns:a="http://schemas.openxmlformats.org/drawingml/2006/main">
               <a:ext uri="{FF2B5EF4-FFF2-40B4-BE49-F238E27FC236}">
-                <a16:creationId xmlns:a16="http://schemas.microsoft.com/office/drawing/2014/main" id="{ED5F21E0-4FD9-4962-80FA-01252B1ABC89}"/>
+                <a16:creationId xmlns:a16="http://schemas.microsoft.com/office/drawing/2014/main" id="{4283C11A-CCD5-4006-8753-21B52B4B8214}"/>
               </a:ext>
             </a:extLst>
           </p:cNvPr>
@@ -19172,7 +19172,7 @@
           <p:nvPr/>
         </p:nvPicPr>
         <p:blipFill>
-          <a:blip xmlns:r="http://schemas.openxmlformats.org/officeDocument/2006/relationships" xmlns:a="http://schemas.openxmlformats.org/drawingml/2006/main" r:embed="R1301c351d6f241e1"/>
+          <a:blip xmlns:r="http://schemas.openxmlformats.org/officeDocument/2006/relationships" xmlns:a="http://schemas.openxmlformats.org/drawingml/2006/main" r:embed="R5d9a30ae0d3b4015"/>
           <a:srcRect xmlns:a="http://schemas.openxmlformats.org/drawingml/2006/main" l="4000" t="86500" r="4000" b="6500"/>
           <a:stretch xmlns:a="http://schemas.openxmlformats.org/drawingml/2006/main"/>
         </p:blipFill>
@@ -20440,7 +20440,7 @@
           <p:cNvPr id="7" name="">
             <a:extLst xmlns:a="http://schemas.openxmlformats.org/drawingml/2006/main">
               <a:ext uri="{FF2B5EF4-FFF2-40B4-BE49-F238E27FC236}">
-                <a16:creationId xmlns:a16="http://schemas.microsoft.com/office/drawing/2014/main" id="{5CC727A0-0CD7-4E3E-99E7-D33A40CA5835}"/>
+                <a16:creationId xmlns:a16="http://schemas.microsoft.com/office/drawing/2014/main" id="{8E52C725-54F3-4461-B5F7-018BB3E53C7C}"/>
               </a:ext>
             </a:extLst>
           </p:cNvPr>
@@ -20450,7 +20450,7 @@
           <p:nvPr/>
         </p:nvPicPr>
         <p:blipFill>
-          <a:blip xmlns:r="http://schemas.openxmlformats.org/officeDocument/2006/relationships" xmlns:a="http://schemas.openxmlformats.org/drawingml/2006/main" r:embed="R63e5dd5e9a9749be"/>
+          <a:blip xmlns:r="http://schemas.openxmlformats.org/officeDocument/2006/relationships" xmlns:a="http://schemas.openxmlformats.org/drawingml/2006/main" r:embed="R4d70dc7425154b25"/>
           <a:srcRect xmlns:a="http://schemas.openxmlformats.org/drawingml/2006/main" l="8000" t="40000" r="8000" b="37000"/>
           <a:stretch xmlns:a="http://schemas.openxmlformats.org/drawingml/2006/main"/>
         </p:blipFill>
@@ -21660,7 +21660,7 @@
           <p:cNvPr id="7" name="">
             <a:extLst xmlns:a="http://schemas.openxmlformats.org/drawingml/2006/main">
               <a:ext uri="{FF2B5EF4-FFF2-40B4-BE49-F238E27FC236}">
-                <a16:creationId xmlns:a16="http://schemas.microsoft.com/office/drawing/2014/main" id="{F89E876A-30C5-4789-812D-9AD343715ED0}"/>
+                <a16:creationId xmlns:a16="http://schemas.microsoft.com/office/drawing/2014/main" id="{7B4EECC4-3156-4D86-963F-05B1A8F35C97}"/>
               </a:ext>
             </a:extLst>
           </p:cNvPr>
@@ -21670,7 +21670,7 @@
           <p:nvPr/>
         </p:nvPicPr>
         <p:blipFill>
-          <a:blip xmlns:r="http://schemas.openxmlformats.org/officeDocument/2006/relationships" xmlns:a="http://schemas.openxmlformats.org/drawingml/2006/main" r:embed="Re037737aa2cd4907"/>
+          <a:blip xmlns:r="http://schemas.openxmlformats.org/officeDocument/2006/relationships" xmlns:a="http://schemas.openxmlformats.org/drawingml/2006/main" r:embed="Rf4936ab8d5c24e32"/>
           <a:srcRect xmlns:a="http://schemas.openxmlformats.org/drawingml/2006/main" l="2000" t="37000" r="2000" b="19000"/>
           <a:stretch xmlns:a="http://schemas.openxmlformats.org/drawingml/2006/main"/>
         </p:blipFill>
@@ -21689,7 +21689,7 @@
           <p:cNvPr id="8" name="">
             <a:extLst xmlns:a="http://schemas.openxmlformats.org/drawingml/2006/main">
               <a:ext uri="{FF2B5EF4-FFF2-40B4-BE49-F238E27FC236}">
-                <a16:creationId xmlns:a16="http://schemas.microsoft.com/office/drawing/2014/main" id="{E8FB0FC4-7268-4249-93DE-71124B65EB85}"/>
+                <a16:creationId xmlns:a16="http://schemas.microsoft.com/office/drawing/2014/main" id="{AB3AD500-772D-4BCE-8CF5-E15D8B3C65D2}"/>
               </a:ext>
             </a:extLst>
           </p:cNvPr>
@@ -21699,7 +21699,7 @@
           <p:nvPr/>
         </p:nvPicPr>
         <p:blipFill>
-          <a:blip xmlns:r="http://schemas.openxmlformats.org/officeDocument/2006/relationships" xmlns:a="http://schemas.openxmlformats.org/drawingml/2006/main" r:embed="Rf77e5282818f4f7e"/>
+          <a:blip xmlns:r="http://schemas.openxmlformats.org/officeDocument/2006/relationships" xmlns:a="http://schemas.openxmlformats.org/drawingml/2006/main" r:embed="R47efdd92d83e4cf8"/>
           <a:srcRect xmlns:a="http://schemas.openxmlformats.org/drawingml/2006/main" l="2000" t="37000" r="2000" b="19000"/>
           <a:stretch xmlns:a="http://schemas.openxmlformats.org/drawingml/2006/main"/>
         </p:blipFill>
@@ -23357,7 +23357,7 @@
           <p:cNvPr id="7" name="">
             <a:extLst xmlns:a="http://schemas.openxmlformats.org/drawingml/2006/main">
               <a:ext uri="{FF2B5EF4-FFF2-40B4-BE49-F238E27FC236}">
-                <a16:creationId xmlns:a16="http://schemas.microsoft.com/office/drawing/2014/main" id="{30911474-3EC3-420B-B2CC-AF35237D1116}"/>
+                <a16:creationId xmlns:a16="http://schemas.microsoft.com/office/drawing/2014/main" id="{004F217E-4164-4BCB-9615-3BE074D30CE2}"/>
               </a:ext>
             </a:extLst>
           </p:cNvPr>
@@ -23367,7 +23367,7 @@
           <p:nvPr/>
         </p:nvPicPr>
         <p:blipFill>
-          <a:blip xmlns:r="http://schemas.openxmlformats.org/officeDocument/2006/relationships" xmlns:a="http://schemas.openxmlformats.org/drawingml/2006/main" r:embed="R50a1dddac0144e60"/>
+          <a:blip xmlns:r="http://schemas.openxmlformats.org/officeDocument/2006/relationships" xmlns:a="http://schemas.openxmlformats.org/drawingml/2006/main" r:embed="R9bfd7dd38af147fc"/>
           <a:srcRect xmlns:a="http://schemas.openxmlformats.org/drawingml/2006/main" l="4500" t="25500" r="4500" b="41500"/>
           <a:stretch xmlns:a="http://schemas.openxmlformats.org/drawingml/2006/main"/>
         </p:blipFill>
@@ -24469,7 +24469,7 @@
           <p:cNvPr id="7" name="">
             <a:extLst xmlns:a="http://schemas.openxmlformats.org/drawingml/2006/main">
               <a:ext uri="{FF2B5EF4-FFF2-40B4-BE49-F238E27FC236}">
-                <a16:creationId xmlns:a16="http://schemas.microsoft.com/office/drawing/2014/main" id="{CFAA675D-67C3-4257-9961-8371648C3803}"/>
+                <a16:creationId xmlns:a16="http://schemas.microsoft.com/office/drawing/2014/main" id="{1F07C291-4A13-4AA8-901B-81EE14237B32}"/>
               </a:ext>
             </a:extLst>
           </p:cNvPr>
@@ -24479,7 +24479,7 @@
           <p:nvPr/>
         </p:nvPicPr>
         <p:blipFill>
-          <a:blip xmlns:r="http://schemas.openxmlformats.org/officeDocument/2006/relationships" xmlns:a="http://schemas.openxmlformats.org/drawingml/2006/main" r:embed="R95e1563983004836"/>
+          <a:blip xmlns:r="http://schemas.openxmlformats.org/officeDocument/2006/relationships" xmlns:a="http://schemas.openxmlformats.org/drawingml/2006/main" r:embed="R4a738d687ac74ff1"/>
           <a:srcRect xmlns:a="http://schemas.openxmlformats.org/drawingml/2006/main" l="4000" t="58000" r="4000" b="17000"/>
           <a:stretch xmlns:a="http://schemas.openxmlformats.org/drawingml/2006/main"/>
         </p:blipFill>
@@ -27568,7 +27568,7 @@
           <p:cNvPr id="6" name="">
             <a:extLst xmlns:a="http://schemas.openxmlformats.org/drawingml/2006/main">
               <a:ext uri="{FF2B5EF4-FFF2-40B4-BE49-F238E27FC236}">
-                <a16:creationId xmlns:a16="http://schemas.microsoft.com/office/drawing/2014/main" id="{FE27C0A0-4FC3-4FD7-8FE3-E4A0467C6237}"/>
+                <a16:creationId xmlns:a16="http://schemas.microsoft.com/office/drawing/2014/main" id="{37D7B00D-DA2B-418B-8F65-91540CD03253}"/>
               </a:ext>
             </a:extLst>
           </p:cNvPr>
@@ -29617,7 +29617,7 @@
           <p:cNvPr id="6" name="Chart">
             <a:extLst xmlns:a="http://schemas.openxmlformats.org/drawingml/2006/main">
               <a:ext uri="{FF2B5EF4-FFF2-40B4-BE49-F238E27FC236}">
-                <a16:creationId xmlns:a16="http://schemas.microsoft.com/office/drawing/2014/main" id="{42D3DB0E-1DDD-4AD0-8CDD-2B8A0C1B0202}"/>
+                <a16:creationId xmlns:a16="http://schemas.microsoft.com/office/drawing/2014/main" id="{18004E30-9FC1-4191-B87F-269FF50480C7}"/>
               </a:ext>
             </a:extLst>
           </p:cNvPr>
@@ -29630,7 +29630,7 @@
         </p:xfrm>
         <a:graphic xmlns:a="http://schemas.openxmlformats.org/drawingml/2006/main">
           <a:graphicData uri="http://schemas.openxmlformats.org/drawingml/2006/chart">
-            <c:chart xmlns:r="http://schemas.openxmlformats.org/officeDocument/2006/relationships" xmlns:c="http://schemas.openxmlformats.org/drawingml/2006/chart" r:id="R1c8a1cf7f4454d06"/>
+            <c:chart xmlns:r="http://schemas.openxmlformats.org/officeDocument/2006/relationships" xmlns:c="http://schemas.openxmlformats.org/drawingml/2006/chart" r:id="R07016659867c4b84"/>
           </a:graphicData>
         </a:graphic>
       </p:graphicFrame>
@@ -32297,7 +32297,7 @@
           <p:cNvPr id="5" name="">
             <a:extLst xmlns:a="http://schemas.openxmlformats.org/drawingml/2006/main">
               <a:ext uri="{FF2B5EF4-FFF2-40B4-BE49-F238E27FC236}">
-                <a16:creationId xmlns:a16="http://schemas.microsoft.com/office/drawing/2014/main" id="{C24FF05A-4E15-41D6-A03C-DB8428ABCB1F}"/>
+                <a16:creationId xmlns:a16="http://schemas.microsoft.com/office/drawing/2014/main" id="{4852E17F-BE74-4939-AE0E-88E529A18ADA}"/>
               </a:ext>
             </a:extLst>
           </p:cNvPr>
@@ -32307,7 +32307,7 @@
           <p:nvPr/>
         </p:nvPicPr>
         <p:blipFill>
-          <a:blip xmlns:r="http://schemas.openxmlformats.org/officeDocument/2006/relationships" xmlns:a="http://schemas.openxmlformats.org/drawingml/2006/main" r:embed="R145d925432ef4dfc"/>
+          <a:blip xmlns:r="http://schemas.openxmlformats.org/officeDocument/2006/relationships" xmlns:a="http://schemas.openxmlformats.org/drawingml/2006/main" r:embed="R66ce946204294c05"/>
           <a:stretch xmlns:a="http://schemas.openxmlformats.org/drawingml/2006/main"/>
         </p:blipFill>
         <p:spPr>
@@ -32325,7 +32325,7 @@
           <p:cNvPr id="6" name="">
             <a:extLst xmlns:a="http://schemas.openxmlformats.org/drawingml/2006/main">
               <a:ext uri="{FF2B5EF4-FFF2-40B4-BE49-F238E27FC236}">
-                <a16:creationId xmlns:a16="http://schemas.microsoft.com/office/drawing/2014/main" id="{3A1DE2C6-4142-4AB6-ABCE-22E02A0312B8}"/>
+                <a16:creationId xmlns:a16="http://schemas.microsoft.com/office/drawing/2014/main" id="{241C1799-5FA7-4FDB-AFC1-C1ADCB2F3D4B}"/>
               </a:ext>
             </a:extLst>
           </p:cNvPr>
@@ -32335,7 +32335,7 @@
           <p:nvPr/>
         </p:nvPicPr>
         <p:blipFill>
-          <a:blip xmlns:r="http://schemas.openxmlformats.org/officeDocument/2006/relationships" xmlns:a="http://schemas.openxmlformats.org/drawingml/2006/main" r:embed="R05df3c945c654d9b"/>
+          <a:blip xmlns:r="http://schemas.openxmlformats.org/officeDocument/2006/relationships" xmlns:a="http://schemas.openxmlformats.org/drawingml/2006/main" r:embed="Re1cd96d8904046a9"/>
           <a:stretch xmlns:a="http://schemas.openxmlformats.org/drawingml/2006/main"/>
         </p:blipFill>
         <p:spPr>
@@ -34138,7 +34138,7 @@
                 <a:ea typeface="Arial"/>
                 <a:cs typeface="Arial"/>
               </a:rPr>
-              <a:t>I hold our ClickUp evidence, and the instructor’s revised final deadline is October 31. Our team recording is complete. The preserved branch history, integration and actual test logs are available for review. The repository links connect our implementation to the recorded tests.</a:t>
+              <a:t>The preserved branch history, shared data ownership and focused regression tests connect both contributions into one working application. History totals, receipt actions and large-text behavior were checked after integration.</a:t>
             </a:r>
           </a:p>
         </p:txBody>
@@ -37112,7 +37112,7 @@
                 <a:latin typeface="Arial"/>
                 <a:ea typeface="Arial"/>
                 <a:cs typeface="Arial"/>
-                <a:hlinkClick xmlns:r="http://schemas.openxmlformats.org/officeDocument/2006/relationships" r:id="R0cbf5c73a925481b"/>
+                <a:hlinkClick xmlns:r="http://schemas.openxmlformats.org/officeDocument/2006/relationships" r:id="Raed0ae2c63e64868"/>
               </a:rPr>
               <a:t>https://github.com/Omswaroopreddyudumula/ajxom-budget-bites</a:t>
             </a:r>
@@ -38578,7 +38578,7 @@
           <p:cNvPr id="6" name="">
             <a:extLst xmlns:a="http://schemas.openxmlformats.org/drawingml/2006/main">
               <a:ext uri="{FF2B5EF4-FFF2-40B4-BE49-F238E27FC236}">
-                <a16:creationId xmlns:a16="http://schemas.microsoft.com/office/drawing/2014/main" id="{80D2D186-7E10-4C3D-920E-B35C15B78277}"/>
+                <a16:creationId xmlns:a16="http://schemas.microsoft.com/office/drawing/2014/main" id="{6B47BC6D-B99B-4403-9321-E87F8B6CF3B9}"/>
               </a:ext>
             </a:extLst>
           </p:cNvPr>
@@ -38588,7 +38588,7 @@
           <p:nvPr/>
         </p:nvPicPr>
         <p:blipFill>
-          <a:blip xmlns:r="http://schemas.openxmlformats.org/officeDocument/2006/relationships" xmlns:a="http://schemas.openxmlformats.org/drawingml/2006/main" r:embed="R92a8b56c04514485"/>
+          <a:blip xmlns:r="http://schemas.openxmlformats.org/officeDocument/2006/relationships" xmlns:a="http://schemas.openxmlformats.org/drawingml/2006/main" r:embed="Rcfae175e078b4d96"/>
           <a:stretch xmlns:a="http://schemas.openxmlformats.org/drawingml/2006/main"/>
         </p:blipFill>
         <p:spPr>
@@ -40656,7 +40656,7 @@
           <p:cNvPr id="6" name="">
             <a:extLst xmlns:a="http://schemas.openxmlformats.org/drawingml/2006/main">
               <a:ext uri="{FF2B5EF4-FFF2-40B4-BE49-F238E27FC236}">
-                <a16:creationId xmlns:a16="http://schemas.microsoft.com/office/drawing/2014/main" id="{29DB429B-4A59-4773-97A2-B1CACFE64490}"/>
+                <a16:creationId xmlns:a16="http://schemas.microsoft.com/office/drawing/2014/main" id="{532522FE-0DBA-4480-968B-4699C6CD2CCC}"/>
               </a:ext>
             </a:extLst>
           </p:cNvPr>
@@ -40666,7 +40666,7 @@
           <p:nvPr/>
         </p:nvPicPr>
         <p:blipFill>
-          <a:blip xmlns:r="http://schemas.openxmlformats.org/officeDocument/2006/relationships" xmlns:a="http://schemas.openxmlformats.org/drawingml/2006/main" r:embed="R20f54b06f3594ade"/>
+          <a:blip xmlns:r="http://schemas.openxmlformats.org/officeDocument/2006/relationships" xmlns:a="http://schemas.openxmlformats.org/drawingml/2006/main" r:embed="R0f3048a0cedc42ce"/>
           <a:stretch xmlns:a="http://schemas.openxmlformats.org/drawingml/2006/main"/>
         </p:blipFill>
         <p:spPr>
@@ -40850,7 +40850,7 @@
           <p:cNvPr id="8" name="">
             <a:extLst xmlns:a="http://schemas.openxmlformats.org/drawingml/2006/main">
               <a:ext uri="{FF2B5EF4-FFF2-40B4-BE49-F238E27FC236}">
-                <a16:creationId xmlns:a16="http://schemas.microsoft.com/office/drawing/2014/main" id="{A536199A-D513-4388-867A-8A1C777FA757}"/>
+                <a16:creationId xmlns:a16="http://schemas.microsoft.com/office/drawing/2014/main" id="{91174747-62FF-4FB3-9D8E-3948EE697644}"/>
               </a:ext>
             </a:extLst>
           </p:cNvPr>
@@ -40860,7 +40860,7 @@
           <p:nvPr/>
         </p:nvPicPr>
         <p:blipFill>
-          <a:blip xmlns:r="http://schemas.openxmlformats.org/officeDocument/2006/relationships" xmlns:a="http://schemas.openxmlformats.org/drawingml/2006/main" r:embed="R511f047e1874418e"/>
+          <a:blip xmlns:r="http://schemas.openxmlformats.org/officeDocument/2006/relationships" xmlns:a="http://schemas.openxmlformats.org/drawingml/2006/main" r:embed="Racdd7c61221544c2"/>
           <a:stretch xmlns:a="http://schemas.openxmlformats.org/drawingml/2006/main"/>
         </p:blipFill>
         <p:spPr>
@@ -41044,7 +41044,7 @@
           <p:cNvPr id="10" name="">
             <a:extLst xmlns:a="http://schemas.openxmlformats.org/drawingml/2006/main">
               <a:ext uri="{FF2B5EF4-FFF2-40B4-BE49-F238E27FC236}">
-                <a16:creationId xmlns:a16="http://schemas.microsoft.com/office/drawing/2014/main" id="{13126ED0-8C47-4C22-B9AB-7AFC7D93E906}"/>
+                <a16:creationId xmlns:a16="http://schemas.microsoft.com/office/drawing/2014/main" id="{C0DD7F16-45AA-46FF-82C4-9757413CEAE6}"/>
               </a:ext>
             </a:extLst>
           </p:cNvPr>
@@ -41054,7 +41054,7 @@
           <p:nvPr/>
         </p:nvPicPr>
         <p:blipFill>
-          <a:blip xmlns:r="http://schemas.openxmlformats.org/officeDocument/2006/relationships" xmlns:a="http://schemas.openxmlformats.org/drawingml/2006/main" r:embed="R8fdfaed146c74edb"/>
+          <a:blip xmlns:r="http://schemas.openxmlformats.org/officeDocument/2006/relationships" xmlns:a="http://schemas.openxmlformats.org/drawingml/2006/main" r:embed="Ree1d9bf48e3d49f8"/>
           <a:stretch xmlns:a="http://schemas.openxmlformats.org/drawingml/2006/main"/>
         </p:blipFill>
         <p:spPr>
@@ -41238,7 +41238,7 @@
           <p:cNvPr id="12" name="">
             <a:extLst xmlns:a="http://schemas.openxmlformats.org/drawingml/2006/main">
               <a:ext uri="{FF2B5EF4-FFF2-40B4-BE49-F238E27FC236}">
-                <a16:creationId xmlns:a16="http://schemas.microsoft.com/office/drawing/2014/main" id="{335141B5-461F-4500-9D0D-51BF1566312D}"/>
+                <a16:creationId xmlns:a16="http://schemas.microsoft.com/office/drawing/2014/main" id="{92BD3B27-1F19-4578-BD20-C3EAA905DF54}"/>
               </a:ext>
             </a:extLst>
           </p:cNvPr>
@@ -41248,7 +41248,7 @@
           <p:nvPr/>
         </p:nvPicPr>
         <p:blipFill>
-          <a:blip xmlns:r="http://schemas.openxmlformats.org/officeDocument/2006/relationships" xmlns:a="http://schemas.openxmlformats.org/drawingml/2006/main" r:embed="R6afbce61c86d4b9f"/>
+          <a:blip xmlns:r="http://schemas.openxmlformats.org/officeDocument/2006/relationships" xmlns:a="http://schemas.openxmlformats.org/drawingml/2006/main" r:embed="R9791202fd7b84fcc"/>
           <a:stretch xmlns:a="http://schemas.openxmlformats.org/drawingml/2006/main"/>
         </p:blipFill>
         <p:spPr>
@@ -41432,7 +41432,7 @@
           <p:cNvPr id="14" name="">
             <a:extLst xmlns:a="http://schemas.openxmlformats.org/drawingml/2006/main">
               <a:ext uri="{FF2B5EF4-FFF2-40B4-BE49-F238E27FC236}">
-                <a16:creationId xmlns:a16="http://schemas.microsoft.com/office/drawing/2014/main" id="{25D7885C-4A4C-4510-BD18-E57602F3E931}"/>
+                <a16:creationId xmlns:a16="http://schemas.microsoft.com/office/drawing/2014/main" id="{8522B5AA-A6AE-4082-9B2F-924E3B6FD137}"/>
               </a:ext>
             </a:extLst>
           </p:cNvPr>
@@ -41442,7 +41442,7 @@
           <p:nvPr/>
         </p:nvPicPr>
         <p:blipFill>
-          <a:blip xmlns:r="http://schemas.openxmlformats.org/officeDocument/2006/relationships" xmlns:a="http://schemas.openxmlformats.org/drawingml/2006/main" r:embed="R9ffd963a9a944a22"/>
+          <a:blip xmlns:r="http://schemas.openxmlformats.org/officeDocument/2006/relationships" xmlns:a="http://schemas.openxmlformats.org/drawingml/2006/main" r:embed="Refa2e3763e664d1b"/>
           <a:stretch xmlns:a="http://schemas.openxmlformats.org/drawingml/2006/main"/>
         </p:blipFill>
         <p:spPr>
@@ -41655,7 +41655,7 @@
           <p:cNvPr id="11" name="">
             <a:extLst xmlns:a="http://schemas.openxmlformats.org/drawingml/2006/main">
               <a:ext uri="{FF2B5EF4-FFF2-40B4-BE49-F238E27FC236}">
-                <a16:creationId xmlns:a16="http://schemas.microsoft.com/office/drawing/2014/main" id="{E3F2BF44-1131-40BF-9902-F20B1DCAD645}"/>
+                <a16:creationId xmlns:a16="http://schemas.microsoft.com/office/drawing/2014/main" id="{AF0FC4E6-EC20-4FAC-B425-7F7DB1A04505}"/>
               </a:ext>
             </a:extLst>
           </p:cNvPr>
@@ -41686,7 +41686,7 @@
           <p:cNvPr id="10" name="">
             <a:extLst xmlns:a="http://schemas.openxmlformats.org/drawingml/2006/main">
               <a:ext uri="{FF2B5EF4-FFF2-40B4-BE49-F238E27FC236}">
-                <a16:creationId xmlns:a16="http://schemas.microsoft.com/office/drawing/2014/main" id="{0D2BB147-3AC8-4B1B-84B8-6E99130D9D07}"/>
+                <a16:creationId xmlns:a16="http://schemas.microsoft.com/office/drawing/2014/main" id="{41F3A165-0564-4FA4-8D9B-FE7C8CF0C3BC}"/>
               </a:ext>
             </a:extLst>
           </p:cNvPr>
@@ -47515,7 +47515,7 @@
           <p:cNvPr id="7" name="">
             <a:extLst xmlns:a="http://schemas.openxmlformats.org/drawingml/2006/main">
               <a:ext uri="{FF2B5EF4-FFF2-40B4-BE49-F238E27FC236}">
-                <a16:creationId xmlns:a16="http://schemas.microsoft.com/office/drawing/2014/main" id="{592868B8-18A0-47C1-A2B2-FA2C4EC86847}"/>
+                <a16:creationId xmlns:a16="http://schemas.microsoft.com/office/drawing/2014/main" id="{B163E8A3-3620-4753-AD1E-FBAC4BEB72E2}"/>
               </a:ext>
             </a:extLst>
           </p:cNvPr>
@@ -47525,7 +47525,7 @@
           <p:nvPr/>
         </p:nvPicPr>
         <p:blipFill>
-          <a:blip xmlns:r="http://schemas.openxmlformats.org/officeDocument/2006/relationships" xmlns:a="http://schemas.openxmlformats.org/drawingml/2006/main" r:embed="R7769198ae4f94d88"/>
+          <a:blip xmlns:r="http://schemas.openxmlformats.org/officeDocument/2006/relationships" xmlns:a="http://schemas.openxmlformats.org/drawingml/2006/main" r:embed="R73ca288fa6de4eda"/>
           <a:srcRect xmlns:a="http://schemas.openxmlformats.org/drawingml/2006/main" l="13000" t="37500" r="13000" b="33500"/>
           <a:stretch xmlns:a="http://schemas.openxmlformats.org/drawingml/2006/main"/>
         </p:blipFill>
@@ -47739,7 +47739,7 @@
           <p:cNvPr id="7" name="">
             <a:extLst xmlns:a="http://schemas.openxmlformats.org/drawingml/2006/main">
               <a:ext uri="{FF2B5EF4-FFF2-40B4-BE49-F238E27FC236}">
-                <a16:creationId xmlns:a16="http://schemas.microsoft.com/office/drawing/2014/main" id="{B6F2FA01-6D0E-432D-812C-78BF759EFDCB}"/>
+                <a16:creationId xmlns:a16="http://schemas.microsoft.com/office/drawing/2014/main" id="{7C3DA347-1CA0-4D23-87A2-EC2DF3BC85A5}"/>
               </a:ext>
             </a:extLst>
           </p:cNvPr>

</xml_diff>

<commit_message>
Polish final documentation and remove rehearsal-only material
</commit_message>
<xml_diff>
--- a/submission/Project1_Presentation.pptx
+++ b/submission/Project1_Presentation.pptx
@@ -2,40 +2,40 @@
 <file path=ppt/presentation.xml><?xml version="1.0" encoding="utf-8"?>
 <p:presentation xmlns:p="http://schemas.openxmlformats.org/presentationml/2006/main">
   <p:sldMasterIdLst>
-    <p:sldMasterId xmlns:r="http://schemas.openxmlformats.org/officeDocument/2006/relationships" id="2147483648" r:id="R2f6c0666d9774630"/>
+    <p:sldMasterId xmlns:r="http://schemas.openxmlformats.org/officeDocument/2006/relationships" id="2147483648" r:id="R24ecff7215764f2d"/>
   </p:sldMasterIdLst>
   <p:notesMasterIdLst>
-    <p:notesMasterId xmlns:r="http://schemas.openxmlformats.org/officeDocument/2006/relationships" r:id="R76c1ccfbee2240b1"/>
+    <p:notesMasterId xmlns:r="http://schemas.openxmlformats.org/officeDocument/2006/relationships" r:id="R910c707372414a8a"/>
   </p:notesMasterIdLst>
   <p:sldIdLst>
-    <p:sldId xmlns:r="http://schemas.openxmlformats.org/officeDocument/2006/relationships" id="256" r:id="Rc262af832e584845"/>
-    <p:sldId xmlns:r="http://schemas.openxmlformats.org/officeDocument/2006/relationships" id="257" r:id="R67861ceee6274b7a"/>
-    <p:sldId xmlns:r="http://schemas.openxmlformats.org/officeDocument/2006/relationships" id="258" r:id="Ra1d497e917f14f50"/>
-    <p:sldId xmlns:r="http://schemas.openxmlformats.org/officeDocument/2006/relationships" id="259" r:id="R8106b5e208284730"/>
-    <p:sldId xmlns:r="http://schemas.openxmlformats.org/officeDocument/2006/relationships" id="260" r:id="R49e4d12a89a44d9e"/>
-    <p:sldId xmlns:r="http://schemas.openxmlformats.org/officeDocument/2006/relationships" id="261" r:id="R79ea75d7f20c4397"/>
-    <p:sldId xmlns:r="http://schemas.openxmlformats.org/officeDocument/2006/relationships" id="262" r:id="Rde0153c993d04c61"/>
-    <p:sldId xmlns:r="http://schemas.openxmlformats.org/officeDocument/2006/relationships" id="263" r:id="Rbdf55c726bf44a2e"/>
-    <p:sldId xmlns:r="http://schemas.openxmlformats.org/officeDocument/2006/relationships" id="264" r:id="R6f6cdcb2c19941ab"/>
-    <p:sldId xmlns:r="http://schemas.openxmlformats.org/officeDocument/2006/relationships" id="265" r:id="Refebaea549eb4473"/>
-    <p:sldId xmlns:r="http://schemas.openxmlformats.org/officeDocument/2006/relationships" id="266" r:id="R495b125ad07041d3"/>
-    <p:sldId xmlns:r="http://schemas.openxmlformats.org/officeDocument/2006/relationships" id="267" r:id="R632e0aed7b004077"/>
-    <p:sldId xmlns:r="http://schemas.openxmlformats.org/officeDocument/2006/relationships" id="268" r:id="Rb19b5e44a97c409d"/>
-    <p:sldId xmlns:r="http://schemas.openxmlformats.org/officeDocument/2006/relationships" id="269" r:id="R605ff5c97d4b4b7b"/>
-    <p:sldId xmlns:r="http://schemas.openxmlformats.org/officeDocument/2006/relationships" id="270" r:id="R2c4260df3e4c4a75"/>
-    <p:sldId xmlns:r="http://schemas.openxmlformats.org/officeDocument/2006/relationships" id="271" r:id="Rddc7ab21a1034163"/>
-    <p:sldId xmlns:r="http://schemas.openxmlformats.org/officeDocument/2006/relationships" id="272" r:id="R1e2b3acdf4ae4494"/>
-    <p:sldId xmlns:r="http://schemas.openxmlformats.org/officeDocument/2006/relationships" id="273" r:id="R7acda321335143e2"/>
-    <p:sldId xmlns:r="http://schemas.openxmlformats.org/officeDocument/2006/relationships" id="274" r:id="Rd6186a0afd9847ce"/>
-    <p:sldId xmlns:r="http://schemas.openxmlformats.org/officeDocument/2006/relationships" id="275" r:id="R93bc79826cb04124"/>
-    <p:sldId xmlns:r="http://schemas.openxmlformats.org/officeDocument/2006/relationships" id="276" r:id="R38c0b5f053b541c9"/>
-    <p:sldId xmlns:r="http://schemas.openxmlformats.org/officeDocument/2006/relationships" id="277" r:id="R931d052cf3d94c12"/>
-    <p:sldId xmlns:r="http://schemas.openxmlformats.org/officeDocument/2006/relationships" id="278" r:id="Rd5846a9e7e0c4d05"/>
-    <p:sldId xmlns:r="http://schemas.openxmlformats.org/officeDocument/2006/relationships" id="279" r:id="Rc5f977b28927443b"/>
-    <p:sldId xmlns:r="http://schemas.openxmlformats.org/officeDocument/2006/relationships" id="280" r:id="Rc4b78e7c13784546"/>
-    <p:sldId xmlns:r="http://schemas.openxmlformats.org/officeDocument/2006/relationships" id="281" r:id="Rbe2d993f964548a3"/>
-    <p:sldId xmlns:r="http://schemas.openxmlformats.org/officeDocument/2006/relationships" id="282" r:id="R9df815d6892e4550"/>
-    <p:sldId xmlns:r="http://schemas.openxmlformats.org/officeDocument/2006/relationships" id="283" r:id="Ra044dc48d5d44db4"/>
+    <p:sldId xmlns:r="http://schemas.openxmlformats.org/officeDocument/2006/relationships" id="256" r:id="Re34a97aee5dc42e2"/>
+    <p:sldId xmlns:r="http://schemas.openxmlformats.org/officeDocument/2006/relationships" id="257" r:id="R139774a8ed84419c"/>
+    <p:sldId xmlns:r="http://schemas.openxmlformats.org/officeDocument/2006/relationships" id="258" r:id="R718b6f965395417f"/>
+    <p:sldId xmlns:r="http://schemas.openxmlformats.org/officeDocument/2006/relationships" id="259" r:id="R5bfe4f6a8c024909"/>
+    <p:sldId xmlns:r="http://schemas.openxmlformats.org/officeDocument/2006/relationships" id="260" r:id="Re8133df7bcc34b18"/>
+    <p:sldId xmlns:r="http://schemas.openxmlformats.org/officeDocument/2006/relationships" id="261" r:id="Rf0b5da71992a4ae1"/>
+    <p:sldId xmlns:r="http://schemas.openxmlformats.org/officeDocument/2006/relationships" id="262" r:id="Ra3a35cb5cf3f4849"/>
+    <p:sldId xmlns:r="http://schemas.openxmlformats.org/officeDocument/2006/relationships" id="263" r:id="Rce58689e3b0b4738"/>
+    <p:sldId xmlns:r="http://schemas.openxmlformats.org/officeDocument/2006/relationships" id="264" r:id="R3fd8850783924bf3"/>
+    <p:sldId xmlns:r="http://schemas.openxmlformats.org/officeDocument/2006/relationships" id="265" r:id="R5f2ccd72cf994852"/>
+    <p:sldId xmlns:r="http://schemas.openxmlformats.org/officeDocument/2006/relationships" id="266" r:id="R43be82dd71d84575"/>
+    <p:sldId xmlns:r="http://schemas.openxmlformats.org/officeDocument/2006/relationships" id="267" r:id="Re59e87e69e44460c"/>
+    <p:sldId xmlns:r="http://schemas.openxmlformats.org/officeDocument/2006/relationships" id="268" r:id="R1921922747df4fbf"/>
+    <p:sldId xmlns:r="http://schemas.openxmlformats.org/officeDocument/2006/relationships" id="269" r:id="R9611734b926a4e91"/>
+    <p:sldId xmlns:r="http://schemas.openxmlformats.org/officeDocument/2006/relationships" id="270" r:id="R68e1afc839694519"/>
+    <p:sldId xmlns:r="http://schemas.openxmlformats.org/officeDocument/2006/relationships" id="271" r:id="Re4cda52b9b304b28"/>
+    <p:sldId xmlns:r="http://schemas.openxmlformats.org/officeDocument/2006/relationships" id="272" r:id="R894d59db03304421"/>
+    <p:sldId xmlns:r="http://schemas.openxmlformats.org/officeDocument/2006/relationships" id="273" r:id="Rf51531211a6c440f"/>
+    <p:sldId xmlns:r="http://schemas.openxmlformats.org/officeDocument/2006/relationships" id="274" r:id="Ra2b1548c44164785"/>
+    <p:sldId xmlns:r="http://schemas.openxmlformats.org/officeDocument/2006/relationships" id="275" r:id="R3e97851a09a84df5"/>
+    <p:sldId xmlns:r="http://schemas.openxmlformats.org/officeDocument/2006/relationships" id="276" r:id="R27b157bed4334cdd"/>
+    <p:sldId xmlns:r="http://schemas.openxmlformats.org/officeDocument/2006/relationships" id="277" r:id="R23e6ba5c6a894e42"/>
+    <p:sldId xmlns:r="http://schemas.openxmlformats.org/officeDocument/2006/relationships" id="278" r:id="Rc37183d777af4198"/>
+    <p:sldId xmlns:r="http://schemas.openxmlformats.org/officeDocument/2006/relationships" id="279" r:id="R453b45b470e74638"/>
+    <p:sldId xmlns:r="http://schemas.openxmlformats.org/officeDocument/2006/relationships" id="280" r:id="Rdd3a74b4677f49ed"/>
+    <p:sldId xmlns:r="http://schemas.openxmlformats.org/officeDocument/2006/relationships" id="281" r:id="Rbad76e1f129c4e1f"/>
+    <p:sldId xmlns:r="http://schemas.openxmlformats.org/officeDocument/2006/relationships" id="282" r:id="R10f770cdbfc94d4e"/>
+    <p:sldId xmlns:r="http://schemas.openxmlformats.org/officeDocument/2006/relationships" id="283" r:id="R184c390874ac4e44"/>
   </p:sldIdLst>
   <p:sldSz cx="12192000" cy="6858000"/>
   <p:notesSz cx="6858000" cy="9144000"/>
@@ -474,7 +474,7 @@
           </a:p>
           <a:p xmlns:a="http://schemas.openxmlformats.org/drawingml/2006/main">
             <a:r>
-              <a:t>Read aloud:</a:t>
+              <a:t/>
             </a:r>
           </a:p>
           <a:p xmlns:a="http://schemas.openxmlformats.org/drawingml/2006/main">
@@ -509,42 +509,17 @@
           </a:p>
           <a:p xmlns:a="http://schemas.openxmlformats.org/drawingml/2006/main">
             <a:r>
-              <a:t>Visuals support this narration. Code excerpts are actual source with whitespace wrapped for slide readability. Screenshots are real release captures with fictional examples.</a:t>
-            </a:r>
-          </a:p>
-          <a:p xmlns:a="http://schemas.openxmlformats.org/drawingml/2006/main">
-            <a:r>
               <a:t>Questions: R1.</a:t>
             </a:r>
           </a:p>
           <a:p xmlns:a="http://schemas.openxmlformats.org/drawingml/2006/main">
             <a:r>
+              <a:t/>
+            </a:r>
+          </a:p>
+          <a:p xmlns:a="http://schemas.openxmlformats.org/drawingml/2006/main">
+            <a:r>
               <a:t>Sources: https://github.com/Omswaroopreddyudumula/ajxom-budget-bites; ARCHITECTURE.md; AI_FEATURE.md; docs/CONTRIBUTIONS.md; docs/TEST_RESULTS.md; final-prefixed evidence logs.</a:t>
-            </a:r>
-          </a:p>
-          <a:p xmlns:a="http://schemas.openxmlformats.org/drawingml/2006/main">
-            <a:r>
-              <a:t>Visual/code sources: /Users/omswaroopudumula/Documents/Codex/2026-10-14/referenced-chatgpt-conversation-this-is-an/work/visual-presentation/assets/meal-save.png; /Users/omswaroopudumula/Documents/Codex/2026-10-14/referenced-chatgpt-conversation-this-is-an/work/visual-presentation/assets/dark-settings.png.</a:t>
-            </a:r>
-          </a:p>
-          <a:p xmlns:a="http://schemas.openxmlformats.org/drawingml/2006/main">
-            <a:r>
-              <a:t>Frame provenance is recorded in the private presentation build assets.</a:t>
-            </a:r>
-          </a:p>
-          <a:p xmlns:a="http://schemas.openxmlformats.org/drawingml/2006/main">
-            <a:r>
-              <a:t>Rehearse the full recording with the live demo within 20–25 minutes.</a:t>
-            </a:r>
-          </a:p>
-          <a:p xmlns:a="http://schemas.openxmlformats.org/drawingml/2006/main">
-            <a:r>
-              <a:t/>
-            </a:r>
-          </a:p>
-          <a:p xmlns:a="http://schemas.openxmlformats.org/drawingml/2006/main">
-            <a:r>
-              <a:t>Speaker plan: Om presents slides 1–4 and 14–16 (about 4–5 minutes total). A.J. presents slides 5–13 and 17–28 and narrates the full app demo. Presentation leadership does not change code authorship.</a:t>
             </a:r>
           </a:p>
         </p:txBody>
@@ -619,22 +594,12 @@
           </a:p>
           <a:p xmlns:a="http://schemas.openxmlformats.org/drawingml/2006/main">
             <a:r>
-              <a:t>Read aloud:</a:t>
-            </a:r>
-          </a:p>
-          <a:p xmlns:a="http://schemas.openxmlformats.org/drawingml/2006/main">
-            <a:r>
-              <a:t>Create inserts a validated Meal and lets SQLite generate its ID. Read retrieves saved rows in a consistent order and converts them into Meal objects. Update requires an existing ID and applies changes to the row whose ID matches that value.</a:t>
-            </a:r>
-          </a:p>
-          <a:p xmlns:a="http://schemas.openxmlformats.org/drawingml/2006/main">
-            <a:r>
               <a:t/>
             </a:r>
           </a:p>
           <a:p xmlns:a="http://schemas.openxmlformats.org/drawingml/2006/main">
             <a:r>
-              <a:t>Delete also uses the database ID. Before deleting a meal, the data layer checks for linked purchases. The final application provides the same independent CRUD operations for PurchaseLog, allowing users to add a receipt, view it, correct its amount or remove it after confirmation.</a:t>
+              <a:t>Questions: D1.</a:t>
             </a:r>
           </a:p>
           <a:p xmlns:a="http://schemas.openxmlformats.org/drawingml/2006/main">
@@ -644,52 +609,7 @@
           </a:p>
           <a:p xmlns:a="http://schemas.openxmlformats.org/drawingml/2006/main">
             <a:r>
-              <a:t>Queries use bound arguments for IDs. Refreshing the saved lists after a successful change keeps the catalog, purchase log and totals aligned with current database rows.</a:t>
-            </a:r>
-          </a:p>
-          <a:p xmlns:a="http://schemas.openxmlformats.org/drawingml/2006/main">
-            <a:r>
-              <a:t/>
-            </a:r>
-          </a:p>
-          <a:p xmlns:a="http://schemas.openxmlformats.org/drawingml/2006/main">
-            <a:r>
-              <a:t>Visuals support this narration. Code excerpts are actual source with whitespace wrapped for slide readability. Screenshots are real release captures with fictional examples.</a:t>
-            </a:r>
-          </a:p>
-          <a:p xmlns:a="http://schemas.openxmlformats.org/drawingml/2006/main">
-            <a:r>
-              <a:t>Questions: D1.</a:t>
-            </a:r>
-          </a:p>
-          <a:p xmlns:a="http://schemas.openxmlformats.org/drawingml/2006/main">
-            <a:r>
               <a:t>Sources: https://github.com/Omswaroopreddyudumula/ajxom-budget-bites; ARCHITECTURE.md; AI_FEATURE.md; docs/CONTRIBUTIONS.md; docs/TEST_RESULTS.md; final-prefixed evidence logs.</a:t>
-            </a:r>
-          </a:p>
-          <a:p xmlns:a="http://schemas.openxmlformats.org/drawingml/2006/main">
-            <a:r>
-              <a:t>Visual/code sources: lib/data/meal_database.dart.</a:t>
-            </a:r>
-          </a:p>
-          <a:p xmlns:a="http://schemas.openxmlformats.org/drawingml/2006/main">
-            <a:r>
-              <a:t>Frame provenance is recorded in the private presentation build assets.</a:t>
-            </a:r>
-          </a:p>
-          <a:p xmlns:a="http://schemas.openxmlformats.org/drawingml/2006/main">
-            <a:r>
-              <a:t>Rehearse the full recording with the live demo within 20–25 minutes.</a:t>
-            </a:r>
-          </a:p>
-          <a:p xmlns:a="http://schemas.openxmlformats.org/drawingml/2006/main">
-            <a:r>
-              <a:t/>
-            </a:r>
-          </a:p>
-          <a:p xmlns:a="http://schemas.openxmlformats.org/drawingml/2006/main">
-            <a:r>
-              <a:t>Speaker plan: Om presents slides 1–4 and 14–16 (about 4–5 minutes total). A.J. presents slides 5–13 and 17–28 and narrates the full app demo. Presentation leadership does not change code authorship.</a:t>
             </a:r>
           </a:p>
         </p:txBody>
@@ -764,7 +684,7 @@
           </a:p>
           <a:p xmlns:a="http://schemas.openxmlformats.org/drawingml/2006/main">
             <a:r>
-              <a:t>Read aloud:</a:t>
+              <a:t/>
             </a:r>
           </a:p>
           <a:p xmlns:a="http://schemas.openxmlformats.org/drawingml/2006/main">
@@ -799,42 +719,17 @@
           </a:p>
           <a:p xmlns:a="http://schemas.openxmlformats.org/drawingml/2006/main">
             <a:r>
-              <a:t>Visuals support this narration. Code excerpts are actual source with whitespace wrapped for slide readability. Screenshots are real release captures with fictional examples.</a:t>
-            </a:r>
-          </a:p>
-          <a:p xmlns:a="http://schemas.openxmlformats.org/drawingml/2006/main">
-            <a:r>
               <a:t>Questions: D1, T2.</a:t>
             </a:r>
           </a:p>
           <a:p xmlns:a="http://schemas.openxmlformats.org/drawingml/2006/main">
             <a:r>
+              <a:t/>
+            </a:r>
+          </a:p>
+          <a:p xmlns:a="http://schemas.openxmlformats.org/drawingml/2006/main">
+            <a:r>
               <a:t>Sources: https://github.com/Omswaroopreddyudumula/ajxom-budget-bites; ARCHITECTURE.md; AI_FEATURE.md; docs/CONTRIBUTIONS.md; docs/TEST_RESULTS.md; final-prefixed evidence logs.</a:t>
-            </a:r>
-          </a:p>
-          <a:p xmlns:a="http://schemas.openxmlformats.org/drawingml/2006/main">
-            <a:r>
-              <a:t>Visual/code sources: lib/data/meal_database.dart.</a:t>
-            </a:r>
-          </a:p>
-          <a:p xmlns:a="http://schemas.openxmlformats.org/drawingml/2006/main">
-            <a:r>
-              <a:t>Frame provenance is recorded in the private presentation build assets.</a:t>
-            </a:r>
-          </a:p>
-          <a:p xmlns:a="http://schemas.openxmlformats.org/drawingml/2006/main">
-            <a:r>
-              <a:t>Rehearse the full recording with the live demo within 20–25 minutes.</a:t>
-            </a:r>
-          </a:p>
-          <a:p xmlns:a="http://schemas.openxmlformats.org/drawingml/2006/main">
-            <a:r>
-              <a:t/>
-            </a:r>
-          </a:p>
-          <a:p xmlns:a="http://schemas.openxmlformats.org/drawingml/2006/main">
-            <a:r>
-              <a:t>Speaker plan: Om presents slides 1–4 and 14–16 (about 4–5 minutes total). A.J. presents slides 5–13 and 17–28 and narrates the full app demo. Presentation leadership does not change code authorship.</a:t>
             </a:r>
           </a:p>
         </p:txBody>
@@ -909,22 +804,12 @@
           </a:p>
           <a:p xmlns:a="http://schemas.openxmlformats.org/drawingml/2006/main">
             <a:r>
-              <a:t>Read aloud:</a:t>
-            </a:r>
-          </a:p>
-          <a:p xmlns:a="http://schemas.openxmlformats.org/drawingml/2006/main">
-            <a:r>
-              <a:t>Repeated taps or a retried operation should not create duplicate receipts. The final save path uses a stable token for one purchase draft. Inside a transaction, it looks for an existing receipt with that token and returns the existing ID when one is already present.</a:t>
-            </a:r>
-          </a:p>
-          <a:p xmlns:a="http://schemas.openxmlformats.org/drawingml/2006/main">
-            <a:r>
               <a:t/>
             </a:r>
           </a:p>
           <a:p xmlns:a="http://schemas.openxmlformats.org/drawingml/2006/main">
             <a:r>
-              <a:t>A unique constraint protects the token. Each deliberate new purchase receives a new token, while the frontend disables Save during a pending write.</a:t>
+              <a:t>Questions: T2, D1, R1.</a:t>
             </a:r>
           </a:p>
           <a:p xmlns:a="http://schemas.openxmlformats.org/drawingml/2006/main">
@@ -934,52 +819,7 @@
           </a:p>
           <a:p xmlns:a="http://schemas.openxmlformats.org/drawingml/2006/main">
             <a:r>
-              <a:t>My original History page supplied the Card and ListTile foundation. The integrated version now displays child purchase records and passes their IDs to the appropriate actions.</a:t>
-            </a:r>
-          </a:p>
-          <a:p xmlns:a="http://schemas.openxmlformats.org/drawingml/2006/main">
-            <a:r>
-              <a:t/>
-            </a:r>
-          </a:p>
-          <a:p xmlns:a="http://schemas.openxmlformats.org/drawingml/2006/main">
-            <a:r>
-              <a:t>Visuals support this narration. Code excerpts are actual source with whitespace wrapped for slide readability. Screenshots are real release captures with fictional examples.</a:t>
-            </a:r>
-          </a:p>
-          <a:p xmlns:a="http://schemas.openxmlformats.org/drawingml/2006/main">
-            <a:r>
-              <a:t>Questions: T2, D1, R1.</a:t>
-            </a:r>
-          </a:p>
-          <a:p xmlns:a="http://schemas.openxmlformats.org/drawingml/2006/main">
-            <a:r>
               <a:t>Sources: https://github.com/Omswaroopreddyudumula/ajxom-budget-bites; ARCHITECTURE.md; AI_FEATURE.md; docs/CONTRIBUTIONS.md; docs/TEST_RESULTS.md; final-prefixed evidence logs.</a:t>
-            </a:r>
-          </a:p>
-          <a:p xmlns:a="http://schemas.openxmlformats.org/drawingml/2006/main">
-            <a:r>
-              <a:t>Visual/code sources: lib/data/meal_database.dart; lib/screens/purchase_editor.dart.</a:t>
-            </a:r>
-          </a:p>
-          <a:p xmlns:a="http://schemas.openxmlformats.org/drawingml/2006/main">
-            <a:r>
-              <a:t>Frame provenance is recorded in the private presentation build assets.</a:t>
-            </a:r>
-          </a:p>
-          <a:p xmlns:a="http://schemas.openxmlformats.org/drawingml/2006/main">
-            <a:r>
-              <a:t>Rehearse the full recording with the live demo within 20–25 minutes.</a:t>
-            </a:r>
-          </a:p>
-          <a:p xmlns:a="http://schemas.openxmlformats.org/drawingml/2006/main">
-            <a:r>
-              <a:t/>
-            </a:r>
-          </a:p>
-          <a:p xmlns:a="http://schemas.openxmlformats.org/drawingml/2006/main">
-            <a:r>
-              <a:t>Speaker plan: Om presents slides 1–4 and 14–16 (about 4–5 minutes total). A.J. presents slides 5–13 and 17–28 and narrates the full app demo. Presentation leadership does not change code authorship.</a:t>
             </a:r>
           </a:p>
         </p:txBody>
@@ -1054,22 +894,12 @@
           </a:p>
           <a:p xmlns:a="http://schemas.openxmlformats.org/drawingml/2006/main">
             <a:r>
-              <a:t>Read aloud:</a:t>
-            </a:r>
-          </a:p>
-          <a:p xmlns:a="http://schemas.openxmlformats.org/drawingml/2006/main">
-            <a:r>
-              <a:t>The transaction checks the draft token before inserting. Retrying the same draft returns its existing receipt ID. A new purchase receives a new token.</a:t>
-            </a:r>
-          </a:p>
-          <a:p xmlns:a="http://schemas.openxmlformats.org/drawingml/2006/main">
-            <a:r>
               <a:t/>
             </a:r>
           </a:p>
           <a:p xmlns:a="http://schemas.openxmlformats.org/drawingml/2006/main">
             <a:r>
-              <a:t>Om will now explain how the frontend connects these backend operations to the student's workflow.</a:t>
+              <a:t>The transaction checks the draft token before inserting. Retrying the same draft returns its existing receipt ID. A new purchase receives a new token. Om will now explain how the frontend connects these backend operations to the student's workflow.</a:t>
             </a:r>
           </a:p>
           <a:p xmlns:a="http://schemas.openxmlformats.org/drawingml/2006/main">
@@ -1079,42 +909,17 @@
           </a:p>
           <a:p xmlns:a="http://schemas.openxmlformats.org/drawingml/2006/main">
             <a:r>
-              <a:t>Visuals support this narration. Code excerpts are actual source with whitespace wrapped for slide readability. Screenshots are real release captures with fictional examples.</a:t>
-            </a:r>
-          </a:p>
-          <a:p xmlns:a="http://schemas.openxmlformats.org/drawingml/2006/main">
-            <a:r>
               <a:t>Questions: T2, D1.</a:t>
             </a:r>
           </a:p>
           <a:p xmlns:a="http://schemas.openxmlformats.org/drawingml/2006/main">
             <a:r>
+              <a:t/>
+            </a:r>
+          </a:p>
+          <a:p xmlns:a="http://schemas.openxmlformats.org/drawingml/2006/main">
+            <a:r>
               <a:t>Sources: https://github.com/Omswaroopreddyudumula/ajxom-budget-bites; ARCHITECTURE.md; AI_FEATURE.md; docs/CONTRIBUTIONS.md; docs/TEST_RESULTS.md; final-prefixed evidence logs.</a:t>
-            </a:r>
-          </a:p>
-          <a:p xmlns:a="http://schemas.openxmlformats.org/drawingml/2006/main">
-            <a:r>
-              <a:t>Visual/code sources: lib/data/meal_database.dart.</a:t>
-            </a:r>
-          </a:p>
-          <a:p xmlns:a="http://schemas.openxmlformats.org/drawingml/2006/main">
-            <a:r>
-              <a:t>Frame provenance is recorded in the private presentation build assets.</a:t>
-            </a:r>
-          </a:p>
-          <a:p xmlns:a="http://schemas.openxmlformats.org/drawingml/2006/main">
-            <a:r>
-              <a:t>Rehearse the full recording with the live demo within 20–25 minutes.</a:t>
-            </a:r>
-          </a:p>
-          <a:p xmlns:a="http://schemas.openxmlformats.org/drawingml/2006/main">
-            <a:r>
-              <a:t/>
-            </a:r>
-          </a:p>
-          <a:p xmlns:a="http://schemas.openxmlformats.org/drawingml/2006/main">
-            <a:r>
-              <a:t>Speaker plan: Om presents slides 1–4 and 14–16 (about 4–5 minutes total). A.J. presents slides 5–13 and 17–28 and narrates the full app demo. Presentation leadership does not change code authorship.</a:t>
             </a:r>
           </a:p>
         </p:txBody>
@@ -1189,7 +994,7 @@
           </a:p>
           <a:p xmlns:a="http://schemas.openxmlformats.org/drawingml/2006/main">
             <a:r>
-              <a:t>Read aloud:</a:t>
+              <a:t/>
             </a:r>
           </a:p>
           <a:p xmlns:a="http://schemas.openxmlformats.org/drawingml/2006/main">
@@ -1224,42 +1029,17 @@
           </a:p>
           <a:p xmlns:a="http://schemas.openxmlformats.org/drawingml/2006/main">
             <a:r>
-              <a:t>Visuals support this narration. Code excerpts are actual source with whitespace wrapped for slide readability. Screenshots are real release captures with fictional examples.</a:t>
-            </a:r>
-          </a:p>
-          <a:p xmlns:a="http://schemas.openxmlformats.org/drawingml/2006/main">
-            <a:r>
               <a:t>Questions: I1, R1.</a:t>
             </a:r>
           </a:p>
           <a:p xmlns:a="http://schemas.openxmlformats.org/drawingml/2006/main">
             <a:r>
+              <a:t/>
+            </a:r>
+          </a:p>
+          <a:p xmlns:a="http://schemas.openxmlformats.org/drawingml/2006/main">
+            <a:r>
               <a:t>Sources: https://github.com/Omswaroopreddyudumula/ajxom-budget-bites; ARCHITECTURE.md; AI_FEATURE.md; docs/CONTRIBUTIONS.md; docs/TEST_RESULTS.md; final-prefixed evidence logs.</a:t>
-            </a:r>
-          </a:p>
-          <a:p xmlns:a="http://schemas.openxmlformats.org/drawingml/2006/main">
-            <a:r>
-              <a:t>Visual/code sources: /Users/omswaroopudumula/Documents/Codex/2026-10-14/referenced-chatgpt-conversation-this-is-an/work/visual-presentation/assets/persisted-settings.png.</a:t>
-            </a:r>
-          </a:p>
-          <a:p xmlns:a="http://schemas.openxmlformats.org/drawingml/2006/main">
-            <a:r>
-              <a:t>Frame provenance is recorded in the private presentation build assets.</a:t>
-            </a:r>
-          </a:p>
-          <a:p xmlns:a="http://schemas.openxmlformats.org/drawingml/2006/main">
-            <a:r>
-              <a:t>Rehearse the full recording with the live demo within 20–25 minutes.</a:t>
-            </a:r>
-          </a:p>
-          <a:p xmlns:a="http://schemas.openxmlformats.org/drawingml/2006/main">
-            <a:r>
-              <a:t/>
-            </a:r>
-          </a:p>
-          <a:p xmlns:a="http://schemas.openxmlformats.org/drawingml/2006/main">
-            <a:r>
-              <a:t>Speaker plan: Om presents slides 1–4 and 14–16 (about 4–5 minutes total). A.J. presents slides 5–13 and 17–28 and narrates the full app demo. Presentation leadership does not change code authorship.</a:t>
             </a:r>
           </a:p>
         </p:txBody>
@@ -1334,7 +1114,7 @@
           </a:p>
           <a:p xmlns:a="http://schemas.openxmlformats.org/drawingml/2006/main">
             <a:r>
-              <a:t>Read aloud:</a:t>
+              <a:t/>
             </a:r>
           </a:p>
           <a:p xmlns:a="http://schemas.openxmlformats.org/drawingml/2006/main">
@@ -1369,42 +1149,17 @@
           </a:p>
           <a:p xmlns:a="http://schemas.openxmlformats.org/drawingml/2006/main">
             <a:r>
-              <a:t>Visuals support this narration. Code excerpts are actual source with whitespace wrapped for slide readability. Screenshots are real release captures with fictional examples.</a:t>
-            </a:r>
-          </a:p>
-          <a:p xmlns:a="http://schemas.openxmlformats.org/drawingml/2006/main">
-            <a:r>
               <a:t>Questions: I2, A1, A2.</a:t>
             </a:r>
           </a:p>
           <a:p xmlns:a="http://schemas.openxmlformats.org/drawingml/2006/main">
             <a:r>
+              <a:t/>
+            </a:r>
+          </a:p>
+          <a:p xmlns:a="http://schemas.openxmlformats.org/drawingml/2006/main">
+            <a:r>
               <a:t>Sources: https://github.com/Omswaroopreddyudumula/ajxom-budget-bites; ARCHITECTURE.md; AI_FEATURE.md; docs/CONTRIBUTIONS.md; docs/TEST_RESULTS.md; final-prefixed evidence logs.</a:t>
-            </a:r>
-          </a:p>
-          <a:p xmlns:a="http://schemas.openxmlformats.org/drawingml/2006/main">
-            <a:r>
-              <a:t>Visual/code sources: lib/state/app_store.dart.</a:t>
-            </a:r>
-          </a:p>
-          <a:p xmlns:a="http://schemas.openxmlformats.org/drawingml/2006/main">
-            <a:r>
-              <a:t>Frame provenance is recorded in the private presentation build assets.</a:t>
-            </a:r>
-          </a:p>
-          <a:p xmlns:a="http://schemas.openxmlformats.org/drawingml/2006/main">
-            <a:r>
-              <a:t>Rehearse the full recording with the live demo within 20–25 minutes.</a:t>
-            </a:r>
-          </a:p>
-          <a:p xmlns:a="http://schemas.openxmlformats.org/drawingml/2006/main">
-            <a:r>
-              <a:t/>
-            </a:r>
-          </a:p>
-          <a:p xmlns:a="http://schemas.openxmlformats.org/drawingml/2006/main">
-            <a:r>
-              <a:t>Speaker plan: Om presents slides 1–4 and 14–16 (about 4–5 minutes total). A.J. presents slides 5–13 and 17–28 and narrates the full app demo. Presentation leadership does not change code authorship.</a:t>
             </a:r>
           </a:p>
         </p:txBody>
@@ -1479,7 +1234,7 @@
           </a:p>
           <a:p xmlns:a="http://schemas.openxmlformats.org/drawingml/2006/main">
             <a:r>
-              <a:t>Read aloud:</a:t>
+              <a:t/>
             </a:r>
           </a:p>
           <a:p xmlns:a="http://schemas.openxmlformats.org/drawingml/2006/main">
@@ -1514,7 +1269,7 @@
           </a:p>
           <a:p xmlns:a="http://schemas.openxmlformats.org/drawingml/2006/main">
             <a:r>
-              <a:t>A.J. will continue from here.</a:t>
+              <a:t>Questions: I1, I2, T2.</a:t>
             </a:r>
           </a:p>
           <a:p xmlns:a="http://schemas.openxmlformats.org/drawingml/2006/main">
@@ -1524,42 +1279,7 @@
           </a:p>
           <a:p xmlns:a="http://schemas.openxmlformats.org/drawingml/2006/main">
             <a:r>
-              <a:t>Visuals support this narration. Code excerpts are actual source with whitespace wrapped for slide readability. Screenshots are real release captures with fictional examples.</a:t>
-            </a:r>
-          </a:p>
-          <a:p xmlns:a="http://schemas.openxmlformats.org/drawingml/2006/main">
-            <a:r>
-              <a:t>Questions: I1, I2, T2.</a:t>
-            </a:r>
-          </a:p>
-          <a:p xmlns:a="http://schemas.openxmlformats.org/drawingml/2006/main">
-            <a:r>
               <a:t>Sources: https://github.com/Omswaroopreddyudumula/ajxom-budget-bites; ARCHITECTURE.md; AI_FEATURE.md; docs/CONTRIBUTIONS.md; docs/TEST_RESULTS.md; final-prefixed evidence logs.</a:t>
-            </a:r>
-          </a:p>
-          <a:p xmlns:a="http://schemas.openxmlformats.org/drawingml/2006/main">
-            <a:r>
-              <a:t>Visual/code sources: /Users/omswaroopudumula/Documents/Codex/2026-10-14/referenced-chatgpt-conversation-this-is-an/work/visual-presentation/assets/edit-price.png; /Users/omswaroopudumula/Documents/Codex/2026-10-14/referenced-chatgpt-conversation-this-is-an/work/visual-presentation/assets/new-meal-complete.png.</a:t>
-            </a:r>
-          </a:p>
-          <a:p xmlns:a="http://schemas.openxmlformats.org/drawingml/2006/main">
-            <a:r>
-              <a:t>Frame provenance is recorded in the private presentation build assets.</a:t>
-            </a:r>
-          </a:p>
-          <a:p xmlns:a="http://schemas.openxmlformats.org/drawingml/2006/main">
-            <a:r>
-              <a:t>Rehearse the full recording with the live demo within 20–25 minutes.</a:t>
-            </a:r>
-          </a:p>
-          <a:p xmlns:a="http://schemas.openxmlformats.org/drawingml/2006/main">
-            <a:r>
-              <a:t/>
-            </a:r>
-          </a:p>
-          <a:p xmlns:a="http://schemas.openxmlformats.org/drawingml/2006/main">
-            <a:r>
-              <a:t>Speaker plan: Om presents slides 1–4 and 14–16 (about 4–5 minutes total). A.J. presents slides 5–13 and 17–28 and narrates the full app demo. Presentation leadership does not change code authorship.</a:t>
             </a:r>
           </a:p>
         </p:txBody>
@@ -1634,7 +1354,7 @@
           </a:p>
           <a:p xmlns:a="http://schemas.openxmlformats.org/drawingml/2006/main">
             <a:r>
-              <a:t>Read aloud:</a:t>
+              <a:t/>
             </a:r>
           </a:p>
           <a:p xmlns:a="http://schemas.openxmlformats.org/drawingml/2006/main">
@@ -1669,42 +1389,17 @@
           </a:p>
           <a:p xmlns:a="http://schemas.openxmlformats.org/drawingml/2006/main">
             <a:r>
-              <a:t>Visuals support this narration. Code excerpts are actual source with whitespace wrapped for slide readability. Screenshots are real release captures with fictional examples.</a:t>
-            </a:r>
-          </a:p>
-          <a:p xmlns:a="http://schemas.openxmlformats.org/drawingml/2006/main">
-            <a:r>
               <a:t>Questions: I2, D1, D2.</a:t>
             </a:r>
           </a:p>
           <a:p xmlns:a="http://schemas.openxmlformats.org/drawingml/2006/main">
             <a:r>
+              <a:t/>
+            </a:r>
+          </a:p>
+          <a:p xmlns:a="http://schemas.openxmlformats.org/drawingml/2006/main">
+            <a:r>
               <a:t>Sources: https://github.com/Omswaroopreddyudumula/ajxom-budget-bites; ARCHITECTURE.md; AI_FEATURE.md; docs/CONTRIBUTIONS.md; docs/TEST_RESULTS.md; final-prefixed evidence logs.</a:t>
-            </a:r>
-          </a:p>
-          <a:p xmlns:a="http://schemas.openxmlformats.org/drawingml/2006/main">
-            <a:r>
-              <a:t>Visual/code sources: /Users/omswaroopudumula/Documents/Codex/2026-10-14/referenced-chatgpt-conversation-this-is-an/work/visual-presentation/assets/reset-confirm.png.</a:t>
-            </a:r>
-          </a:p>
-          <a:p xmlns:a="http://schemas.openxmlformats.org/drawingml/2006/main">
-            <a:r>
-              <a:t>Frame provenance is recorded in the private presentation build assets.</a:t>
-            </a:r>
-          </a:p>
-          <a:p xmlns:a="http://schemas.openxmlformats.org/drawingml/2006/main">
-            <a:r>
-              <a:t>Rehearse the full recording with the live demo within 20–25 minutes.</a:t>
-            </a:r>
-          </a:p>
-          <a:p xmlns:a="http://schemas.openxmlformats.org/drawingml/2006/main">
-            <a:r>
-              <a:t/>
-            </a:r>
-          </a:p>
-          <a:p xmlns:a="http://schemas.openxmlformats.org/drawingml/2006/main">
-            <a:r>
-              <a:t>Speaker plan: Om presents slides 1–4 and 14–16 (about 4–5 minutes total). A.J. presents slides 5–13 and 17–28 and narrates the full app demo. Presentation leadership does not change code authorship.</a:t>
             </a:r>
           </a:p>
         </p:txBody>
@@ -1779,57 +1474,22 @@
           </a:p>
           <a:p xmlns:a="http://schemas.openxmlformats.org/drawingml/2006/main">
             <a:r>
-              <a:t>Read aloud:</a:t>
-            </a:r>
-          </a:p>
-          <a:p xmlns:a="http://schemas.openxmlformats.org/drawingml/2006/main">
-            <a:r>
-              <a:t>The same receipt changes from $6.50 to $6.00. The spending total refreshes while the catalog estimate remains separate.</a:t>
-            </a:r>
-          </a:p>
-          <a:p xmlns:a="http://schemas.openxmlformats.org/drawingml/2006/main">
-            <a:r>
               <a:t/>
             </a:r>
           </a:p>
           <a:p xmlns:a="http://schemas.openxmlformats.org/drawingml/2006/main">
             <a:r>
-              <a:t>Visuals support this narration. Code excerpts are actual source with whitespace wrapped for slide readability. Screenshots are real release captures with fictional examples.</a:t>
-            </a:r>
-          </a:p>
-          <a:p xmlns:a="http://schemas.openxmlformats.org/drawingml/2006/main">
-            <a:r>
               <a:t>Questions: D1.</a:t>
             </a:r>
           </a:p>
           <a:p xmlns:a="http://schemas.openxmlformats.org/drawingml/2006/main">
             <a:r>
+              <a:t/>
+            </a:r>
+          </a:p>
+          <a:p xmlns:a="http://schemas.openxmlformats.org/drawingml/2006/main">
+            <a:r>
               <a:t>Sources: https://github.com/Omswaroopreddyudumula/ajxom-budget-bites; ARCHITECTURE.md; AI_FEATURE.md; docs/CONTRIBUTIONS.md; docs/TEST_RESULTS.md; final-prefixed evidence logs.</a:t>
-            </a:r>
-          </a:p>
-          <a:p xmlns:a="http://schemas.openxmlformats.org/drawingml/2006/main">
-            <a:r>
-              <a:t>Visual/code sources: /Users/omswaroopudumula/Documents/Codex/2026-10-14/referenced-chatgpt-conversation-this-is-an/work/visual-presentation/assets/receipt.png; /Users/omswaroopudumula/Documents/Codex/2026-10-14/referenced-chatgpt-conversation-this-is-an/work/visual-presentation/assets/after-delete600.png.</a:t>
-            </a:r>
-          </a:p>
-          <a:p xmlns:a="http://schemas.openxmlformats.org/drawingml/2006/main">
-            <a:r>
-              <a:t>Frame provenance is recorded in the private presentation build assets.</a:t>
-            </a:r>
-          </a:p>
-          <a:p xmlns:a="http://schemas.openxmlformats.org/drawingml/2006/main">
-            <a:r>
-              <a:t>Rehearse the full recording with the live demo within 20–25 minutes.</a:t>
-            </a:r>
-          </a:p>
-          <a:p xmlns:a="http://schemas.openxmlformats.org/drawingml/2006/main">
-            <a:r>
-              <a:t/>
-            </a:r>
-          </a:p>
-          <a:p xmlns:a="http://schemas.openxmlformats.org/drawingml/2006/main">
-            <a:r>
-              <a:t>Speaker plan: Om presents slides 1–4 and 14–16 (about 4–5 minutes total). A.J. presents slides 5–13 and 17–28 and narrates the full app demo. Presentation leadership does not change code authorship.</a:t>
             </a:r>
           </a:p>
         </p:txBody>
@@ -1904,7 +1564,7 @@
           </a:p>
           <a:p xmlns:a="http://schemas.openxmlformats.org/drawingml/2006/main">
             <a:r>
-              <a:t>Read aloud:</a:t>
+              <a:t/>
             </a:r>
           </a:p>
           <a:p xmlns:a="http://schemas.openxmlformats.org/drawingml/2006/main">
@@ -1939,42 +1599,17 @@
           </a:p>
           <a:p xmlns:a="http://schemas.openxmlformats.org/drawingml/2006/main">
             <a:r>
-              <a:t>Visuals support this narration. Code excerpts are actual source with whitespace wrapped for slide readability. Screenshots are real release captures with fictional examples.</a:t>
-            </a:r>
-          </a:p>
-          <a:p xmlns:a="http://schemas.openxmlformats.org/drawingml/2006/main">
-            <a:r>
               <a:t>Questions: R4, A1.</a:t>
             </a:r>
           </a:p>
           <a:p xmlns:a="http://schemas.openxmlformats.org/drawingml/2006/main">
             <a:r>
+              <a:t/>
+            </a:r>
+          </a:p>
+          <a:p xmlns:a="http://schemas.openxmlformats.org/drawingml/2006/main">
+            <a:r>
               <a:t>Sources: https://github.com/Omswaroopreddyudumula/ajxom-budget-bites; ARCHITECTURE.md; AI_FEATURE.md; docs/CONTRIBUTIONS.md; docs/TEST_RESULTS.md; final-prefixed evidence logs.</a:t>
-            </a:r>
-          </a:p>
-          <a:p xmlns:a="http://schemas.openxmlformats.org/drawingml/2006/main">
-            <a:r>
-              <a:t>Visual/code sources: /Users/omswaroopudumula/Documents/Codex/2026-10-14/referenced-chatgpt-conversation-this-is-an/work/visual-presentation/assets/lens.png.</a:t>
-            </a:r>
-          </a:p>
-          <a:p xmlns:a="http://schemas.openxmlformats.org/drawingml/2006/main">
-            <a:r>
-              <a:t>Frame provenance is recorded in the private presentation build assets.</a:t>
-            </a:r>
-          </a:p>
-          <a:p xmlns:a="http://schemas.openxmlformats.org/drawingml/2006/main">
-            <a:r>
-              <a:t>Rehearse the full recording with the live demo within 20–25 minutes.</a:t>
-            </a:r>
-          </a:p>
-          <a:p xmlns:a="http://schemas.openxmlformats.org/drawingml/2006/main">
-            <a:r>
-              <a:t/>
-            </a:r>
-          </a:p>
-          <a:p xmlns:a="http://schemas.openxmlformats.org/drawingml/2006/main">
-            <a:r>
-              <a:t>Speaker plan: Om presents slides 1–4 and 14–16 (about 4–5 minutes total). A.J. presents slides 5–13 and 17–28 and narrates the full app demo. Presentation leadership does not change code authorship.</a:t>
             </a:r>
           </a:p>
         </p:txBody>
@@ -2049,7 +1684,7 @@
           </a:p>
           <a:p xmlns:a="http://schemas.openxmlformats.org/drawingml/2006/main">
             <a:r>
-              <a:t>Read aloud:</a:t>
+              <a:t/>
             </a:r>
           </a:p>
           <a:p xmlns:a="http://schemas.openxmlformats.org/drawingml/2006/main">
@@ -2084,42 +1719,17 @@
           </a:p>
           <a:p xmlns:a="http://schemas.openxmlformats.org/drawingml/2006/main">
             <a:r>
-              <a:t>Visuals support this narration. Code excerpts are actual source with whitespace wrapped for slide readability. Screenshots are real release captures with fictional examples.</a:t>
-            </a:r>
-          </a:p>
-          <a:p xmlns:a="http://schemas.openxmlformats.org/drawingml/2006/main">
-            <a:r>
               <a:t>Questions: Introduction.</a:t>
             </a:r>
           </a:p>
           <a:p xmlns:a="http://schemas.openxmlformats.org/drawingml/2006/main">
             <a:r>
+              <a:t/>
+            </a:r>
+          </a:p>
+          <a:p xmlns:a="http://schemas.openxmlformats.org/drawingml/2006/main">
+            <a:r>
               <a:t>Sources: https://github.com/Omswaroopreddyudumula/ajxom-budget-bites; ARCHITECTURE.md; AI_FEATURE.md; docs/CONTRIBUTIONS.md; docs/TEST_RESULTS.md; final-prefixed evidence logs.</a:t>
-            </a:r>
-          </a:p>
-          <a:p xmlns:a="http://schemas.openxmlformats.org/drawingml/2006/main">
-            <a:r>
-              <a:t>Visual/code sources: /Users/omswaroopudumula/Documents/Codex/2026-10-14/referenced-chatgpt-conversation-this-is-an/work/visual-presentation/assets/history650.png.</a:t>
-            </a:r>
-          </a:p>
-          <a:p xmlns:a="http://schemas.openxmlformats.org/drawingml/2006/main">
-            <a:r>
-              <a:t>Frame provenance is recorded in the private presentation build assets.</a:t>
-            </a:r>
-          </a:p>
-          <a:p xmlns:a="http://schemas.openxmlformats.org/drawingml/2006/main">
-            <a:r>
-              <a:t>Rehearse the full recording with the live demo within 20–25 minutes.</a:t>
-            </a:r>
-          </a:p>
-          <a:p xmlns:a="http://schemas.openxmlformats.org/drawingml/2006/main">
-            <a:r>
-              <a:t/>
-            </a:r>
-          </a:p>
-          <a:p xmlns:a="http://schemas.openxmlformats.org/drawingml/2006/main">
-            <a:r>
-              <a:t>Speaker plan: Om presents slides 1–4 and 14–16 (about 4–5 minutes total). A.J. presents slides 5–13 and 17–28 and narrates the full app demo. Presentation leadership does not change code authorship.</a:t>
             </a:r>
           </a:p>
         </p:txBody>
@@ -2194,7 +1804,7 @@
           </a:p>
           <a:p xmlns:a="http://schemas.openxmlformats.org/drawingml/2006/main">
             <a:r>
-              <a:t>Read aloud:</a:t>
+              <a:t/>
             </a:r>
           </a:p>
           <a:p xmlns:a="http://schemas.openxmlformats.org/drawingml/2006/main">
@@ -2209,42 +1819,17 @@
           </a:p>
           <a:p xmlns:a="http://schemas.openxmlformats.org/drawingml/2006/main">
             <a:r>
-              <a:t>Visuals support this narration. Code excerpts are actual source with whitespace wrapped for slide readability. Screenshots are real release captures with fictional examples.</a:t>
-            </a:r>
-          </a:p>
-          <a:p xmlns:a="http://schemas.openxmlformats.org/drawingml/2006/main">
-            <a:r>
               <a:t>Questions: R4, A1.</a:t>
             </a:r>
           </a:p>
           <a:p xmlns:a="http://schemas.openxmlformats.org/drawingml/2006/main">
             <a:r>
+              <a:t/>
+            </a:r>
+          </a:p>
+          <a:p xmlns:a="http://schemas.openxmlformats.org/drawingml/2006/main">
+            <a:r>
               <a:t>Sources: https://github.com/Omswaroopreddyudumula/ajxom-budget-bites; ARCHITECTURE.md; AI_FEATURE.md; docs/CONTRIBUTIONS.md; docs/TEST_RESULTS.md; final-prefixed evidence logs.</a:t>
-            </a:r>
-          </a:p>
-          <a:p xmlns:a="http://schemas.openxmlformats.org/drawingml/2006/main">
-            <a:r>
-              <a:t>Visual/code sources: lib/domain/lunch_lens.dart.</a:t>
-            </a:r>
-          </a:p>
-          <a:p xmlns:a="http://schemas.openxmlformats.org/drawingml/2006/main">
-            <a:r>
-              <a:t>Frame provenance is recorded in the private presentation build assets.</a:t>
-            </a:r>
-          </a:p>
-          <a:p xmlns:a="http://schemas.openxmlformats.org/drawingml/2006/main">
-            <a:r>
-              <a:t>Rehearse the full recording with the live demo within 20–25 minutes.</a:t>
-            </a:r>
-          </a:p>
-          <a:p xmlns:a="http://schemas.openxmlformats.org/drawingml/2006/main">
-            <a:r>
-              <a:t/>
-            </a:r>
-          </a:p>
-          <a:p xmlns:a="http://schemas.openxmlformats.org/drawingml/2006/main">
-            <a:r>
-              <a:t>Speaker plan: Om presents slides 1–4 and 14–16 (about 4–5 minutes total). A.J. presents slides 5–13 and 17–28 and narrates the full app demo. Presentation leadership does not change code authorship.</a:t>
             </a:r>
           </a:p>
         </p:txBody>
@@ -2319,16 +1904,6 @@
           </a:p>
           <a:p xmlns:a="http://schemas.openxmlformats.org/drawingml/2006/main">
             <a:r>
-              <a:t>Read aloud:</a:t>
-            </a:r>
-          </a:p>
-          <a:p xmlns:a="http://schemas.openxmlformats.org/drawingml/2006/main">
-            <a:r>
-              <a:t>We checked five fictional case types. The table shows chronological input amounts in cents and the actual outputs from the passing checks.</a:t>
-            </a:r>
-          </a:p>
-          <a:p xmlns:a="http://schemas.openxmlformats.org/drawingml/2006/main">
-            <a:r>
               <a:t/>
             </a:r>
           </a:p>
@@ -2344,42 +1919,17 @@
           </a:p>
           <a:p xmlns:a="http://schemas.openxmlformats.org/drawingml/2006/main">
             <a:r>
-              <a:t>Visuals support this narration. Code excerpts are actual source with whitespace wrapped for slide readability. Screenshots are real release captures with fictional examples.</a:t>
-            </a:r>
-          </a:p>
-          <a:p xmlns:a="http://schemas.openxmlformats.org/drawingml/2006/main">
-            <a:r>
               <a:t>Questions: R4, T1.</a:t>
             </a:r>
           </a:p>
           <a:p xmlns:a="http://schemas.openxmlformats.org/drawingml/2006/main">
             <a:r>
+              <a:t/>
+            </a:r>
+          </a:p>
+          <a:p xmlns:a="http://schemas.openxmlformats.org/drawingml/2006/main">
+            <a:r>
               <a:t>Sources: https://github.com/Omswaroopreddyudumula/ajxom-budget-bites; ARCHITECTURE.md; AI_FEATURE.md; docs/CONTRIBUTIONS.md; docs/TEST_RESULTS.md; final-prefixed evidence logs.</a:t>
-            </a:r>
-          </a:p>
-          <a:p xmlns:a="http://schemas.openxmlformats.org/drawingml/2006/main">
-            <a:r>
-              <a:t>Visual/code sources: .</a:t>
-            </a:r>
-          </a:p>
-          <a:p xmlns:a="http://schemas.openxmlformats.org/drawingml/2006/main">
-            <a:r>
-              <a:t>Frame provenance is recorded in the private presentation build assets.</a:t>
-            </a:r>
-          </a:p>
-          <a:p xmlns:a="http://schemas.openxmlformats.org/drawingml/2006/main">
-            <a:r>
-              <a:t>Rehearse the full recording with the live demo within 20–25 minutes.</a:t>
-            </a:r>
-          </a:p>
-          <a:p xmlns:a="http://schemas.openxmlformats.org/drawingml/2006/main">
-            <a:r>
-              <a:t/>
-            </a:r>
-          </a:p>
-          <a:p xmlns:a="http://schemas.openxmlformats.org/drawingml/2006/main">
-            <a:r>
-              <a:t>Speaker plan: Om presents slides 1–4 and 14–16 (about 4–5 minutes total). A.J. presents slides 5–13 and 17–28 and narrates the full app demo. Presentation leadership does not change code authorship.</a:t>
             </a:r>
           </a:p>
         </p:txBody>
@@ -2454,7 +2004,7 @@
           </a:p>
           <a:p xmlns:a="http://schemas.openxmlformats.org/drawingml/2006/main">
             <a:r>
-              <a:t>Read aloud:</a:t>
+              <a:t/>
             </a:r>
           </a:p>
           <a:p xmlns:a="http://schemas.openxmlformats.org/drawingml/2006/main">
@@ -2489,42 +2039,17 @@
           </a:p>
           <a:p xmlns:a="http://schemas.openxmlformats.org/drawingml/2006/main">
             <a:r>
-              <a:t>Visuals support this narration. Code excerpts are actual source with whitespace wrapped for slide readability. Screenshots are real release captures with fictional examples.</a:t>
-            </a:r>
-          </a:p>
-          <a:p xmlns:a="http://schemas.openxmlformats.org/drawingml/2006/main">
-            <a:r>
               <a:t>Questions: R4.</a:t>
             </a:r>
           </a:p>
           <a:p xmlns:a="http://schemas.openxmlformats.org/drawingml/2006/main">
             <a:r>
+              <a:t/>
+            </a:r>
+          </a:p>
+          <a:p xmlns:a="http://schemas.openxmlformats.org/drawingml/2006/main">
+            <a:r>
               <a:t>Sources: https://github.com/Omswaroopreddyudumula/ajxom-budget-bites; ARCHITECTURE.md; AI_FEATURE.md; docs/CONTRIBUTIONS.md; docs/TEST_RESULTS.md; final-prefixed evidence logs.</a:t>
-            </a:r>
-          </a:p>
-          <a:p xmlns:a="http://schemas.openxmlformats.org/drawingml/2006/main">
-            <a:r>
-              <a:t>Visual/code sources: .</a:t>
-            </a:r>
-          </a:p>
-          <a:p xmlns:a="http://schemas.openxmlformats.org/drawingml/2006/main">
-            <a:r>
-              <a:t>Frame provenance is recorded in the private presentation build assets.</a:t>
-            </a:r>
-          </a:p>
-          <a:p xmlns:a="http://schemas.openxmlformats.org/drawingml/2006/main">
-            <a:r>
-              <a:t>Rehearse the full recording with the live demo within 20–25 minutes.</a:t>
-            </a:r>
-          </a:p>
-          <a:p xmlns:a="http://schemas.openxmlformats.org/drawingml/2006/main">
-            <a:r>
-              <a:t/>
-            </a:r>
-          </a:p>
-          <a:p xmlns:a="http://schemas.openxmlformats.org/drawingml/2006/main">
-            <a:r>
-              <a:t>Speaker plan: Om presents slides 1–4 and 14–16 (about 4–5 minutes total). A.J. presents slides 5–13 and 17–28 and narrates the full app demo. Presentation leadership does not change code authorship.</a:t>
             </a:r>
           </a:p>
         </p:txBody>
@@ -2599,22 +2124,12 @@
           </a:p>
           <a:p xmlns:a="http://schemas.openxmlformats.org/drawingml/2006/main">
             <a:r>
-              <a:t>Read aloud:</a:t>
-            </a:r>
-          </a:p>
-          <a:p xmlns:a="http://schemas.openxmlformats.org/drawingml/2006/main">
-            <a:r>
-              <a:t>Our final analyzer run reported no issues, and the logic and widget suite passed seventeen checks. Pure-function tests cover money rules and helper cases. Widget tests use an injected fake data boundary to examine navigation, invalid inputs, a failed save and the helper's explanation and dismissal.</a:t>
-            </a:r>
-          </a:p>
-          <a:p xmlns:a="http://schemas.openxmlformats.org/drawingml/2006/main">
-            <a:r>
               <a:t/>
             </a:r>
           </a:p>
           <a:p xmlns:a="http://schemas.openxmlformats.org/drawingml/2006/main">
             <a:r>
-              <a:t>Android integration checks use the real SQLite plugin. Three checks passed on each of two emulator profiles, covering CRUD, constraints, repeated-save behavior, migration and reopening saved data. Release installation and offline restart checks also showed retained records and preferences through the running interface.</a:t>
+              <a:t>Questions: T1, T2, D2.</a:t>
             </a:r>
           </a:p>
           <a:p xmlns:a="http://schemas.openxmlformats.org/drawingml/2006/main">
@@ -2624,57 +2139,7 @@
           </a:p>
           <a:p xmlns:a="http://schemas.openxmlformats.org/drawingml/2006/main">
             <a:r>
-              <a:t>The emulators have different display settings but share one Android API image. Physical-device testing and independent peer revision remain incomplete. Genuine logs identify the checks we actually performed.</a:t>
-            </a:r>
-          </a:p>
-          <a:p xmlns:a="http://schemas.openxmlformats.org/drawingml/2006/main">
-            <a:r>
-              <a:t/>
-            </a:r>
-          </a:p>
-          <a:p xmlns:a="http://schemas.openxmlformats.org/drawingml/2006/main">
-            <a:r>
-              <a:t>Visuals support this narration. Code excerpts are actual source with whitespace wrapped for slide readability. Screenshots are real release captures with fictional examples.</a:t>
-            </a:r>
-          </a:p>
-          <a:p xmlns:a="http://schemas.openxmlformats.org/drawingml/2006/main">
-            <a:r>
-              <a:t>Questions: T1, T2, D2.</a:t>
-            </a:r>
-          </a:p>
-          <a:p xmlns:a="http://schemas.openxmlformats.org/drawingml/2006/main">
-            <a:r>
               <a:t>Sources: https://github.com/Omswaroopreddyudumula/ajxom-budget-bites; ARCHITECTURE.md; AI_FEATURE.md; docs/CONTRIBUTIONS.md; docs/TEST_RESULTS.md; final-prefixed evidence logs.</a:t>
-            </a:r>
-          </a:p>
-          <a:p xmlns:a="http://schemas.openxmlformats.org/drawingml/2006/main">
-            <a:r>
-              <a:t>Visual/code sources: final-unit-widget-tests.txt; final-phone-integration.txt</a:t>
-            </a:r>
-          </a:p>
-          <a:p xmlns:a="http://schemas.openxmlformats.org/drawingml/2006/main">
-            <a:r>
-              <a:t>final-large-integration.txt.</a:t>
-            </a:r>
-          </a:p>
-          <a:p xmlns:a="http://schemas.openxmlformats.org/drawingml/2006/main">
-            <a:r>
-              <a:t>Frame provenance is recorded in the private presentation build assets.</a:t>
-            </a:r>
-          </a:p>
-          <a:p xmlns:a="http://schemas.openxmlformats.org/drawingml/2006/main">
-            <a:r>
-              <a:t>Rehearse the full recording with the live demo within 20–25 minutes.</a:t>
-            </a:r>
-          </a:p>
-          <a:p xmlns:a="http://schemas.openxmlformats.org/drawingml/2006/main">
-            <a:r>
-              <a:t/>
-            </a:r>
-          </a:p>
-          <a:p xmlns:a="http://schemas.openxmlformats.org/drawingml/2006/main">
-            <a:r>
-              <a:t>Speaker plan: Om presents slides 1–4 and 14–16 (about 4–5 minutes total). A.J. presents slides 5–13 and 17–28 and narrates the full app demo. Presentation leadership does not change code authorship.</a:t>
             </a:r>
           </a:p>
         </p:txBody>
@@ -2749,57 +2214,22 @@
           </a:p>
           <a:p xmlns:a="http://schemas.openxmlformats.org/drawingml/2006/main">
             <a:r>
-              <a:t>Read aloud:</a:t>
-            </a:r>
-          </a:p>
-          <a:p xmlns:a="http://schemas.openxmlformats.org/drawingml/2006/main">
-            <a:r>
-              <a:t>These genuine final release captures show the same saved $4.50 receipt on two display configurations. Three integration checks passed on each profile. Both use the same Android API image.</a:t>
-            </a:r>
-          </a:p>
-          <a:p xmlns:a="http://schemas.openxmlformats.org/drawingml/2006/main">
-            <a:r>
               <a:t/>
             </a:r>
           </a:p>
           <a:p xmlns:a="http://schemas.openxmlformats.org/drawingml/2006/main">
             <a:r>
-              <a:t>Visuals support this narration. Code excerpts are actual source with whitespace wrapped for slide readability. Screenshots are real release captures with fictional examples.</a:t>
-            </a:r>
-          </a:p>
-          <a:p xmlns:a="http://schemas.openxmlformats.org/drawingml/2006/main">
-            <a:r>
               <a:t>Questions: D2, T1.</a:t>
             </a:r>
           </a:p>
           <a:p xmlns:a="http://schemas.openxmlformats.org/drawingml/2006/main">
             <a:r>
+              <a:t/>
+            </a:r>
+          </a:p>
+          <a:p xmlns:a="http://schemas.openxmlformats.org/drawingml/2006/main">
+            <a:r>
               <a:t>Sources: https://github.com/Omswaroopreddyudumula/ajxom-budget-bites; ARCHITECTURE.md; AI_FEATURE.md; docs/CONTRIBUTIONS.md; docs/TEST_RESULTS.md; final-prefixed evidence logs.</a:t>
-            </a:r>
-          </a:p>
-          <a:p xmlns:a="http://schemas.openxmlformats.org/drawingml/2006/main">
-            <a:r>
-              <a:t>Visual/code sources: /Users/omswaroopudumula/Documents/Codex/2026-10-14/referenced-chatgpt-conversation-this-is-an/work/ajxom-budget-bites/evidence/final-emulator-5554-history.png; /Users/omswaroopudumula/Documents/Codex/2026-10-14/referenced-chatgpt-conversation-this-is-an/work/ajxom-budget-bites/evidence/final-emulator-5556-history.png.</a:t>
-            </a:r>
-          </a:p>
-          <a:p xmlns:a="http://schemas.openxmlformats.org/drawingml/2006/main">
-            <a:r>
-              <a:t>Frame provenance is recorded in the private presentation build assets.</a:t>
-            </a:r>
-          </a:p>
-          <a:p xmlns:a="http://schemas.openxmlformats.org/drawingml/2006/main">
-            <a:r>
-              <a:t>Rehearse the full recording with the live demo within 20–25 minutes.</a:t>
-            </a:r>
-          </a:p>
-          <a:p xmlns:a="http://schemas.openxmlformats.org/drawingml/2006/main">
-            <a:r>
-              <a:t/>
-            </a:r>
-          </a:p>
-          <a:p xmlns:a="http://schemas.openxmlformats.org/drawingml/2006/main">
-            <a:r>
-              <a:t>Speaker plan: Om presents slides 1–4 and 14–16 (about 4–5 minutes total). A.J. presents slides 5–13 and 17–28 and narrates the full app demo. Presentation leadership does not change code authorship.</a:t>
             </a:r>
           </a:p>
         </p:txBody>
@@ -2874,7 +2304,7 @@
           </a:p>
           <a:p xmlns:a="http://schemas.openxmlformats.org/drawingml/2006/main">
             <a:r>
-              <a:t>Read aloud:</a:t>
+              <a:t/>
             </a:r>
           </a:p>
           <a:p xmlns:a="http://schemas.openxmlformats.org/drawingml/2006/main">
@@ -2899,7 +2329,7 @@
           </a:p>
           <a:p xmlns:a="http://schemas.openxmlformats.org/drawingml/2006/main">
             <a:r>
-              <a:t>The preserved branch history, shared data ownership and focused regression tests connect both contributions into one working application. The preserved branch history, integration and actual test logs are available for review. In a future project, we would collect board evidence throughout development.</a:t>
+              <a:t>The preserved branch history, shared data ownership and focused regression tests connect both contributions into one working application. History totals, receipt actions and large-text behavior were checked after integration.</a:t>
             </a:r>
           </a:p>
           <a:p xmlns:a="http://schemas.openxmlformats.org/drawingml/2006/main">
@@ -2909,42 +2339,17 @@
           </a:p>
           <a:p xmlns:a="http://schemas.openxmlformats.org/drawingml/2006/main">
             <a:r>
-              <a:t>Visuals support this narration. Code excerpts are actual source with whitespace wrapped for slide readability. Screenshots are real release captures with fictional examples.</a:t>
-            </a:r>
-          </a:p>
-          <a:p xmlns:a="http://schemas.openxmlformats.org/drawingml/2006/main">
-            <a:r>
               <a:t>Questions: R1, R2, A1.</a:t>
             </a:r>
           </a:p>
           <a:p xmlns:a="http://schemas.openxmlformats.org/drawingml/2006/main">
             <a:r>
+              <a:t/>
+            </a:r>
+          </a:p>
+          <a:p xmlns:a="http://schemas.openxmlformats.org/drawingml/2006/main">
+            <a:r>
               <a:t>Sources: https://github.com/Omswaroopreddyudumula/ajxom-budget-bites; ARCHITECTURE.md; AI_FEATURE.md; docs/CONTRIBUTIONS.md; docs/TEST_RESULTS.md; final-prefixed evidence logs.</a:t>
-            </a:r>
-          </a:p>
-          <a:p xmlns:a="http://schemas.openxmlformats.org/drawingml/2006/main">
-            <a:r>
-              <a:t>Visual/code sources: lib/screens/meal_history.dart.</a:t>
-            </a:r>
-          </a:p>
-          <a:p xmlns:a="http://schemas.openxmlformats.org/drawingml/2006/main">
-            <a:r>
-              <a:t>Frame provenance is recorded in the private presentation build assets.</a:t>
-            </a:r>
-          </a:p>
-          <a:p xmlns:a="http://schemas.openxmlformats.org/drawingml/2006/main">
-            <a:r>
-              <a:t>Rehearse the full recording with the live demo within 20–25 minutes.</a:t>
-            </a:r>
-          </a:p>
-          <a:p xmlns:a="http://schemas.openxmlformats.org/drawingml/2006/main">
-            <a:r>
-              <a:t/>
-            </a:r>
-          </a:p>
-          <a:p xmlns:a="http://schemas.openxmlformats.org/drawingml/2006/main">
-            <a:r>
-              <a:t>Speaker plan: Om presents slides 1–4 and 14–16 (about 4–5 minutes total). A.J. presents slides 5–13 and 17–28 and narrates the full app demo. Presentation leadership does not change code authorship.</a:t>
             </a:r>
           </a:p>
         </p:txBody>
@@ -3019,7 +2424,7 @@
           </a:p>
           <a:p xmlns:a="http://schemas.openxmlformats.org/drawingml/2006/main">
             <a:r>
-              <a:t>Read aloud:</a:t>
+              <a:t/>
             </a:r>
           </a:p>
           <a:p xmlns:a="http://schemas.openxmlformats.org/drawingml/2006/main">
@@ -3054,42 +2459,17 @@
           </a:p>
           <a:p xmlns:a="http://schemas.openxmlformats.org/drawingml/2006/main">
             <a:r>
-              <a:t>Visuals support this narration. Code excerpts are actual source with whitespace wrapped for slide readability. Screenshots are real release captures with fictional examples.</a:t>
-            </a:r>
-          </a:p>
-          <a:p xmlns:a="http://schemas.openxmlformats.org/drawingml/2006/main">
-            <a:r>
               <a:t>Questions: R4.</a:t>
             </a:r>
           </a:p>
           <a:p xmlns:a="http://schemas.openxmlformats.org/drawingml/2006/main">
             <a:r>
+              <a:t/>
+            </a:r>
+          </a:p>
+          <a:p xmlns:a="http://schemas.openxmlformats.org/drawingml/2006/main">
+            <a:r>
               <a:t>Sources: https://github.com/Omswaroopreddyudumula/ajxom-budget-bites; ARCHITECTURE.md; AI_FEATURE.md; docs/CONTRIBUTIONS.md; docs/TEST_RESULTS.md; final-prefixed evidence logs.</a:t>
-            </a:r>
-          </a:p>
-          <a:p xmlns:a="http://schemas.openxmlformats.org/drawingml/2006/main">
-            <a:r>
-              <a:t>Visual/code sources: .</a:t>
-            </a:r>
-          </a:p>
-          <a:p xmlns:a="http://schemas.openxmlformats.org/drawingml/2006/main">
-            <a:r>
-              <a:t>Frame provenance is recorded in the private presentation build assets.</a:t>
-            </a:r>
-          </a:p>
-          <a:p xmlns:a="http://schemas.openxmlformats.org/drawingml/2006/main">
-            <a:r>
-              <a:t>Rehearse the full recording with the live demo within 20–25 minutes.</a:t>
-            </a:r>
-          </a:p>
-          <a:p xmlns:a="http://schemas.openxmlformats.org/drawingml/2006/main">
-            <a:r>
-              <a:t/>
-            </a:r>
-          </a:p>
-          <a:p xmlns:a="http://schemas.openxmlformats.org/drawingml/2006/main">
-            <a:r>
-              <a:t>Speaker plan: Om presents slides 1–4 and 14–16 (about 4–5 minutes total). A.J. presents slides 5–13 and 17–28 and narrates the full app demo. Presentation leadership does not change code authorship.</a:t>
             </a:r>
           </a:p>
         </p:txBody>
@@ -3164,7 +2544,7 @@
           </a:p>
           <a:p xmlns:a="http://schemas.openxmlformats.org/drawingml/2006/main">
             <a:r>
-              <a:t>Read aloud:</a:t>
+              <a:t/>
             </a:r>
           </a:p>
           <a:p xmlns:a="http://schemas.openxmlformats.org/drawingml/2006/main">
@@ -3199,42 +2579,17 @@
           </a:p>
           <a:p xmlns:a="http://schemas.openxmlformats.org/drawingml/2006/main">
             <a:r>
-              <a:t>Visuals support this narration. Code excerpts are actual source with whitespace wrapped for slide readability. Screenshots are real release captures with fictional examples.</a:t>
-            </a:r>
-          </a:p>
-          <a:p xmlns:a="http://schemas.openxmlformats.org/drawingml/2006/main">
-            <a:r>
               <a:t>Questions: R1, R2.</a:t>
             </a:r>
           </a:p>
           <a:p xmlns:a="http://schemas.openxmlformats.org/drawingml/2006/main">
             <a:r>
+              <a:t/>
+            </a:r>
+          </a:p>
+          <a:p xmlns:a="http://schemas.openxmlformats.org/drawingml/2006/main">
+            <a:r>
               <a:t>Sources: https://github.com/Omswaroopreddyudumula/ajxom-budget-bites; ARCHITECTURE.md; AI_FEATURE.md; docs/CONTRIBUTIONS.md; docs/TEST_RESULTS.md; final-prefixed evidence logs.</a:t>
-            </a:r>
-          </a:p>
-          <a:p xmlns:a="http://schemas.openxmlformats.org/drawingml/2006/main">
-            <a:r>
-              <a:t>Visual/code sources: Repository map.</a:t>
-            </a:r>
-          </a:p>
-          <a:p xmlns:a="http://schemas.openxmlformats.org/drawingml/2006/main">
-            <a:r>
-              <a:t>Frame provenance is recorded in the private presentation build assets.</a:t>
-            </a:r>
-          </a:p>
-          <a:p xmlns:a="http://schemas.openxmlformats.org/drawingml/2006/main">
-            <a:r>
-              <a:t>Rehearse the full recording with the live demo within 20–25 minutes.</a:t>
-            </a:r>
-          </a:p>
-          <a:p xmlns:a="http://schemas.openxmlformats.org/drawingml/2006/main">
-            <a:r>
-              <a:t/>
-            </a:r>
-          </a:p>
-          <a:p xmlns:a="http://schemas.openxmlformats.org/drawingml/2006/main">
-            <a:r>
-              <a:t>Speaker plan: Om presents slides 1–4 and 14–16 (about 4–5 minutes total). A.J. presents slides 5–13 and 17–28 and narrates the full app demo. Presentation leadership does not change code authorship.</a:t>
             </a:r>
           </a:p>
         </p:txBody>
@@ -3309,7 +2664,7 @@
           </a:p>
           <a:p xmlns:a="http://schemas.openxmlformats.org/drawingml/2006/main">
             <a:r>
-              <a:t>Read aloud:</a:t>
+              <a:t/>
             </a:r>
           </a:p>
           <a:p xmlns:a="http://schemas.openxmlformats.org/drawingml/2006/main">
@@ -3344,387 +2699,17 @@
           </a:p>
           <a:p xmlns:a="http://schemas.openxmlformats.org/drawingml/2006/main">
             <a:r>
-              <a:t>Visuals support this narration. Code excerpts are actual source with whitespace wrapped for slide readability. Screenshots are real release captures with fictional examples.</a:t>
-            </a:r>
-          </a:p>
-          <a:p xmlns:a="http://schemas.openxmlformats.org/drawingml/2006/main">
-            <a:r>
               <a:t>Questions: D1, D2, R4.</a:t>
             </a:r>
           </a:p>
           <a:p xmlns:a="http://schemas.openxmlformats.org/drawingml/2006/main">
             <a:r>
+              <a:t/>
+            </a:r>
+          </a:p>
+          <a:p xmlns:a="http://schemas.openxmlformats.org/drawingml/2006/main">
+            <a:r>
               <a:t>Sources: https://github.com/Omswaroopreddyudumula/ajxom-budget-bites; ARCHITECTURE.md; AI_FEATURE.md; docs/CONTRIBUTIONS.md; docs/TEST_RESULTS.md; final-prefixed evidence logs.</a:t>
-            </a:r>
-          </a:p>
-          <a:p xmlns:a="http://schemas.openxmlformats.org/drawingml/2006/main">
-            <a:r>
-              <a:t>Visual/code sources: /Users/omswaroopudumula/Documents/Codex/2026-10-14/referenced-chatgpt-conversation-this-is-an/work/visual-presentation/assets/offline-receipts.png.</a:t>
-            </a:r>
-          </a:p>
-          <a:p xmlns:a="http://schemas.openxmlformats.org/drawingml/2006/main">
-            <a:r>
-              <a:t>Frame provenance is recorded in the private presentation build assets.</a:t>
-            </a:r>
-          </a:p>
-          <a:p xmlns:a="http://schemas.openxmlformats.org/drawingml/2006/main">
-            <a:r>
-              <a:t>Rehearse the full recording with the live demo within 20–25 minutes.</a:t>
-            </a:r>
-          </a:p>
-          <a:p xmlns:a="http://schemas.openxmlformats.org/drawingml/2006/main">
-            <a:r>
-              <a:t/>
-            </a:r>
-          </a:p>
-          <a:p xmlns:a="http://schemas.openxmlformats.org/drawingml/2006/main">
-            <a:r>
-              <a:t>A.J. live demo script after the slides:</a:t>
-            </a:r>
-          </a:p>
-          <a:p xmlns:a="http://schemas.openxmlformats.org/drawingml/2006/main">
-            <a:r>
-              <a:t># A.J.'s live Budget Bites demo script</a:t>
-            </a:r>
-          </a:p>
-          <a:p xmlns:a="http://schemas.openxmlformats.org/drawingml/2006/main">
-            <a:r>
-              <a:t/>
-            </a:r>
-          </a:p>
-          <a:p xmlns:a="http://schemas.openxmlformats.org/drawingml/2006/main">
-            <a:r>
-              <a:t>**Speaker:** A.J. throughout the application demo. Om can operate the emulator while A.J. reads.</a:t>
-            </a:r>
-          </a:p>
-          <a:p xmlns:a="http://schemas.openxmlformats.org/drawingml/2006/main">
-            <a:r>
-              <a:t/>
-            </a:r>
-          </a:p>
-          <a:p xmlns:a="http://schemas.openxmlformats.org/drawingml/2006/main">
-            <a:r>
-              <a:t>**Presentation split:** Om speaks on slides 1–4 and 14–16, about 4–5 minutes in total. A.J. leads slides 5–13 and 17–28, then narrates the full app demo. Presenter assignment does not change authorship: A.J. credits Om for frontend and integration work.</a:t>
-            </a:r>
-          </a:p>
-          <a:p xmlns:a="http://schemas.openxmlformats.org/drawingml/2006/main">
-            <a:r>
-              <a:t/>
-            </a:r>
-          </a:p>
-          <a:p xmlns:a="http://schemas.openxmlformats.org/drawingml/2006/main">
-            <a:r>
-              <a:t>**Order:** Present all 28 slides first, then switch to the installed Android release app. Aim for about 5–6 minutes for this walkthrough, speaking while performing the actions. Rehearse the combined presentation at a comfortable pace and keep the full recording within the course's 20–25 minutes.</a:t>
-            </a:r>
-          </a:p>
-          <a:p xmlns:a="http://schemas.openxmlformats.org/drawingml/2006/main">
-            <a:r>
-              <a:t/>
-            </a:r>
-          </a:p>
-          <a:p xmlns:a="http://schemas.openxmlformats.org/drawingml/2006/main">
-            <a:r>
-              <a:t>Read the quoted paragraphs. The **Show** lines are operator instructions and are not spoken. These are fictional demonstration amounts, not actual purchases. Keep existing records. Use a new unique demo meal name if “Showcase Lunch” already exists. Do not delete unrelated records.</a:t>
-            </a:r>
-          </a:p>
-          <a:p xmlns:a="http://schemas.openxmlformats.org/drawingml/2006/main">
-            <a:r>
-              <a:t/>
-            </a:r>
-          </a:p>
-          <a:p xmlns:a="http://schemas.openxmlformats.org/drawingml/2006/main">
-            <a:r>
-              <a:t>## 1. Home and the purpose of the app</a:t>
-            </a:r>
-          </a:p>
-          <a:p xmlns:a="http://schemas.openxmlformats.org/drawingml/2006/main">
-            <a:r>
-              <a:t/>
-            </a:r>
-          </a:p>
-          <a:p xmlns:a="http://schemas.openxmlformats.org/drawingml/2006/main">
-            <a:r>
-              <a:t>**Show:** Open Budget Bites. Show Home, the budget value, search, cuisine filter and favorites. Set the budget to $10.00 and light mode before this walkthrough if necessary.</a:t>
-            </a:r>
-          </a:p>
-          <a:p xmlns:a="http://schemas.openxmlformats.org/drawingml/2006/main">
-            <a:r>
-              <a:t/>
-            </a:r>
-          </a:p>
-          <a:p xmlns:a="http://schemas.openxmlformats.org/drawingml/2006/main">
-            <a:r>
-              <a:t>&gt; I will now demonstrate the team's integrated application. Home shows the meal catalog and the current lunch budget. A student can search their own meal notes, choose a cuisine or use the favorites filter. These are local records, and the starter meals are fictional examples. I will use a separate fictional meal so the demonstration does not change unrelated records.</a:t>
-            </a:r>
-          </a:p>
-          <a:p xmlns:a="http://schemas.openxmlformats.org/drawingml/2006/main">
-            <a:r>
-              <a:t/>
-            </a:r>
-          </a:p>
-          <a:p xmlns:a="http://schemas.openxmlformats.org/drawingml/2006/main">
-            <a:r>
-              <a:t>## 2. Create, read and edit a meal</a:t>
-            </a:r>
-          </a:p>
-          <a:p xmlns:a="http://schemas.openxmlformats.org/drawingml/2006/main">
-            <a:r>
-              <a:t/>
-            </a:r>
-          </a:p>
-          <a:p xmlns:a="http://schemas.openxmlformats.org/drawingml/2006/main">
-            <a:r>
-              <a:t>**Show:** Select **Add meal**. Enter **Showcase Lunch**, venue **Fictional demo cafe**, entree **Wrap** at **5.50**, and side **Fruit** at **1.00**. Leave the other price at zero and save. Search for the meal. Open **Edit meal**, change the venue note to **Fictional demo cafe, student menu**, and save.</a:t>
-            </a:r>
-          </a:p>
-          <a:p xmlns:a="http://schemas.openxmlformats.org/drawingml/2006/main">
-            <a:r>
-              <a:t/>
-            </a:r>
-          </a:p>
-          <a:p xmlns:a="http://schemas.openxmlformats.org/drawingml/2006/main">
-            <a:r>
-              <a:t>&gt; This is the reusable meal editor from Om's frontend work. I am entering a name, venue note and estimated item prices. Saving creates a Meal with its own database ID. The two prices produce a six-dollar-fifty-cent catalog estimate. Editing the venue updates the same record rather than creating another meal. This demonstrates the connection between the form and our database CRUD boundary.</a:t>
-            </a:r>
-          </a:p>
-          <a:p xmlns:a="http://schemas.openxmlformats.org/drawingml/2006/main">
-            <a:r>
-              <a:t/>
-            </a:r>
-          </a:p>
-          <a:p xmlns:a="http://schemas.openxmlformats.org/drawingml/2006/main">
-            <a:r>
-              <a:t>## 3. Validate and save an actual purchase</a:t>
-            </a:r>
-          </a:p>
-          <a:p xmlns:a="http://schemas.openxmlformats.org/drawingml/2006/main">
-            <a:r>
-              <a:t/>
-            </a:r>
-          </a:p>
-          <a:p xmlns:a="http://schemas.openxmlformats.org/drawingml/2006/main">
-            <a:r>
-              <a:t>**Show:** Open **View meal**, then **Start plan**. Enter **6.999** in **Actual amount (USD)** and attempt Save to show the decimal-place validation. Correct it to **6.50**, then choose **Save purchase and finish**. Open **History** and select this meal using the meal filter.</a:t>
-            </a:r>
-          </a:p>
-          <a:p xmlns:a="http://schemas.openxmlformats.org/drawingml/2006/main">
-            <a:r>
-              <a:t/>
-            </a:r>
-          </a:p>
-          <a:p xmlns:a="http://schemas.openxmlformats.org/drawingml/2006/main">
-            <a:r>
-              <a:t>&gt; A planned estimate and an actual purchase are separate values. This amount has too many decimal places, so the form asks me to correct it before saving. After I enter six dollars and fifty cents and explicitly save, the app creates a purchase record linked to this meal. History is our purchase log, and its total reflects the selected meal and date filters.</a:t>
-            </a:r>
-          </a:p>
-          <a:p xmlns:a="http://schemas.openxmlformats.org/drawingml/2006/main">
-            <a:r>
-              <a:t/>
-            </a:r>
-          </a:p>
-          <a:p xmlns:a="http://schemas.openxmlformats.org/drawingml/2006/main">
-            <a:r>
-              <a:t>## 4. Read and correct history</a:t>
-            </a:r>
-          </a:p>
-          <a:p xmlns:a="http://schemas.openxmlformats.org/drawingml/2006/main">
-            <a:r>
-              <a:t/>
-            </a:r>
-          </a:p>
-          <a:p xmlns:a="http://schemas.openxmlformats.org/drawingml/2006/main">
-            <a:r>
-              <a:t>**Show:** Select **View receipt**, close it, then **Edit purchase**. Change **6.50** to **6.00** and choose **Save correction**. From History use **Add purchase**, select the same meal and save **4.50**. Add a second purchase of **7.50**. Reselect the meal filter if necessary. The three receipts now total **18.00**.</a:t>
-            </a:r>
-          </a:p>
-          <a:p xmlns:a="http://schemas.openxmlformats.org/drawingml/2006/main">
-            <a:r>
-              <a:t/>
-            </a:r>
-          </a:p>
-          <a:p xmlns:a="http://schemas.openxmlformats.org/drawingml/2006/main">
-            <a:r>
-              <a:t>&gt; The receipt shows the amount saved for a particular purchase. I can correct that amount to six dollars without changing the meal's current estimate. The spending total refreshes after the correction. I have now added two more fictional purchases, four dollars fifty and seven dollars fifty, which gives this meal three receipts totaling eighteen dollars.</a:t>
-            </a:r>
-          </a:p>
-          <a:p xmlns:a="http://schemas.openxmlformats.org/drawingml/2006/main">
-            <a:r>
-              <a:t/>
-            </a:r>
-          </a:p>
-          <a:p xmlns:a="http://schemas.openxmlformats.org/drawingml/2006/main">
-            <a:r>
-              <a:t>## 5. Delete safely and protect relationships</a:t>
-            </a:r>
-          </a:p>
-          <a:p xmlns:a="http://schemas.openxmlformats.org/drawingml/2006/main">
-            <a:r>
-              <a:t/>
-            </a:r>
-          </a:p>
-          <a:p xmlns:a="http://schemas.openxmlformats.org/drawingml/2006/main">
-            <a:r>
-              <a:t>**Show:** Add an extra **1.00** purchase for the same meal. The total becomes **19.00**. Delete that $1.00 receipt and confirm. The total returns to **18.00**. From Home attempt **Delete meal** on Showcase Lunch to show the linked-purchase restriction. Keep the three existing receipts.</a:t>
-            </a:r>
-          </a:p>
-          <a:p xmlns:a="http://schemas.openxmlformats.org/drawingml/2006/main">
-            <a:r>
-              <a:t/>
-            </a:r>
-          </a:p>
-          <a:p xmlns:a="http://schemas.openxmlformats.org/drawingml/2006/main">
-            <a:r>
-              <a:t>&gt; A purchase can also be deleted independently. This confirmation removes only the temporary one-dollar receipt and refreshes the total. The meal still has three linked purchases, so deleting the parent meal produces a restriction message. This protects the relationship between the catalog entry and its receipts. The original backend foundation and the integrated constraints work together here.</a:t>
-            </a:r>
-          </a:p>
-          <a:p xmlns:a="http://schemas.openxmlformats.org/drawingml/2006/main">
-            <a:r>
-              <a:t/>
-            </a:r>
-          </a:p>
-          <a:p xmlns:a="http://schemas.openxmlformats.org/drawingml/2006/main">
-            <a:r>
-              <a:t>## 6. Explain Lunch Lens and reset a draft</a:t>
-            </a:r>
-          </a:p>
-          <a:p xmlns:a="http://schemas.openxmlformats.org/drawingml/2006/main">
-            <a:r>
-              <a:t/>
-            </a:r>
-          </a:p>
-          <a:p xmlns:a="http://schemas.openxmlformats.org/drawingml/2006/main">
-            <a:r>
-              <a:t>**Show:** Open the meal's activity. Show Lunch Lens: earlier amounts **7.50, 4.50, 6.00**, mean **6.00**, last-price baseline **7.50**. Choose **Not now**, then **Show Lunch Lens**. Select **Start plan**, scroll to **Reset draft**, and confirm Reset. Do not save another receipt. Return to History to verify $18.00 remains.</a:t>
-            </a:r>
-          </a:p>
-          <a:p xmlns:a="http://schemas.openxmlformats.org/drawingml/2006/main">
-            <a:r>
-              <a:t/>
-            </a:r>
-          </a:p>
-          <a:p xmlns:a="http://schemas.openxmlformats.org/drawingml/2006/main">
-            <a:r>
-              <a:t>&gt; Lunch Lens now has enough earlier history. Its three amounts average six dollars, while the last-price baseline is seven dollars fifty. The card explains this calculation, and I can dismiss or reopen it. The helper does not enter the actual amount for me. Resetting this unsaved plan also leaves our three saved receipts and eighteen-dollar total unchanged.</a:t>
-            </a:r>
-          </a:p>
-          <a:p xmlns:a="http://schemas.openxmlformats.org/drawingml/2006/main">
-            <a:r>
-              <a:t/>
-            </a:r>
-          </a:p>
-          <a:p xmlns:a="http://schemas.openxmlformats.org/drawingml/2006/main">
-            <a:r>
-              <a:t>## 7. Preferences and an offline restart</a:t>
-            </a:r>
-          </a:p>
-          <a:p xmlns:a="http://schemas.openxmlformats.org/drawingml/2006/main">
-            <a:r>
-              <a:t/>
-            </a:r>
-          </a:p>
-          <a:p xmlns:a="http://schemas.openxmlformats.org/drawingml/2006/main">
-            <a:r>
-              <a:t>**Show:** In Settings move the budget slider from **10.00** to **13.50**, then enable dark mode. Turn on the emulator's airplane mode and explicitly turn Wi-Fi off. Open Android App info for Budget Bites, choose **Force stop** and confirm. Relaunch the app. Show $13.50 and dark mode in Settings. Open History and reselect Showcase Lunch to show three receipts and $18.00.</a:t>
-            </a:r>
-          </a:p>
-          <a:p xmlns:a="http://schemas.openxmlformats.org/drawingml/2006/main">
-            <a:r>
-              <a:t/>
-            </a:r>
-          </a:p>
-          <a:p xmlns:a="http://schemas.openxmlformats.org/drawingml/2006/main">
-            <a:r>
-              <a:t>&gt; Settings saves the budget and display preference locally. I am now turning off networking and restarting the app's process. After relaunch, the budget and dark mode remain saved. The three purchase records and their total are also still available. This demonstrates persistence through the running release app, with SQLite storing the records and SharedPreferences storing the simple settings.</a:t>
-            </a:r>
-          </a:p>
-          <a:p xmlns:a="http://schemas.openxmlformats.org/drawingml/2006/main">
-            <a:r>
-              <a:t/>
-            </a:r>
-          </a:p>
-          <a:p xmlns:a="http://schemas.openxmlformats.org/drawingml/2006/main">
-            <a:r>
-              <a:t>## 8. Close and invite questions</a:t>
-            </a:r>
-          </a:p>
-          <a:p xmlns:a="http://schemas.openxmlformats.org/drawingml/2006/main">
-            <a:r>
-              <a:t/>
-            </a:r>
-          </a:p>
-          <a:p xmlns:a="http://schemas.openxmlformats.org/drawingml/2006/main">
-            <a:r>
-              <a:t>**Show:** Keep History or the helper card visible, then return to the call or recording view.</a:t>
-            </a:r>
-          </a:p>
-          <a:p xmlns:a="http://schemas.openxmlformats.org/drawingml/2006/main">
-            <a:r>
-              <a:t/>
-            </a:r>
-          </a:p>
-          <a:p xmlns:a="http://schemas.openxmlformats.org/drawingml/2006/main">
-            <a:r>
-              <a:t>&gt; This completes the walkthrough of meal management, actual purchase history, the local helper and offline persistence. Thank you for watching. We are ready to answer questions about our individual work and the implementation.</a:t>
-            </a:r>
-          </a:p>
-          <a:p xmlns:a="http://schemas.openxmlformats.org/drawingml/2006/main">
-            <a:r>
-              <a:t/>
-            </a:r>
-          </a:p>
-          <a:p xmlns:a="http://schemas.openxmlformats.org/drawingml/2006/main">
-            <a:r>
-              <a:t>---</a:t>
-            </a:r>
-          </a:p>
-          <a:p xmlns:a="http://schemas.openxmlformats.org/drawingml/2006/main">
-            <a:r>
-              <a:t/>
-            </a:r>
-          </a:p>
-          <a:p xmlns:a="http://schemas.openxmlformats.org/drawingml/2006/main">
-            <a:r>
-              <a:t>## Rehearsal checks, not spoken</a:t>
-            </a:r>
-          </a:p>
-          <a:p xmlns:a="http://schemas.openxmlformats.org/drawingml/2006/main">
-            <a:r>
-              <a:t/>
-            </a:r>
-          </a:p>
-          <a:p xmlns:a="http://schemas.openxmlformats.org/drawingml/2006/main">
-            <a:r>
-              <a:t>- Verify the three receipts really are $6.00, $4.50 and $7.50 before showing the helper. Keep their timestamps earlier than the activity's selected time. Do not promise a fixed receipt ID.</a:t>
-            </a:r>
-          </a:p>
-          <a:p xmlns:a="http://schemas.openxmlformats.org/drawingml/2006/main">
-            <a:r>
-              <a:t>- If other data exists, use the meal filter before citing the $18.00 total. A new installation intentionally has no purchase history.</a:t>
-            </a:r>
-          </a:p>
-          <a:p xmlns:a="http://schemas.openxmlformats.org/drawingml/2006/main">
-            <a:r>
-              <a:t>- On an insufficient-history card, create the three demonstration receipts rather than claiming that an estimate is present.</a:t>
-            </a:r>
-          </a:p>
-          <a:p xmlns:a="http://schemas.openxmlformats.org/drawingml/2006/main">
-            <a:r>
-              <a:t>- For an unlinked meal-delete example, create a separate temporary meal with no receipts, delete it and confirm. Do not remove the meal used for the persistence demonstration.</a:t>
-            </a:r>
-          </a:p>
-          <a:p xmlns:a="http://schemas.openxmlformats.org/drawingml/2006/main">
-            <a:r>
-              <a:t>- If a control needs more time, continue describing the visible state. The steps are a rehearsal plan, not a claim that a new recording has already been completed.</a:t>
-            </a:r>
-          </a:p>
-          <a:p xmlns:a="http://schemas.openxmlformats.org/drawingml/2006/main">
-            <a:r>
-              <a:t>- The earlier three silent emulator clips remain available as backups. This revision uses a live app demo after the slides.</a:t>
-            </a:r>
-          </a:p>
-          <a:p xmlns:a="http://schemas.openxmlformats.org/drawingml/2006/main">
-            <a:r>
-              <a:t/>
             </a:r>
           </a:p>
         </p:txBody>
@@ -3799,7 +2784,7 @@
           </a:p>
           <a:p xmlns:a="http://schemas.openxmlformats.org/drawingml/2006/main">
             <a:r>
-              <a:t>Read aloud:</a:t>
+              <a:t/>
             </a:r>
           </a:p>
           <a:p xmlns:a="http://schemas.openxmlformats.org/drawingml/2006/main">
@@ -3834,42 +2819,17 @@
           </a:p>
           <a:p xmlns:a="http://schemas.openxmlformats.org/drawingml/2006/main">
             <a:r>
-              <a:t>Visuals support this narration. Code excerpts are actual source with whitespace wrapped for slide readability. Screenshots are real release captures with fictional examples.</a:t>
-            </a:r>
-          </a:p>
-          <a:p xmlns:a="http://schemas.openxmlformats.org/drawingml/2006/main">
-            <a:r>
               <a:t>Questions: D1, D2, R4.</a:t>
             </a:r>
           </a:p>
           <a:p xmlns:a="http://schemas.openxmlformats.org/drawingml/2006/main">
             <a:r>
+              <a:t/>
+            </a:r>
+          </a:p>
+          <a:p xmlns:a="http://schemas.openxmlformats.org/drawingml/2006/main">
+            <a:r>
               <a:t>Sources: https://github.com/Omswaroopreddyudumula/ajxom-budget-bites; ARCHITECTURE.md; AI_FEATURE.md; docs/CONTRIBUTIONS.md; docs/TEST_RESULTS.md; final-prefixed evidence logs.</a:t>
-            </a:r>
-          </a:p>
-          <a:p xmlns:a="http://schemas.openxmlformats.org/drawingml/2006/main">
-            <a:r>
-              <a:t>Visual/code sources: .</a:t>
-            </a:r>
-          </a:p>
-          <a:p xmlns:a="http://schemas.openxmlformats.org/drawingml/2006/main">
-            <a:r>
-              <a:t>Frame provenance is recorded in the private presentation build assets.</a:t>
-            </a:r>
-          </a:p>
-          <a:p xmlns:a="http://schemas.openxmlformats.org/drawingml/2006/main">
-            <a:r>
-              <a:t>Rehearse the full recording with the live demo within 20–25 minutes.</a:t>
-            </a:r>
-          </a:p>
-          <a:p xmlns:a="http://schemas.openxmlformats.org/drawingml/2006/main">
-            <a:r>
-              <a:t/>
-            </a:r>
-          </a:p>
-          <a:p xmlns:a="http://schemas.openxmlformats.org/drawingml/2006/main">
-            <a:r>
-              <a:t>Speaker plan: Om presents slides 1–4 and 14–16 (about 4–5 minutes total). A.J. presents slides 5–13 and 17–28 and narrates the full app demo. Presentation leadership does not change code authorship.</a:t>
             </a:r>
           </a:p>
         </p:txBody>
@@ -3944,57 +2904,22 @@
           </a:p>
           <a:p xmlns:a="http://schemas.openxmlformats.org/drawingml/2006/main">
             <a:r>
-              <a:t>Read aloud:</a:t>
-            </a:r>
-          </a:p>
-          <a:p xmlns:a="http://schemas.openxmlformats.org/drawingml/2006/main">
-            <a:r>
-              <a:t>These are actual screens from the release app. The catalog, reusable editor, activity, purchase log and settings form one connected offline workflow. A.J. will now explain the architecture and backend.</a:t>
-            </a:r>
-          </a:p>
-          <a:p xmlns:a="http://schemas.openxmlformats.org/drawingml/2006/main">
-            <a:r>
               <a:t/>
             </a:r>
           </a:p>
           <a:p xmlns:a="http://schemas.openxmlformats.org/drawingml/2006/main">
             <a:r>
-              <a:t>Visuals support this narration. Code excerpts are actual source with whitespace wrapped for slide readability. Screenshots are real release captures with fictional examples.</a:t>
-            </a:r>
-          </a:p>
-          <a:p xmlns:a="http://schemas.openxmlformats.org/drawingml/2006/main">
-            <a:r>
               <a:t>Questions: I1, D1.</a:t>
             </a:r>
           </a:p>
           <a:p xmlns:a="http://schemas.openxmlformats.org/drawingml/2006/main">
             <a:r>
+              <a:t/>
+            </a:r>
+          </a:p>
+          <a:p xmlns:a="http://schemas.openxmlformats.org/drawingml/2006/main">
+            <a:r>
               <a:t>Sources: https://github.com/Omswaroopreddyudumula/ajxom-budget-bites; ARCHITECTURE.md; AI_FEATURE.md; docs/CONTRIBUTIONS.md; docs/TEST_RESULTS.md; final-prefixed evidence logs.</a:t>
-            </a:r>
-          </a:p>
-          <a:p xmlns:a="http://schemas.openxmlformats.org/drawingml/2006/main">
-            <a:r>
-              <a:t>Visual/code sources: /Users/omswaroopudumula/Documents/Codex/2026-10-14/referenced-chatgpt-conversation-this-is-an/work/visual-presentation/assets/activity.png; /Users/omswaroopudumula/Documents/Codex/2026-10-14/referenced-chatgpt-conversation-this-is-an/work/visual-presentation/assets/new-meal-complete.png; /Users/omswaroopudumula/Documents/Codex/2026-10-14/referenced-chatgpt-conversation-this-is-an/work/visual-presentation/assets/purchase-form.png; /Users/omswaroopudumula/Documents/Codex/2026-10-14/referenced-chatgpt-conversation-this-is-an/work/visual-presentation/assets/two-receipts.png; /Users/omswaroopudumula/Documents/Codex/2026-10-14/referenced-chatgpt-conversation-this-is-an/work/visual-presentation/assets/settings.png.</a:t>
-            </a:r>
-          </a:p>
-          <a:p xmlns:a="http://schemas.openxmlformats.org/drawingml/2006/main">
-            <a:r>
-              <a:t>Frame provenance is recorded in the private presentation build assets.</a:t>
-            </a:r>
-          </a:p>
-          <a:p xmlns:a="http://schemas.openxmlformats.org/drawingml/2006/main">
-            <a:r>
-              <a:t>Rehearse the full recording with the live demo within 20–25 minutes.</a:t>
-            </a:r>
-          </a:p>
-          <a:p xmlns:a="http://schemas.openxmlformats.org/drawingml/2006/main">
-            <a:r>
-              <a:t/>
-            </a:r>
-          </a:p>
-          <a:p xmlns:a="http://schemas.openxmlformats.org/drawingml/2006/main">
-            <a:r>
-              <a:t>Speaker plan: Om presents slides 1–4 and 14–16 (about 4–5 minutes total). A.J. presents slides 5–13 and 17–28 and narrates the full app demo. Presentation leadership does not change code authorship.</a:t>
             </a:r>
           </a:p>
         </p:txBody>
@@ -4069,22 +2994,12 @@
           </a:p>
           <a:p xmlns:a="http://schemas.openxmlformats.org/drawingml/2006/main">
             <a:r>
-              <a:t>Read aloud:</a:t>
-            </a:r>
-          </a:p>
-          <a:p xmlns:a="http://schemas.openxmlformats.org/drawingml/2006/main">
-            <a:r>
-              <a:t>We divided the work around the data foundation and the user experience. I contributed the original Meal model, database CRUD functions and standalone History page. Om's work focused on the frontend and the feature branch that connected the screens, purchase records, preferences, helper and tests.</a:t>
-            </a:r>
-          </a:p>
-          <a:p xmlns:a="http://schemas.openxmlformats.org/drawingml/2006/main">
-            <a:r>
               <a:t/>
             </a:r>
           </a:p>
           <a:p xmlns:a="http://schemas.openxmlformats.org/drawingml/2006/main">
             <a:r>
-              <a:t>Screens handle interaction, AppStore shares saved values and MealDatabase manages SQLite. Independent Dart functions handle money parsing and Lunch Lens, keeping calculation rules separate from widgets.</a:t>
+              <a:t>Questions: A1, R1.</a:t>
             </a:r>
           </a:p>
           <a:p xmlns:a="http://schemas.openxmlformats.org/drawingml/2006/main">
@@ -4094,52 +3009,7 @@
           </a:p>
           <a:p xmlns:a="http://schemas.openxmlformats.org/drawingml/2006/main">
             <a:r>
-              <a:t>This separation helped us combine both parts of the project without putting SQL inside every screen. We preserved my original branch history during integration. I will now explain the backend foundation and how the final application stores and protects its records.</a:t>
-            </a:r>
-          </a:p>
-          <a:p xmlns:a="http://schemas.openxmlformats.org/drawingml/2006/main">
-            <a:r>
-              <a:t/>
-            </a:r>
-          </a:p>
-          <a:p xmlns:a="http://schemas.openxmlformats.org/drawingml/2006/main">
-            <a:r>
-              <a:t>Visuals support this narration. Code excerpts are actual source with whitespace wrapped for slide readability. Screenshots are real release captures with fictional examples.</a:t>
-            </a:r>
-          </a:p>
-          <a:p xmlns:a="http://schemas.openxmlformats.org/drawingml/2006/main">
-            <a:r>
-              <a:t>Questions: A1, R1.</a:t>
-            </a:r>
-          </a:p>
-          <a:p xmlns:a="http://schemas.openxmlformats.org/drawingml/2006/main">
-            <a:r>
               <a:t>Sources: https://github.com/Omswaroopreddyudumula/ajxom-budget-bites; ARCHITECTURE.md; AI_FEATURE.md; docs/CONTRIBUTIONS.md; docs/TEST_RESULTS.md; final-prefixed evidence logs.</a:t>
-            </a:r>
-          </a:p>
-          <a:p xmlns:a="http://schemas.openxmlformats.org/drawingml/2006/main">
-            <a:r>
-              <a:t>Visual/code sources: .</a:t>
-            </a:r>
-          </a:p>
-          <a:p xmlns:a="http://schemas.openxmlformats.org/drawingml/2006/main">
-            <a:r>
-              <a:t>Frame provenance is recorded in the private presentation build assets.</a:t>
-            </a:r>
-          </a:p>
-          <a:p xmlns:a="http://schemas.openxmlformats.org/drawingml/2006/main">
-            <a:r>
-              <a:t>Rehearse the full recording with the live demo within 20–25 minutes.</a:t>
-            </a:r>
-          </a:p>
-          <a:p xmlns:a="http://schemas.openxmlformats.org/drawingml/2006/main">
-            <a:r>
-              <a:t/>
-            </a:r>
-          </a:p>
-          <a:p xmlns:a="http://schemas.openxmlformats.org/drawingml/2006/main">
-            <a:r>
-              <a:t>Speaker plan: Om presents slides 1–4 and 14–16 (about 4–5 minutes total). A.J. presents slides 5–13 and 17–28 and narrates the full app demo. Presentation leadership does not change code authorship.</a:t>
             </a:r>
           </a:p>
         </p:txBody>
@@ -4214,7 +3084,7 @@
           </a:p>
           <a:p xmlns:a="http://schemas.openxmlformats.org/drawingml/2006/main">
             <a:r>
-              <a:t>Read aloud:</a:t>
+              <a:t/>
             </a:r>
           </a:p>
           <a:p xmlns:a="http://schemas.openxmlformats.org/drawingml/2006/main">
@@ -4249,42 +3119,17 @@
           </a:p>
           <a:p xmlns:a="http://schemas.openxmlformats.org/drawingml/2006/main">
             <a:r>
-              <a:t>Visuals support this narration. Code excerpts are actual source with whitespace wrapped for slide readability. Screenshots are real release captures with fictional examples.</a:t>
-            </a:r>
-          </a:p>
-          <a:p xmlns:a="http://schemas.openxmlformats.org/drawingml/2006/main">
-            <a:r>
               <a:t>Questions: A1, R1.</a:t>
             </a:r>
           </a:p>
           <a:p xmlns:a="http://schemas.openxmlformats.org/drawingml/2006/main">
             <a:r>
+              <a:t/>
+            </a:r>
+          </a:p>
+          <a:p xmlns:a="http://schemas.openxmlformats.org/drawingml/2006/main">
+            <a:r>
               <a:t>Sources: https://github.com/Omswaroopreddyudumula/ajxom-budget-bites; ARCHITECTURE.md; AI_FEATURE.md; docs/CONTRIBUTIONS.md; docs/TEST_RESULTS.md; final-prefixed evidence logs.</a:t>
-            </a:r>
-          </a:p>
-          <a:p xmlns:a="http://schemas.openxmlformats.org/drawingml/2006/main">
-            <a:r>
-              <a:t>Visual/code sources: lib/data/meal_database.dart.</a:t>
-            </a:r>
-          </a:p>
-          <a:p xmlns:a="http://schemas.openxmlformats.org/drawingml/2006/main">
-            <a:r>
-              <a:t>Frame provenance is recorded in the private presentation build assets.</a:t>
-            </a:r>
-          </a:p>
-          <a:p xmlns:a="http://schemas.openxmlformats.org/drawingml/2006/main">
-            <a:r>
-              <a:t>Rehearse the full recording with the live demo within 20–25 minutes.</a:t>
-            </a:r>
-          </a:p>
-          <a:p xmlns:a="http://schemas.openxmlformats.org/drawingml/2006/main">
-            <a:r>
-              <a:t/>
-            </a:r>
-          </a:p>
-          <a:p xmlns:a="http://schemas.openxmlformats.org/drawingml/2006/main">
-            <a:r>
-              <a:t>Speaker plan: Om presents slides 1–4 and 14–16 (about 4–5 minutes total). A.J. presents slides 5–13 and 17–28 and narrates the full app demo. Presentation leadership does not change code authorship.</a:t>
             </a:r>
           </a:p>
         </p:txBody>
@@ -4359,22 +3204,12 @@
           </a:p>
           <a:p xmlns:a="http://schemas.openxmlformats.org/drawingml/2006/main">
             <a:r>
-              <a:t>Read aloud:</a:t>
-            </a:r>
-          </a:p>
-          <a:p xmlns:a="http://schemas.openxmlformats.org/drawingml/2006/main">
-            <a:r>
-              <a:t>The Meal model represents an entry in the student's personal catalog. It contains a generated ID, meal name, venue note and cuisine. It also stores labels and estimated prices for an entree, a side and another optional item, plus a favorite flag.</a:t>
-            </a:r>
-          </a:p>
-          <a:p xmlns:a="http://schemas.openxmlformats.org/drawingml/2006/main">
-            <a:r>
               <a:t/>
             </a:r>
           </a:p>
           <a:p xmlns:a="http://schemas.openxmlformats.org/drawingml/2006/main">
             <a:r>
-              <a:t>The final model derives the total estimate by adding the three item prices. It stores prices as integer cents, so a value of 650 represents six dollars and fifty cents. This makes money calculations consistent with the values used by the purchase log.</a:t>
+              <a:t>Questions: D1.</a:t>
             </a:r>
           </a:p>
           <a:p xmlns:a="http://schemas.openxmlformats.org/drawingml/2006/main">
@@ -4384,52 +3219,7 @@
           </a:p>
           <a:p xmlns:a="http://schemas.openxmlformats.org/drawingml/2006/main">
             <a:r>
-              <a:t>The toMap method prepares values for SQLite, and fromMap reconstructs the Meal. A stable ID lets the interface update the correct record even after its name or position changes.</a:t>
-            </a:r>
-          </a:p>
-          <a:p xmlns:a="http://schemas.openxmlformats.org/drawingml/2006/main">
-            <a:r>
-              <a:t/>
-            </a:r>
-          </a:p>
-          <a:p xmlns:a="http://schemas.openxmlformats.org/drawingml/2006/main">
-            <a:r>
-              <a:t>Visuals support this narration. Code excerpts are actual source with whitespace wrapped for slide readability. Screenshots are real release captures with fictional examples.</a:t>
-            </a:r>
-          </a:p>
-          <a:p xmlns:a="http://schemas.openxmlformats.org/drawingml/2006/main">
-            <a:r>
-              <a:t>Questions: D1.</a:t>
-            </a:r>
-          </a:p>
-          <a:p xmlns:a="http://schemas.openxmlformats.org/drawingml/2006/main">
-            <a:r>
               <a:t>Sources: https://github.com/Omswaroopreddyudumula/ajxom-budget-bites; ARCHITECTURE.md; AI_FEATURE.md; docs/CONTRIBUTIONS.md; docs/TEST_RESULTS.md; final-prefixed evidence logs.</a:t>
-            </a:r>
-          </a:p>
-          <a:p xmlns:a="http://schemas.openxmlformats.org/drawingml/2006/main">
-            <a:r>
-              <a:t>Visual/code sources: lib/models/meal.dart.</a:t>
-            </a:r>
-          </a:p>
-          <a:p xmlns:a="http://schemas.openxmlformats.org/drawingml/2006/main">
-            <a:r>
-              <a:t>Frame provenance is recorded in the private presentation build assets.</a:t>
-            </a:r>
-          </a:p>
-          <a:p xmlns:a="http://schemas.openxmlformats.org/drawingml/2006/main">
-            <a:r>
-              <a:t>Rehearse the full recording with the live demo within 20–25 minutes.</a:t>
-            </a:r>
-          </a:p>
-          <a:p xmlns:a="http://schemas.openxmlformats.org/drawingml/2006/main">
-            <a:r>
-              <a:t/>
-            </a:r>
-          </a:p>
-          <a:p xmlns:a="http://schemas.openxmlformats.org/drawingml/2006/main">
-            <a:r>
-              <a:t>Speaker plan: Om presents slides 1–4 and 14–16 (about 4–5 minutes total). A.J. presents slides 5–13 and 17–28 and narrates the full app demo. Presentation leadership does not change code authorship.</a:t>
             </a:r>
           </a:p>
         </p:txBody>
@@ -4504,7 +3294,7 @@
           </a:p>
           <a:p xmlns:a="http://schemas.openxmlformats.org/drawingml/2006/main">
             <a:r>
-              <a:t>Read aloud:</a:t>
+              <a:t/>
             </a:r>
           </a:p>
           <a:p xmlns:a="http://schemas.openxmlformats.org/drawingml/2006/main">
@@ -4539,42 +3329,17 @@
           </a:p>
           <a:p xmlns:a="http://schemas.openxmlformats.org/drawingml/2006/main">
             <a:r>
-              <a:t>Visuals support this narration. Code excerpts are actual source with whitespace wrapped for slide readability. Screenshots are real release captures with fictional examples.</a:t>
-            </a:r>
-          </a:p>
-          <a:p xmlns:a="http://schemas.openxmlformats.org/drawingml/2006/main">
-            <a:r>
               <a:t>Questions: D1.</a:t>
             </a:r>
           </a:p>
           <a:p xmlns:a="http://schemas.openxmlformats.org/drawingml/2006/main">
             <a:r>
+              <a:t/>
+            </a:r>
+          </a:p>
+          <a:p xmlns:a="http://schemas.openxmlformats.org/drawingml/2006/main">
+            <a:r>
               <a:t>Sources: https://github.com/Omswaroopreddyudumula/ajxom-budget-bites; ARCHITECTURE.md; AI_FEATURE.md; docs/CONTRIBUTIONS.md; docs/TEST_RESULTS.md; final-prefixed evidence logs.</a:t>
-            </a:r>
-          </a:p>
-          <a:p xmlns:a="http://schemas.openxmlformats.org/drawingml/2006/main">
-            <a:r>
-              <a:t>Visual/code sources: /Users/omswaroopudumula/Documents/Codex/2026-10-14/referenced-chatgpt-conversation-this-is-an/work/visual-presentation/assets/correction.png.</a:t>
-            </a:r>
-          </a:p>
-          <a:p xmlns:a="http://schemas.openxmlformats.org/drawingml/2006/main">
-            <a:r>
-              <a:t>Frame provenance is recorded in the private presentation build assets.</a:t>
-            </a:r>
-          </a:p>
-          <a:p xmlns:a="http://schemas.openxmlformats.org/drawingml/2006/main">
-            <a:r>
-              <a:t>Rehearse the full recording with the live demo within 20–25 minutes.</a:t>
-            </a:r>
-          </a:p>
-          <a:p xmlns:a="http://schemas.openxmlformats.org/drawingml/2006/main">
-            <a:r>
-              <a:t/>
-            </a:r>
-          </a:p>
-          <a:p xmlns:a="http://schemas.openxmlformats.org/drawingml/2006/main">
-            <a:r>
-              <a:t>Speaker plan: Om presents slides 1–4 and 14–16 (about 4–5 minutes total). A.J. presents slides 5–13 and 17–28 and narrates the full app demo. Presentation leadership does not change code authorship.</a:t>
             </a:r>
           </a:p>
         </p:txBody>
@@ -4649,57 +3414,22 @@
           </a:p>
           <a:p xmlns:a="http://schemas.openxmlformats.org/drawingml/2006/main">
             <a:r>
-              <a:t>Read aloud:</a:t>
-            </a:r>
-          </a:p>
-          <a:p xmlns:a="http://schemas.openxmlformats.org/drawingml/2006/main">
-            <a:r>
-              <a:t>Meal is the parent catalog entry. PurchaseLog stores each actual receipt. Its foreign key and restricted parent deletion preserve that relationship.</a:t>
-            </a:r>
-          </a:p>
-          <a:p xmlns:a="http://schemas.openxmlformats.org/drawingml/2006/main">
-            <a:r>
               <a:t/>
             </a:r>
           </a:p>
           <a:p xmlns:a="http://schemas.openxmlformats.org/drawingml/2006/main">
             <a:r>
-              <a:t>Visuals support this narration. Code excerpts are actual source with whitespace wrapped for slide readability. Screenshots are real release captures with fictional examples.</a:t>
-            </a:r>
-          </a:p>
-          <a:p xmlns:a="http://schemas.openxmlformats.org/drawingml/2006/main">
-            <a:r>
               <a:t>Questions: D1.</a:t>
             </a:r>
           </a:p>
           <a:p xmlns:a="http://schemas.openxmlformats.org/drawingml/2006/main">
             <a:r>
+              <a:t/>
+            </a:r>
+          </a:p>
+          <a:p xmlns:a="http://schemas.openxmlformats.org/drawingml/2006/main">
+            <a:r>
               <a:t>Sources: https://github.com/Omswaroopreddyudumula/ajxom-budget-bites; ARCHITECTURE.md; AI_FEATURE.md; docs/CONTRIBUTIONS.md; docs/TEST_RESULTS.md; final-prefixed evidence logs.</a:t>
-            </a:r>
-          </a:p>
-          <a:p xmlns:a="http://schemas.openxmlformats.org/drawingml/2006/main">
-            <a:r>
-              <a:t>Visual/code sources: .</a:t>
-            </a:r>
-          </a:p>
-          <a:p xmlns:a="http://schemas.openxmlformats.org/drawingml/2006/main">
-            <a:r>
-              <a:t>Frame provenance is recorded in the private presentation build assets.</a:t>
-            </a:r>
-          </a:p>
-          <a:p xmlns:a="http://schemas.openxmlformats.org/drawingml/2006/main">
-            <a:r>
-              <a:t>Rehearse the full recording with the live demo within 20–25 minutes.</a:t>
-            </a:r>
-          </a:p>
-          <a:p xmlns:a="http://schemas.openxmlformats.org/drawingml/2006/main">
-            <a:r>
-              <a:t/>
-            </a:r>
-          </a:p>
-          <a:p xmlns:a="http://schemas.openxmlformats.org/drawingml/2006/main">
-            <a:r>
-              <a:t>Speaker plan: Om presents slides 1–4 and 14–16 (about 4–5 minutes total). A.J. presents slides 5–13 and 17–28 and narrates the full app demo. Presentation leadership does not change code authorship.</a:t>
             </a:r>
           </a:p>
         </p:txBody>
@@ -7142,12 +5872,12 @@
   </p:cSld>
   <p:clrMap bg1="lt1" tx1="dk1" bg2="lt2" tx2="dk2" accent1="accent1" accent2="accent2" accent3="accent3" accent4="accent4" accent5="accent5" accent6="accent6" hlink="hlink" folHlink="folHlink"/>
   <p:sldLayoutIdLst>
-    <p:sldLayoutId xmlns:r="http://schemas.openxmlformats.org/officeDocument/2006/relationships" id="2147483649" r:id="Rc5e3ee7467124200"/>
-    <p:sldLayoutId xmlns:r="http://schemas.openxmlformats.org/officeDocument/2006/relationships" id="2147483650" r:id="R54bd08de30384167"/>
-    <p:sldLayoutId xmlns:r="http://schemas.openxmlformats.org/officeDocument/2006/relationships" id="2147483651" r:id="R526b91d6b65440ab"/>
-    <p:sldLayoutId xmlns:r="http://schemas.openxmlformats.org/officeDocument/2006/relationships" id="2147483652" r:id="R95986136d75a4f15"/>
-    <p:sldLayoutId xmlns:r="http://schemas.openxmlformats.org/officeDocument/2006/relationships" id="2147483653" r:id="R0a46196606a24675"/>
-    <p:sldLayoutId xmlns:r="http://schemas.openxmlformats.org/officeDocument/2006/relationships" id="2147483654" r:id="Rf5cc2477e4a14231"/>
+    <p:sldLayoutId xmlns:r="http://schemas.openxmlformats.org/officeDocument/2006/relationships" id="2147483649" r:id="R231ea580e8d04415"/>
+    <p:sldLayoutId xmlns:r="http://schemas.openxmlformats.org/officeDocument/2006/relationships" id="2147483650" r:id="Rf2bd7def17a546be"/>
+    <p:sldLayoutId xmlns:r="http://schemas.openxmlformats.org/officeDocument/2006/relationships" id="2147483651" r:id="R1ff7c8aa07f342a4"/>
+    <p:sldLayoutId xmlns:r="http://schemas.openxmlformats.org/officeDocument/2006/relationships" id="2147483652" r:id="Re155bae85dab4da4"/>
+    <p:sldLayoutId xmlns:r="http://schemas.openxmlformats.org/officeDocument/2006/relationships" id="2147483653" r:id="Rd20040b49eb0469e"/>
+    <p:sldLayoutId xmlns:r="http://schemas.openxmlformats.org/officeDocument/2006/relationships" id="2147483654" r:id="Rfd569d08319f4fc8"/>
   </p:sldLayoutIdLst>
   <p:txStyles>
     <p:titleStyle>
@@ -8827,7 +7557,7 @@
           <p:cNvPr id="6" name="">
             <a:extLst xmlns:a="http://schemas.openxmlformats.org/drawingml/2006/main">
               <a:ext uri="{FF2B5EF4-FFF2-40B4-BE49-F238E27FC236}">
-                <a16:creationId xmlns:a16="http://schemas.microsoft.com/office/drawing/2014/main" id="{C3CE75D1-1D84-48DD-8025-E5C65F4CD00A}"/>
+                <a16:creationId xmlns:a16="http://schemas.microsoft.com/office/drawing/2014/main" id="{8B7DD4F7-0FCF-4422-9A87-8F4852FDBE56}"/>
               </a:ext>
             </a:extLst>
           </p:cNvPr>
@@ -8837,7 +7567,7 @@
           <p:nvPr/>
         </p:nvPicPr>
         <p:blipFill>
-          <a:blip xmlns:r="http://schemas.openxmlformats.org/officeDocument/2006/relationships" xmlns:a="http://schemas.openxmlformats.org/drawingml/2006/main" r:embed="R584b0e0af8af430f"/>
+          <a:blip xmlns:r="http://schemas.openxmlformats.org/officeDocument/2006/relationships" xmlns:a="http://schemas.openxmlformats.org/drawingml/2006/main" r:embed="Rf6e8d3813bc14e68"/>
           <a:stretch xmlns:a="http://schemas.openxmlformats.org/drawingml/2006/main"/>
         </p:blipFill>
         <p:spPr>
@@ -8855,7 +7585,7 @@
           <p:cNvPr id="7" name="">
             <a:extLst xmlns:a="http://schemas.openxmlformats.org/drawingml/2006/main">
               <a:ext uri="{FF2B5EF4-FFF2-40B4-BE49-F238E27FC236}">
-                <a16:creationId xmlns:a16="http://schemas.microsoft.com/office/drawing/2014/main" id="{AEE0C344-DE49-452A-A5E8-CBCF72AD0F6C}"/>
+                <a16:creationId xmlns:a16="http://schemas.microsoft.com/office/drawing/2014/main" id="{3C1112F9-6CD0-4AD1-B279-A86B61105314}"/>
               </a:ext>
             </a:extLst>
           </p:cNvPr>
@@ -8865,7 +7595,7 @@
           <p:nvPr/>
         </p:nvPicPr>
         <p:blipFill>
-          <a:blip xmlns:r="http://schemas.openxmlformats.org/officeDocument/2006/relationships" xmlns:a="http://schemas.openxmlformats.org/drawingml/2006/main" r:embed="R287b9904d4134c00"/>
+          <a:blip xmlns:r="http://schemas.openxmlformats.org/officeDocument/2006/relationships" xmlns:a="http://schemas.openxmlformats.org/drawingml/2006/main" r:embed="Rf38184f7890e4873"/>
           <a:stretch xmlns:a="http://schemas.openxmlformats.org/drawingml/2006/main"/>
         </p:blipFill>
         <p:spPr>
@@ -16334,7 +15064,7 @@
           <p:cNvPr id="7" name="">
             <a:extLst xmlns:a="http://schemas.openxmlformats.org/drawingml/2006/main">
               <a:ext uri="{FF2B5EF4-FFF2-40B4-BE49-F238E27FC236}">
-                <a16:creationId xmlns:a16="http://schemas.microsoft.com/office/drawing/2014/main" id="{62E3CA1A-74E7-4FAA-8056-A9303CF8BB73}"/>
+                <a16:creationId xmlns:a16="http://schemas.microsoft.com/office/drawing/2014/main" id="{E1820E8F-1CCD-4438-8993-AE2E047F6C80}"/>
               </a:ext>
             </a:extLst>
           </p:cNvPr>
@@ -16344,7 +15074,7 @@
           <p:nvPr/>
         </p:nvPicPr>
         <p:blipFill>
-          <a:blip xmlns:r="http://schemas.openxmlformats.org/officeDocument/2006/relationships" xmlns:a="http://schemas.openxmlformats.org/drawingml/2006/main" r:embed="R66ea30d4df6c4388"/>
+          <a:blip xmlns:r="http://schemas.openxmlformats.org/officeDocument/2006/relationships" xmlns:a="http://schemas.openxmlformats.org/drawingml/2006/main" r:embed="R6ac8423a31c248e7"/>
           <a:stretch xmlns:a="http://schemas.openxmlformats.org/drawingml/2006/main"/>
         </p:blipFill>
         <p:spPr>
@@ -18967,7 +17697,7 @@
           <p:cNvPr id="7" name="">
             <a:extLst xmlns:a="http://schemas.openxmlformats.org/drawingml/2006/main">
               <a:ext uri="{FF2B5EF4-FFF2-40B4-BE49-F238E27FC236}">
-                <a16:creationId xmlns:a16="http://schemas.microsoft.com/office/drawing/2014/main" id="{3A4D4157-D518-4D02-95B5-E463091C2163}"/>
+                <a16:creationId xmlns:a16="http://schemas.microsoft.com/office/drawing/2014/main" id="{D7848EAB-E856-424D-A61A-ADE79331D797}"/>
               </a:ext>
             </a:extLst>
           </p:cNvPr>
@@ -18977,7 +17707,7 @@
           <p:nvPr/>
         </p:nvPicPr>
         <p:blipFill>
-          <a:blip xmlns:r="http://schemas.openxmlformats.org/officeDocument/2006/relationships" xmlns:a="http://schemas.openxmlformats.org/drawingml/2006/main" r:embed="Rc505e338ed8f4765"/>
+          <a:blip xmlns:r="http://schemas.openxmlformats.org/officeDocument/2006/relationships" xmlns:a="http://schemas.openxmlformats.org/drawingml/2006/main" r:embed="Rb9f803e7a19743ad"/>
           <a:srcRect xmlns:a="http://schemas.openxmlformats.org/drawingml/2006/main" l="4000" t="32500" r="4000" b="50000"/>
           <a:stretch xmlns:a="http://schemas.openxmlformats.org/drawingml/2006/main"/>
         </p:blipFill>
@@ -19162,7 +17892,7 @@
           <p:cNvPr id="9" name="">
             <a:extLst xmlns:a="http://schemas.openxmlformats.org/drawingml/2006/main">
               <a:ext uri="{FF2B5EF4-FFF2-40B4-BE49-F238E27FC236}">
-                <a16:creationId xmlns:a16="http://schemas.microsoft.com/office/drawing/2014/main" id="{4283C11A-CCD5-4006-8753-21B52B4B8214}"/>
+                <a16:creationId xmlns:a16="http://schemas.microsoft.com/office/drawing/2014/main" id="{1A5C5A66-3A52-4FC5-9289-CF75F7F5676E}"/>
               </a:ext>
             </a:extLst>
           </p:cNvPr>
@@ -19172,7 +17902,7 @@
           <p:nvPr/>
         </p:nvPicPr>
         <p:blipFill>
-          <a:blip xmlns:r="http://schemas.openxmlformats.org/officeDocument/2006/relationships" xmlns:a="http://schemas.openxmlformats.org/drawingml/2006/main" r:embed="R5d9a30ae0d3b4015"/>
+          <a:blip xmlns:r="http://schemas.openxmlformats.org/officeDocument/2006/relationships" xmlns:a="http://schemas.openxmlformats.org/drawingml/2006/main" r:embed="Ra13701a29ec94018"/>
           <a:srcRect xmlns:a="http://schemas.openxmlformats.org/drawingml/2006/main" l="4000" t="86500" r="4000" b="6500"/>
           <a:stretch xmlns:a="http://schemas.openxmlformats.org/drawingml/2006/main"/>
         </p:blipFill>
@@ -20440,7 +19170,7 @@
           <p:cNvPr id="7" name="">
             <a:extLst xmlns:a="http://schemas.openxmlformats.org/drawingml/2006/main">
               <a:ext uri="{FF2B5EF4-FFF2-40B4-BE49-F238E27FC236}">
-                <a16:creationId xmlns:a16="http://schemas.microsoft.com/office/drawing/2014/main" id="{8E52C725-54F3-4461-B5F7-018BB3E53C7C}"/>
+                <a16:creationId xmlns:a16="http://schemas.microsoft.com/office/drawing/2014/main" id="{E9FB4DFA-CE81-4266-993C-8439A0101364}"/>
               </a:ext>
             </a:extLst>
           </p:cNvPr>
@@ -20450,7 +19180,7 @@
           <p:nvPr/>
         </p:nvPicPr>
         <p:blipFill>
-          <a:blip xmlns:r="http://schemas.openxmlformats.org/officeDocument/2006/relationships" xmlns:a="http://schemas.openxmlformats.org/drawingml/2006/main" r:embed="R4d70dc7425154b25"/>
+          <a:blip xmlns:r="http://schemas.openxmlformats.org/officeDocument/2006/relationships" xmlns:a="http://schemas.openxmlformats.org/drawingml/2006/main" r:embed="R352c09315d5e41b1"/>
           <a:srcRect xmlns:a="http://schemas.openxmlformats.org/drawingml/2006/main" l="8000" t="40000" r="8000" b="37000"/>
           <a:stretch xmlns:a="http://schemas.openxmlformats.org/drawingml/2006/main"/>
         </p:blipFill>
@@ -21660,7 +20390,7 @@
           <p:cNvPr id="7" name="">
             <a:extLst xmlns:a="http://schemas.openxmlformats.org/drawingml/2006/main">
               <a:ext uri="{FF2B5EF4-FFF2-40B4-BE49-F238E27FC236}">
-                <a16:creationId xmlns:a16="http://schemas.microsoft.com/office/drawing/2014/main" id="{7B4EECC4-3156-4D86-963F-05B1A8F35C97}"/>
+                <a16:creationId xmlns:a16="http://schemas.microsoft.com/office/drawing/2014/main" id="{2EEC5372-02AB-4CBD-8E5D-A82BA391F44D}"/>
               </a:ext>
             </a:extLst>
           </p:cNvPr>
@@ -21670,7 +20400,7 @@
           <p:nvPr/>
         </p:nvPicPr>
         <p:blipFill>
-          <a:blip xmlns:r="http://schemas.openxmlformats.org/officeDocument/2006/relationships" xmlns:a="http://schemas.openxmlformats.org/drawingml/2006/main" r:embed="Rf4936ab8d5c24e32"/>
+          <a:blip xmlns:r="http://schemas.openxmlformats.org/officeDocument/2006/relationships" xmlns:a="http://schemas.openxmlformats.org/drawingml/2006/main" r:embed="Rbde628fc647b458f"/>
           <a:srcRect xmlns:a="http://schemas.openxmlformats.org/drawingml/2006/main" l="2000" t="37000" r="2000" b="19000"/>
           <a:stretch xmlns:a="http://schemas.openxmlformats.org/drawingml/2006/main"/>
         </p:blipFill>
@@ -21689,7 +20419,7 @@
           <p:cNvPr id="8" name="">
             <a:extLst xmlns:a="http://schemas.openxmlformats.org/drawingml/2006/main">
               <a:ext uri="{FF2B5EF4-FFF2-40B4-BE49-F238E27FC236}">
-                <a16:creationId xmlns:a16="http://schemas.microsoft.com/office/drawing/2014/main" id="{AB3AD500-772D-4BCE-8CF5-E15D8B3C65D2}"/>
+                <a16:creationId xmlns:a16="http://schemas.microsoft.com/office/drawing/2014/main" id="{802E7A4F-DACB-4F01-95A8-C7F1D4D6B50A}"/>
               </a:ext>
             </a:extLst>
           </p:cNvPr>
@@ -21699,7 +20429,7 @@
           <p:nvPr/>
         </p:nvPicPr>
         <p:blipFill>
-          <a:blip xmlns:r="http://schemas.openxmlformats.org/officeDocument/2006/relationships" xmlns:a="http://schemas.openxmlformats.org/drawingml/2006/main" r:embed="R47efdd92d83e4cf8"/>
+          <a:blip xmlns:r="http://schemas.openxmlformats.org/officeDocument/2006/relationships" xmlns:a="http://schemas.openxmlformats.org/drawingml/2006/main" r:embed="R941541a88a874c5b"/>
           <a:srcRect xmlns:a="http://schemas.openxmlformats.org/drawingml/2006/main" l="2000" t="37000" r="2000" b="19000"/>
           <a:stretch xmlns:a="http://schemas.openxmlformats.org/drawingml/2006/main"/>
         </p:blipFill>
@@ -23357,7 +22087,7 @@
           <p:cNvPr id="7" name="">
             <a:extLst xmlns:a="http://schemas.openxmlformats.org/drawingml/2006/main">
               <a:ext uri="{FF2B5EF4-FFF2-40B4-BE49-F238E27FC236}">
-                <a16:creationId xmlns:a16="http://schemas.microsoft.com/office/drawing/2014/main" id="{004F217E-4164-4BCB-9615-3BE074D30CE2}"/>
+                <a16:creationId xmlns:a16="http://schemas.microsoft.com/office/drawing/2014/main" id="{BF4CAF4A-5A4A-4329-A3E6-3ED7EC33D4C5}"/>
               </a:ext>
             </a:extLst>
           </p:cNvPr>
@@ -23367,7 +22097,7 @@
           <p:nvPr/>
         </p:nvPicPr>
         <p:blipFill>
-          <a:blip xmlns:r="http://schemas.openxmlformats.org/officeDocument/2006/relationships" xmlns:a="http://schemas.openxmlformats.org/drawingml/2006/main" r:embed="R9bfd7dd38af147fc"/>
+          <a:blip xmlns:r="http://schemas.openxmlformats.org/officeDocument/2006/relationships" xmlns:a="http://schemas.openxmlformats.org/drawingml/2006/main" r:embed="Rb0dbd36597034b32"/>
           <a:srcRect xmlns:a="http://schemas.openxmlformats.org/drawingml/2006/main" l="4500" t="25500" r="4500" b="41500"/>
           <a:stretch xmlns:a="http://schemas.openxmlformats.org/drawingml/2006/main"/>
         </p:blipFill>
@@ -24469,7 +23199,7 @@
           <p:cNvPr id="7" name="">
             <a:extLst xmlns:a="http://schemas.openxmlformats.org/drawingml/2006/main">
               <a:ext uri="{FF2B5EF4-FFF2-40B4-BE49-F238E27FC236}">
-                <a16:creationId xmlns:a16="http://schemas.microsoft.com/office/drawing/2014/main" id="{1F07C291-4A13-4AA8-901B-81EE14237B32}"/>
+                <a16:creationId xmlns:a16="http://schemas.microsoft.com/office/drawing/2014/main" id="{58D13673-6267-4B7F-975C-E03F1E1A1CDA}"/>
               </a:ext>
             </a:extLst>
           </p:cNvPr>
@@ -24479,7 +23209,7 @@
           <p:nvPr/>
         </p:nvPicPr>
         <p:blipFill>
-          <a:blip xmlns:r="http://schemas.openxmlformats.org/officeDocument/2006/relationships" xmlns:a="http://schemas.openxmlformats.org/drawingml/2006/main" r:embed="R4a738d687ac74ff1"/>
+          <a:blip xmlns:r="http://schemas.openxmlformats.org/officeDocument/2006/relationships" xmlns:a="http://schemas.openxmlformats.org/drawingml/2006/main" r:embed="R6b6f86375def4527"/>
           <a:srcRect xmlns:a="http://schemas.openxmlformats.org/drawingml/2006/main" l="4000" t="58000" r="4000" b="17000"/>
           <a:stretch xmlns:a="http://schemas.openxmlformats.org/drawingml/2006/main"/>
         </p:blipFill>
@@ -27568,7 +26298,7 @@
           <p:cNvPr id="6" name="">
             <a:extLst xmlns:a="http://schemas.openxmlformats.org/drawingml/2006/main">
               <a:ext uri="{FF2B5EF4-FFF2-40B4-BE49-F238E27FC236}">
-                <a16:creationId xmlns:a16="http://schemas.microsoft.com/office/drawing/2014/main" id="{37D7B00D-DA2B-418B-8F65-91540CD03253}"/>
+                <a16:creationId xmlns:a16="http://schemas.microsoft.com/office/drawing/2014/main" id="{67917D69-E5B0-47CE-AB2F-2D52988824D0}"/>
               </a:ext>
             </a:extLst>
           </p:cNvPr>
@@ -29617,7 +28347,7 @@
           <p:cNvPr id="6" name="Chart">
             <a:extLst xmlns:a="http://schemas.openxmlformats.org/drawingml/2006/main">
               <a:ext uri="{FF2B5EF4-FFF2-40B4-BE49-F238E27FC236}">
-                <a16:creationId xmlns:a16="http://schemas.microsoft.com/office/drawing/2014/main" id="{18004E30-9FC1-4191-B87F-269FF50480C7}"/>
+                <a16:creationId xmlns:a16="http://schemas.microsoft.com/office/drawing/2014/main" id="{E4A26018-E4E1-4864-96C0-D61605F48E58}"/>
               </a:ext>
             </a:extLst>
           </p:cNvPr>
@@ -29630,7 +28360,7 @@
         </p:xfrm>
         <a:graphic xmlns:a="http://schemas.openxmlformats.org/drawingml/2006/main">
           <a:graphicData uri="http://schemas.openxmlformats.org/drawingml/2006/chart">
-            <c:chart xmlns:r="http://schemas.openxmlformats.org/officeDocument/2006/relationships" xmlns:c="http://schemas.openxmlformats.org/drawingml/2006/chart" r:id="R07016659867c4b84"/>
+            <c:chart xmlns:r="http://schemas.openxmlformats.org/officeDocument/2006/relationships" xmlns:c="http://schemas.openxmlformats.org/drawingml/2006/chart" r:id="R936c512f7d394d73"/>
           </a:graphicData>
         </a:graphic>
       </p:graphicFrame>
@@ -32297,7 +31027,7 @@
           <p:cNvPr id="5" name="">
             <a:extLst xmlns:a="http://schemas.openxmlformats.org/drawingml/2006/main">
               <a:ext uri="{FF2B5EF4-FFF2-40B4-BE49-F238E27FC236}">
-                <a16:creationId xmlns:a16="http://schemas.microsoft.com/office/drawing/2014/main" id="{4852E17F-BE74-4939-AE0E-88E529A18ADA}"/>
+                <a16:creationId xmlns:a16="http://schemas.microsoft.com/office/drawing/2014/main" id="{9B322801-F6B3-493C-B357-7C82F099694A}"/>
               </a:ext>
             </a:extLst>
           </p:cNvPr>
@@ -32307,7 +31037,7 @@
           <p:nvPr/>
         </p:nvPicPr>
         <p:blipFill>
-          <a:blip xmlns:r="http://schemas.openxmlformats.org/officeDocument/2006/relationships" xmlns:a="http://schemas.openxmlformats.org/drawingml/2006/main" r:embed="R66ce946204294c05"/>
+          <a:blip xmlns:r="http://schemas.openxmlformats.org/officeDocument/2006/relationships" xmlns:a="http://schemas.openxmlformats.org/drawingml/2006/main" r:embed="R371002a8c5d94f2a"/>
           <a:stretch xmlns:a="http://schemas.openxmlformats.org/drawingml/2006/main"/>
         </p:blipFill>
         <p:spPr>
@@ -32325,7 +31055,7 @@
           <p:cNvPr id="6" name="">
             <a:extLst xmlns:a="http://schemas.openxmlformats.org/drawingml/2006/main">
               <a:ext uri="{FF2B5EF4-FFF2-40B4-BE49-F238E27FC236}">
-                <a16:creationId xmlns:a16="http://schemas.microsoft.com/office/drawing/2014/main" id="{241C1799-5FA7-4FDB-AFC1-C1ADCB2F3D4B}"/>
+                <a16:creationId xmlns:a16="http://schemas.microsoft.com/office/drawing/2014/main" id="{F2A16973-EE76-4B9C-B05C-26BE1A477778}"/>
               </a:ext>
             </a:extLst>
           </p:cNvPr>
@@ -32335,7 +31065,7 @@
           <p:nvPr/>
         </p:nvPicPr>
         <p:blipFill>
-          <a:blip xmlns:r="http://schemas.openxmlformats.org/officeDocument/2006/relationships" xmlns:a="http://schemas.openxmlformats.org/drawingml/2006/main" r:embed="Re1cd96d8904046a9"/>
+          <a:blip xmlns:r="http://schemas.openxmlformats.org/officeDocument/2006/relationships" xmlns:a="http://schemas.openxmlformats.org/drawingml/2006/main" r:embed="R4c2d6a6028d54de4"/>
           <a:stretch xmlns:a="http://schemas.openxmlformats.org/drawingml/2006/main"/>
         </p:blipFill>
         <p:spPr>
@@ -37112,7 +35842,7 @@
                 <a:latin typeface="Arial"/>
                 <a:ea typeface="Arial"/>
                 <a:cs typeface="Arial"/>
-                <a:hlinkClick xmlns:r="http://schemas.openxmlformats.org/officeDocument/2006/relationships" r:id="Raed0ae2c63e64868"/>
+                <a:hlinkClick xmlns:r="http://schemas.openxmlformats.org/officeDocument/2006/relationships" r:id="R87f70dd3ea75477e"/>
               </a:rPr>
               <a:t>https://github.com/Omswaroopreddyudumula/ajxom-budget-bites</a:t>
             </a:r>
@@ -38578,7 +37308,7 @@
           <p:cNvPr id="6" name="">
             <a:extLst xmlns:a="http://schemas.openxmlformats.org/drawingml/2006/main">
               <a:ext uri="{FF2B5EF4-FFF2-40B4-BE49-F238E27FC236}">
-                <a16:creationId xmlns:a16="http://schemas.microsoft.com/office/drawing/2014/main" id="{6B47BC6D-B99B-4403-9321-E87F8B6CF3B9}"/>
+                <a16:creationId xmlns:a16="http://schemas.microsoft.com/office/drawing/2014/main" id="{9552368F-A83C-441B-8006-691E25B6877C}"/>
               </a:ext>
             </a:extLst>
           </p:cNvPr>
@@ -38588,7 +37318,7 @@
           <p:nvPr/>
         </p:nvPicPr>
         <p:blipFill>
-          <a:blip xmlns:r="http://schemas.openxmlformats.org/officeDocument/2006/relationships" xmlns:a="http://schemas.openxmlformats.org/drawingml/2006/main" r:embed="Rcfae175e078b4d96"/>
+          <a:blip xmlns:r="http://schemas.openxmlformats.org/officeDocument/2006/relationships" xmlns:a="http://schemas.openxmlformats.org/drawingml/2006/main" r:embed="R032339773a6c435b"/>
           <a:stretch xmlns:a="http://schemas.openxmlformats.org/drawingml/2006/main"/>
         </p:blipFill>
         <p:spPr>
@@ -40656,7 +39386,7 @@
           <p:cNvPr id="6" name="">
             <a:extLst xmlns:a="http://schemas.openxmlformats.org/drawingml/2006/main">
               <a:ext uri="{FF2B5EF4-FFF2-40B4-BE49-F238E27FC236}">
-                <a16:creationId xmlns:a16="http://schemas.microsoft.com/office/drawing/2014/main" id="{532522FE-0DBA-4480-968B-4699C6CD2CCC}"/>
+                <a16:creationId xmlns:a16="http://schemas.microsoft.com/office/drawing/2014/main" id="{48DDB923-9999-4553-B647-663163259341}"/>
               </a:ext>
             </a:extLst>
           </p:cNvPr>
@@ -40666,7 +39396,7 @@
           <p:nvPr/>
         </p:nvPicPr>
         <p:blipFill>
-          <a:blip xmlns:r="http://schemas.openxmlformats.org/officeDocument/2006/relationships" xmlns:a="http://schemas.openxmlformats.org/drawingml/2006/main" r:embed="R0f3048a0cedc42ce"/>
+          <a:blip xmlns:r="http://schemas.openxmlformats.org/officeDocument/2006/relationships" xmlns:a="http://schemas.openxmlformats.org/drawingml/2006/main" r:embed="R578a992130504f1e"/>
           <a:stretch xmlns:a="http://schemas.openxmlformats.org/drawingml/2006/main"/>
         </p:blipFill>
         <p:spPr>
@@ -40850,7 +39580,7 @@
           <p:cNvPr id="8" name="">
             <a:extLst xmlns:a="http://schemas.openxmlformats.org/drawingml/2006/main">
               <a:ext uri="{FF2B5EF4-FFF2-40B4-BE49-F238E27FC236}">
-                <a16:creationId xmlns:a16="http://schemas.microsoft.com/office/drawing/2014/main" id="{91174747-62FF-4FB3-9D8E-3948EE697644}"/>
+                <a16:creationId xmlns:a16="http://schemas.microsoft.com/office/drawing/2014/main" id="{BB3394BE-4345-4BD2-A334-54105638E29B}"/>
               </a:ext>
             </a:extLst>
           </p:cNvPr>
@@ -40860,7 +39590,7 @@
           <p:nvPr/>
         </p:nvPicPr>
         <p:blipFill>
-          <a:blip xmlns:r="http://schemas.openxmlformats.org/officeDocument/2006/relationships" xmlns:a="http://schemas.openxmlformats.org/drawingml/2006/main" r:embed="Racdd7c61221544c2"/>
+          <a:blip xmlns:r="http://schemas.openxmlformats.org/officeDocument/2006/relationships" xmlns:a="http://schemas.openxmlformats.org/drawingml/2006/main" r:embed="R5ac6ed7d887747f4"/>
           <a:stretch xmlns:a="http://schemas.openxmlformats.org/drawingml/2006/main"/>
         </p:blipFill>
         <p:spPr>
@@ -41044,7 +39774,7 @@
           <p:cNvPr id="10" name="">
             <a:extLst xmlns:a="http://schemas.openxmlformats.org/drawingml/2006/main">
               <a:ext uri="{FF2B5EF4-FFF2-40B4-BE49-F238E27FC236}">
-                <a16:creationId xmlns:a16="http://schemas.microsoft.com/office/drawing/2014/main" id="{C0DD7F16-45AA-46FF-82C4-9757413CEAE6}"/>
+                <a16:creationId xmlns:a16="http://schemas.microsoft.com/office/drawing/2014/main" id="{9029704F-8574-417C-B6D0-ABC042F40EE3}"/>
               </a:ext>
             </a:extLst>
           </p:cNvPr>
@@ -41054,7 +39784,7 @@
           <p:nvPr/>
         </p:nvPicPr>
         <p:blipFill>
-          <a:blip xmlns:r="http://schemas.openxmlformats.org/officeDocument/2006/relationships" xmlns:a="http://schemas.openxmlformats.org/drawingml/2006/main" r:embed="Ree1d9bf48e3d49f8"/>
+          <a:blip xmlns:r="http://schemas.openxmlformats.org/officeDocument/2006/relationships" xmlns:a="http://schemas.openxmlformats.org/drawingml/2006/main" r:embed="R439e52dba7e04277"/>
           <a:stretch xmlns:a="http://schemas.openxmlformats.org/drawingml/2006/main"/>
         </p:blipFill>
         <p:spPr>
@@ -41238,7 +39968,7 @@
           <p:cNvPr id="12" name="">
             <a:extLst xmlns:a="http://schemas.openxmlformats.org/drawingml/2006/main">
               <a:ext uri="{FF2B5EF4-FFF2-40B4-BE49-F238E27FC236}">
-                <a16:creationId xmlns:a16="http://schemas.microsoft.com/office/drawing/2014/main" id="{92BD3B27-1F19-4578-BD20-C3EAA905DF54}"/>
+                <a16:creationId xmlns:a16="http://schemas.microsoft.com/office/drawing/2014/main" id="{7536E572-EBFB-4A90-B626-6155838515A6}"/>
               </a:ext>
             </a:extLst>
           </p:cNvPr>
@@ -41248,7 +39978,7 @@
           <p:nvPr/>
         </p:nvPicPr>
         <p:blipFill>
-          <a:blip xmlns:r="http://schemas.openxmlformats.org/officeDocument/2006/relationships" xmlns:a="http://schemas.openxmlformats.org/drawingml/2006/main" r:embed="R9791202fd7b84fcc"/>
+          <a:blip xmlns:r="http://schemas.openxmlformats.org/officeDocument/2006/relationships" xmlns:a="http://schemas.openxmlformats.org/drawingml/2006/main" r:embed="R7f78333265424be1"/>
           <a:stretch xmlns:a="http://schemas.openxmlformats.org/drawingml/2006/main"/>
         </p:blipFill>
         <p:spPr>
@@ -41432,7 +40162,7 @@
           <p:cNvPr id="14" name="">
             <a:extLst xmlns:a="http://schemas.openxmlformats.org/drawingml/2006/main">
               <a:ext uri="{FF2B5EF4-FFF2-40B4-BE49-F238E27FC236}">
-                <a16:creationId xmlns:a16="http://schemas.microsoft.com/office/drawing/2014/main" id="{8522B5AA-A6AE-4082-9B2F-924E3B6FD137}"/>
+                <a16:creationId xmlns:a16="http://schemas.microsoft.com/office/drawing/2014/main" id="{0F42C5AB-0CC6-4E72-8232-ED3AB8814ECA}"/>
               </a:ext>
             </a:extLst>
           </p:cNvPr>
@@ -41442,7 +40172,7 @@
           <p:nvPr/>
         </p:nvPicPr>
         <p:blipFill>
-          <a:blip xmlns:r="http://schemas.openxmlformats.org/officeDocument/2006/relationships" xmlns:a="http://schemas.openxmlformats.org/drawingml/2006/main" r:embed="Refa2e3763e664d1b"/>
+          <a:blip xmlns:r="http://schemas.openxmlformats.org/officeDocument/2006/relationships" xmlns:a="http://schemas.openxmlformats.org/drawingml/2006/main" r:embed="R49f29972dac746f2"/>
           <a:stretch xmlns:a="http://schemas.openxmlformats.org/drawingml/2006/main"/>
         </p:blipFill>
         <p:spPr>
@@ -41655,7 +40385,7 @@
           <p:cNvPr id="11" name="">
             <a:extLst xmlns:a="http://schemas.openxmlformats.org/drawingml/2006/main">
               <a:ext uri="{FF2B5EF4-FFF2-40B4-BE49-F238E27FC236}">
-                <a16:creationId xmlns:a16="http://schemas.microsoft.com/office/drawing/2014/main" id="{AF0FC4E6-EC20-4FAC-B425-7F7DB1A04505}"/>
+                <a16:creationId xmlns:a16="http://schemas.microsoft.com/office/drawing/2014/main" id="{462B023C-F730-47CA-AB25-A622D3E7E879}"/>
               </a:ext>
             </a:extLst>
           </p:cNvPr>
@@ -41686,7 +40416,7 @@
           <p:cNvPr id="10" name="">
             <a:extLst xmlns:a="http://schemas.openxmlformats.org/drawingml/2006/main">
               <a:ext uri="{FF2B5EF4-FFF2-40B4-BE49-F238E27FC236}">
-                <a16:creationId xmlns:a16="http://schemas.microsoft.com/office/drawing/2014/main" id="{41F3A165-0564-4FA4-8D9B-FE7C8CF0C3BC}"/>
+                <a16:creationId xmlns:a16="http://schemas.microsoft.com/office/drawing/2014/main" id="{06B218D8-17E0-44CF-85A3-AA91C2A7680E}"/>
               </a:ext>
             </a:extLst>
           </p:cNvPr>
@@ -47515,7 +46245,7 @@
           <p:cNvPr id="7" name="">
             <a:extLst xmlns:a="http://schemas.openxmlformats.org/drawingml/2006/main">
               <a:ext uri="{FF2B5EF4-FFF2-40B4-BE49-F238E27FC236}">
-                <a16:creationId xmlns:a16="http://schemas.microsoft.com/office/drawing/2014/main" id="{B163E8A3-3620-4753-AD1E-FBAC4BEB72E2}"/>
+                <a16:creationId xmlns:a16="http://schemas.microsoft.com/office/drawing/2014/main" id="{C3E11773-B69E-4FE1-95EF-AECE0923BC0B}"/>
               </a:ext>
             </a:extLst>
           </p:cNvPr>
@@ -47525,7 +46255,7 @@
           <p:nvPr/>
         </p:nvPicPr>
         <p:blipFill>
-          <a:blip xmlns:r="http://schemas.openxmlformats.org/officeDocument/2006/relationships" xmlns:a="http://schemas.openxmlformats.org/drawingml/2006/main" r:embed="R73ca288fa6de4eda"/>
+          <a:blip xmlns:r="http://schemas.openxmlformats.org/officeDocument/2006/relationships" xmlns:a="http://schemas.openxmlformats.org/drawingml/2006/main" r:embed="R955fca1dc3004c6b"/>
           <a:srcRect xmlns:a="http://schemas.openxmlformats.org/drawingml/2006/main" l="13000" t="37500" r="13000" b="33500"/>
           <a:stretch xmlns:a="http://schemas.openxmlformats.org/drawingml/2006/main"/>
         </p:blipFill>
@@ -47739,7 +46469,7 @@
           <p:cNvPr id="7" name="">
             <a:extLst xmlns:a="http://schemas.openxmlformats.org/drawingml/2006/main">
               <a:ext uri="{FF2B5EF4-FFF2-40B4-BE49-F238E27FC236}">
-                <a16:creationId xmlns:a16="http://schemas.microsoft.com/office/drawing/2014/main" id="{7C3DA347-1CA0-4D23-87A2-EC2DF3BC85A5}"/>
+                <a16:creationId xmlns:a16="http://schemas.microsoft.com/office/drawing/2014/main" id="{C6524997-F609-4F8F-9C9B-D604DB7F6570}"/>
               </a:ext>
             </a:extLst>
           </p:cNvPr>

</xml_diff>